<commit_message>
Deck polish: no 'synthetic', node/bolt title art, look-away backup slide
- 'synthetic' replaced with 'simulated' everywhere, including the fusion
  map header (regenerated) — zero hits verified by text extraction
- title slide: ring dots replaced with stylized line-art Sage node
  glyphs (pole, enclosure, camera, antennas, microphone arcs) and a
  glowing lightning bolt at the ring center
- new backup slide (Q&A): W097 same-day pair — the node's production
  detector flagged the Halemaumau plume while the steerable PTZ camera
  pointed at canopy; provenance of the boxes stated on-slide
- slide 7 names the vision models (Gemma 4 captions, YOLO11 boxes,
  SmokeyNet planned); bottom margins opened up on slides 4, 7, 10

Co-Authored-By: Claude Opus 5 <noreply@anthropic.com>
Claude-Session: https://claude.ai/code/session_01UD3fcKavuimuC1QvaVbRS3
</commit_message>
<xml_diff>
--- a/flashpoint/deck/FlashPoint-Camp-Results.pptx
+++ b/flashpoint/deck/FlashPoint-Camp-Results.pptx
@@ -15,9 +15,10 @@
     <p:sldId id="263" r:id="rId9"/>
     <p:sldId id="264" r:id="rId10"/>
     <p:sldId id="265" r:id="rId11"/>
+    <p:sldId id="266" r:id="rId12"/>
   </p:sldIdLst>
   <p:notesMasterIdLst>
-    <p:notesMasterId r:id="rId12"/>
+    <p:notesMasterId r:id="rId13"/>
   </p:notesMasterIdLst>
   <p:sldSz cx="12192000" cy="6858000"/>
   <p:notesSz cx="6858000" cy="12192000"/>
@@ -641,6 +642,94 @@
 </p:notes>
 </file>
 
+<file path=ppt/notesSlides/notesSlide11.xml><?xml version="1.0" encoding="utf-8"?>
+<p:notes xmlns:a="http://schemas.openxmlformats.org/drawingml/2006/main" xmlns:r="http://schemas.openxmlformats.org/officeDocument/2006/relationships" xmlns:p="http://schemas.openxmlformats.org/presentationml/2006/main">
+  <p:cSld>
+    <p:spTree>
+      <p:nvGrpSpPr>
+        <p:cNvPr id="1" name=""/>
+        <p:cNvGrpSpPr/>
+        <p:nvPr/>
+      </p:nvGrpSpPr>
+      <p:grpSpPr>
+        <a:xfrm>
+          <a:off x="0" y="0"/>
+          <a:ext cx="0" cy="0"/>
+          <a:chOff x="0" y="0"/>
+          <a:chExt cx="0" cy="0"/>
+        </a:xfrm>
+      </p:grpSpPr>
+      <p:sp>
+        <p:nvSpPr>
+          <p:cNvPr id="2" name="Slide Image Placeholder 1"/>
+          <p:cNvSpPr>
+            <a:spLocks noGrp="1" noRot="1" noChangeAspect="1"/>
+          </p:cNvSpPr>
+          <p:nvPr>
+            <p:ph type="sldImg"/>
+          </p:nvPr>
+        </p:nvSpPr>
+        <p:spPr/>
+      </p:sp>
+      <p:sp>
+        <p:nvSpPr>
+          <p:cNvPr id="3" name="Notes Placeholder 2"/>
+          <p:cNvSpPr>
+            <a:spLocks noGrp="1"/>
+          </p:cNvSpPr>
+          <p:nvPr>
+            <p:ph type="body" idx="1"/>
+          </p:nvPr>
+        </p:nvSpPr>
+        <p:spPr/>
+        <p:txBody>
+          <a:bodyPr/>
+          <a:lstStyle/>
+          <a:p>
+            <a:r>
+              <a:rPr lang="en-US" dirty="0"/>
+              <a:t>[Backup — show only if siting or tasking questions come up in Q&amp;A. Second, independent example: this node's fixed camera flagged the plume with its production detector while the steerable camera studied canopy the same day. Tasking, not camera capability, is the gap the storm-mode controller closes.]</a:t>
+            </a:r>
+            <a:endParaRPr lang="en-US" dirty="0"/>
+          </a:p>
+        </p:txBody>
+      </p:sp>
+      <p:sp>
+        <p:nvSpPr>
+          <p:cNvPr id="4" name="Slide Number Placeholder 3"/>
+          <p:cNvSpPr>
+            <a:spLocks noGrp="1"/>
+          </p:cNvSpPr>
+          <p:nvPr>
+            <p:ph type="sldNum" sz="quarter" idx="10"/>
+          </p:nvPr>
+        </p:nvSpPr>
+        <p:spPr/>
+        <p:txBody>
+          <a:bodyPr/>
+          <a:lstStyle/>
+          <a:p>
+            <a:fld id="{F7021451-1387-4CA6-816F-3879F97B5CBC}" type="slidenum">
+              <a:rPr lang="en-US"/>
+              <a:t>11</a:t>
+            </a:fld>
+            <a:endParaRPr lang="en-US"/>
+          </a:p>
+        </p:txBody>
+      </p:sp>
+    </p:spTree>
+    <p:extLst>
+      <p:ext uri="{BB962C8B-B14F-4D97-AF65-F5344CB8AC3E}">
+        <p14:creationId xmlns:p14="http://schemas.microsoft.com/office/powerpoint/2010/main" val="1024086991"/>
+      </p:ext>
+    </p:extLst>
+  </p:cSld>
+  <p:clrMapOvr>
+    <a:masterClrMapping/>
+  </p:clrMapOvr>
+</p:notes>
+</file>
+
 <file path=ppt/notesSlides/notesSlide2.xml><?xml version="1.0" encoding="utf-8"?>
 <p:notes xmlns:a="http://schemas.openxmlformats.org/drawingml/2006/main" xmlns:r="http://schemas.openxmlformats.org/officeDocument/2006/relationships" xmlns:p="http://schemas.openxmlformats.org/presentationml/2006/main">
   <p:cSld>
@@ -951,7 +1040,7 @@
           <a:p>
             <a:r>
               <a:rPr lang="en-US" dirty="0"/>
-              <a:t>[40 s] How localization works with zero new hardware: light is effectively instant, so the flash gives every node its own clock. Time-to-thunder gives range; ranges from several nodes give a position with an honest uncertainty ellipse. The integration test localizes a strike to 96 meters with no satellite and no synchronization. The map shows the full engine fusing a synthetic replay storm over real Argonne geometry — five for five, all clean fixes.</a:t>
+              <a:t>[40 s] How localization works with zero new hardware: light is effectively instant, so the flash gives every node its own clock. Time-to-thunder gives range; ranges from several nodes give a position with an honest uncertainty ellipse. The integration test localizes a strike to 96 meters with no satellite and no synchronization. The map shows the full engine fusing a simulated storm over real Argonne geometry — five for five, all clean fixes.</a:t>
             </a:r>
             <a:endParaRPr lang="en-US" dirty="0"/>
           </a:p>
@@ -1303,7 +1392,7 @@
           <a:p>
             <a:r>
               <a:rPr lang="en-US" dirty="0"/>
-              <a:t>[40 s] The ledger. Built this week: the full chain — detectors, an edge plugin that already ran on a Sage node and published candidates to the cloud, a first neural probe at 0.95 AUC, the controller, fusion, and the human-review loop, all tested. Found for Sage: real fleet gaps, including zero soil moisture sensors anywhere, and the camera-siting constraint. And the limitations, stated plainly: one real storm behind the audio numbers, synthetic validation for fusion, ground truth coarser than the precision claims — hence the Vaisala research request, submitted July 24 and still awaiting approval — several fire-country node archives that likely hold more storm and fire cases stayed closed to read access, and live PTZ control still untested: the sandbox camera was reachable over an SSH tunnel, but control permissions were not granted, so re-aim runs in simulation only.</a:t>
+              <a:t>[40 s] The ledger. Built this week: the full chain — detectors, an edge plugin that already ran on a Sage node and published candidates to the cloud, a first neural probe at 0.95 AUC, the controller, fusion, and the human-review loop, all tested. Found for Sage: real fleet gaps, including zero soil moisture sensors anywhere, and the camera-siting constraint. And the limitations, stated plainly: one real storm behind the audio numbers, simulation-only validation for fusion, ground truth coarser than the precision claims — hence the Vaisala research request, submitted July 24 and still awaiting approval — several fire-country node archives that likely hold more storm and fire cases stayed closed to read access, and live PTZ control still untested: the sandbox camera was reachable over an SSH tunnel, but control permissions were not granted, so re-aim runs in simulation only.</a:t>
             </a:r>
             <a:endParaRPr lang="en-US" dirty="0"/>
           </a:p>
@@ -1790,347 +1879,9 @@
           </a:ln>
         </p:spPr>
       </p:sp>
-      <p:sp>
-        <p:nvSpPr>
-          <p:cNvPr id="6" name="Shape 4"/>
-          <p:cNvSpPr/>
-          <p:nvPr/>
-        </p:nvSpPr>
-        <p:spPr>
-          <a:xfrm>
-            <a:off x="9107424" y="3118104"/>
-            <a:ext cx="164592" cy="164592"/>
-          </a:xfrm>
-          <a:prstGeom prst="ellipse">
-            <a:avLst/>
-          </a:prstGeom>
-          <a:solidFill>
-            <a:srgbClr val="FAB219"/>
-          </a:solidFill>
-          <a:ln/>
-        </p:spPr>
-      </p:sp>
-      <p:sp>
-        <p:nvSpPr>
-          <p:cNvPr id="7" name="Shape 5"/>
-          <p:cNvSpPr/>
-          <p:nvPr/>
-        </p:nvSpPr>
-        <p:spPr>
-          <a:xfrm>
-            <a:off x="7452360" y="2395728"/>
-            <a:ext cx="118872" cy="118872"/>
-          </a:xfrm>
-          <a:prstGeom prst="ellipse">
-            <a:avLst/>
-          </a:prstGeom>
-          <a:solidFill>
-            <a:srgbClr val="2A78D6"/>
-          </a:solidFill>
-          <a:ln/>
-        </p:spPr>
-      </p:sp>
-      <p:sp>
-        <p:nvSpPr>
-          <p:cNvPr id="8" name="Shape 6"/>
-          <p:cNvSpPr/>
-          <p:nvPr/>
-        </p:nvSpPr>
-        <p:spPr>
-          <a:xfrm>
-            <a:off x="10716768" y="2615184"/>
-            <a:ext cx="118872" cy="118872"/>
-          </a:xfrm>
-          <a:prstGeom prst="ellipse">
-            <a:avLst/>
-          </a:prstGeom>
-          <a:solidFill>
-            <a:srgbClr val="2A78D6"/>
-          </a:solidFill>
-          <a:ln/>
-        </p:spPr>
-      </p:sp>
-      <p:sp>
-        <p:nvSpPr>
-          <p:cNvPr id="9" name="Shape 7"/>
-          <p:cNvSpPr/>
-          <p:nvPr/>
-        </p:nvSpPr>
-        <p:spPr>
-          <a:xfrm>
-            <a:off x="8229600" y="4480560"/>
-            <a:ext cx="118872" cy="118872"/>
-          </a:xfrm>
-          <a:prstGeom prst="ellipse">
-            <a:avLst/>
-          </a:prstGeom>
-          <a:solidFill>
-            <a:srgbClr val="1BAF7A"/>
-          </a:solidFill>
-          <a:ln/>
-        </p:spPr>
-      </p:sp>
-      <p:sp>
-        <p:nvSpPr>
-          <p:cNvPr id="10" name="Shape 8"/>
-          <p:cNvSpPr/>
-          <p:nvPr/>
-        </p:nvSpPr>
-        <p:spPr>
-          <a:xfrm>
-            <a:off x="11292840" y="4041648"/>
-            <a:ext cx="118872" cy="118872"/>
-          </a:xfrm>
-          <a:prstGeom prst="ellipse">
-            <a:avLst/>
-          </a:prstGeom>
-          <a:solidFill>
-            <a:srgbClr val="2A78D6"/>
-          </a:solidFill>
-          <a:ln/>
-        </p:spPr>
-      </p:sp>
-      <p:sp>
-        <p:nvSpPr>
-          <p:cNvPr id="11" name="Text 9"/>
-          <p:cNvSpPr/>
-          <p:nvPr/>
-        </p:nvSpPr>
-        <p:spPr>
-          <a:xfrm>
-            <a:off x="9464040" y="3310128"/>
-            <a:ext cx="2377440" cy="274320"/>
-          </a:xfrm>
-          <a:prstGeom prst="rect">
-            <a:avLst/>
-          </a:prstGeom>
-          <a:noFill/>
-          <a:ln/>
-        </p:spPr>
-        <p:txBody>
-          <a:bodyPr wrap="square" lIns="0" tIns="0" rIns="0" bIns="0" rtlCol="0" anchor="ctr"/>
-          <a:lstStyle/>
-          <a:p>
-            <a:pPr indent="0" marL="0">
-              <a:buNone/>
-            </a:pPr>
-            <a:r>
-              <a:rPr lang="en-US" sz="1000" i="1" dirty="0">
-                <a:solidFill>
-                  <a:srgbClr val="8A97B0"/>
-                </a:solidFill>
-                <a:latin typeface="Arial" pitchFamily="34" charset="0"/>
-                <a:ea typeface="Arial" pitchFamily="34" charset="-122"/>
-                <a:cs typeface="Arial" pitchFamily="34" charset="-120"/>
-              </a:rPr>
-              <a:t>range = Δt × 343 m/s</a:t>
-            </a:r>
-            <a:endParaRPr lang="en-US" sz="1000" dirty="0"/>
-          </a:p>
-        </p:txBody>
-      </p:sp>
-      <p:sp>
-        <p:nvSpPr>
-          <p:cNvPr id="12" name="Text 10"/>
-          <p:cNvSpPr/>
-          <p:nvPr/>
-        </p:nvSpPr>
-        <p:spPr>
-          <a:xfrm>
-            <a:off x="502920" y="1554480"/>
-            <a:ext cx="6949440" cy="914400"/>
-          </a:xfrm>
-          <a:prstGeom prst="rect">
-            <a:avLst/>
-          </a:prstGeom>
-          <a:noFill/>
-          <a:ln/>
-        </p:spPr>
-        <p:txBody>
-          <a:bodyPr wrap="square" lIns="0" tIns="0" rIns="0" bIns="0" rtlCol="0" anchor="ctr"/>
-          <a:lstStyle/>
-          <a:p>
-            <a:pPr indent="0" marL="0">
-              <a:buNone/>
-            </a:pPr>
-            <a:r>
-              <a:rPr lang="en-US" sz="5000" b="1" dirty="0">
-                <a:solidFill>
-                  <a:srgbClr val="F5F7FA"/>
-                </a:solidFill>
-                <a:latin typeface="Arial" pitchFamily="34" charset="0"/>
-                <a:ea typeface="Arial" pitchFamily="34" charset="-122"/>
-                <a:cs typeface="Arial" pitchFamily="34" charset="-120"/>
-              </a:rPr>
-              <a:t>Sage FlashPoint</a:t>
-            </a:r>
-            <a:endParaRPr lang="en-US" sz="5000" dirty="0"/>
-          </a:p>
-        </p:txBody>
-      </p:sp>
-      <p:sp>
-        <p:nvSpPr>
-          <p:cNvPr id="13" name="Text 11"/>
-          <p:cNvSpPr/>
-          <p:nvPr/>
-        </p:nvSpPr>
-        <p:spPr>
-          <a:xfrm>
-            <a:off x="502920" y="2542032"/>
-            <a:ext cx="6400800" cy="868680"/>
-          </a:xfrm>
-          <a:prstGeom prst="rect">
-            <a:avLst/>
-          </a:prstGeom>
-          <a:noFill/>
-          <a:ln/>
-        </p:spPr>
-        <p:txBody>
-          <a:bodyPr wrap="square" lIns="0" tIns="0" rIns="0" bIns="0" rtlCol="0" anchor="ctr"/>
-          <a:lstStyle/>
-          <a:p>
-            <a:pPr indent="0" marL="0">
-              <a:lnSpc>
-                <a:spcPct val="115000"/>
-              </a:lnSpc>
-              <a:buNone/>
-            </a:pPr>
-            <a:r>
-              <a:rPr lang="en-US" sz="2000" dirty="0">
-                <a:solidFill>
-                  <a:srgbClr val="F5F7FA"/>
-                </a:solidFill>
-                <a:latin typeface="Arial" pitchFamily="34" charset="0"/>
-                <a:ea typeface="Arial" pitchFamily="34" charset="-122"/>
-                <a:cs typeface="Arial" pitchFamily="34" charset="-120"/>
-              </a:rPr>
-              <a:t>Multi-node lightning localization</a:t>
-            </a:r>
-            <a:endParaRPr lang="en-US" sz="2000" dirty="0"/>
-          </a:p>
-          <a:p>
-            <a:pPr indent="0" marL="0">
-              <a:lnSpc>
-                <a:spcPct val="115000"/>
-              </a:lnSpc>
-              <a:buNone/>
-            </a:pPr>
-            <a:r>
-              <a:rPr lang="en-US" sz="2000" dirty="0">
-                <a:solidFill>
-                  <a:srgbClr val="F5F7FA"/>
-                </a:solidFill>
-                <a:latin typeface="Arial" pitchFamily="34" charset="0"/>
-                <a:ea typeface="Arial" pitchFamily="34" charset="-122"/>
-                <a:cs typeface="Arial" pitchFamily="34" charset="-120"/>
-              </a:rPr>
-              <a:t>&amp; wildfire ignition watch on the Sage fleet</a:t>
-            </a:r>
-            <a:endParaRPr lang="en-US" sz="2000" dirty="0"/>
-          </a:p>
-        </p:txBody>
-      </p:sp>
-      <p:sp>
-        <p:nvSpPr>
-          <p:cNvPr id="14" name="Text 12"/>
-          <p:cNvSpPr/>
-          <p:nvPr/>
-        </p:nvSpPr>
-        <p:spPr>
-          <a:xfrm>
-            <a:off x="502920" y="3611880"/>
-            <a:ext cx="6583680" cy="685800"/>
-          </a:xfrm>
-          <a:prstGeom prst="rect">
-            <a:avLst/>
-          </a:prstGeom>
-          <a:noFill/>
-          <a:ln/>
-        </p:spPr>
-        <p:txBody>
-          <a:bodyPr wrap="square" lIns="0" tIns="0" rIns="0" bIns="0" rtlCol="0" anchor="ctr"/>
-          <a:lstStyle/>
-          <a:p>
-            <a:pPr indent="0" marL="0">
-              <a:lnSpc>
-                <a:spcPct val="120000"/>
-              </a:lnSpc>
-              <a:buNone/>
-            </a:pPr>
-            <a:r>
-              <a:rPr lang="en-US" sz="1500" b="1" i="1" dirty="0">
-                <a:solidFill>
-                  <a:srgbClr val="2A78D6"/>
-                </a:solidFill>
-                <a:latin typeface="Arial" pitchFamily="34" charset="0"/>
-                <a:ea typeface="Arial" pitchFamily="34" charset="-122"/>
-                <a:cs typeface="Arial" pitchFamily="34" charset="-120"/>
-              </a:rPr>
-              <a:t>Cameras catch the flash. </a:t>
-            </a:r>
-            <a:pPr indent="0" marL="0">
-              <a:lnSpc>
-                <a:spcPct val="120000"/>
-              </a:lnSpc>
-              <a:buNone/>
-            </a:pPr>
-            <a:r>
-              <a:rPr lang="en-US" sz="1500" b="1" i="1" dirty="0">
-                <a:solidFill>
-                  <a:srgbClr val="EB6834"/>
-                </a:solidFill>
-                <a:latin typeface="Arial" pitchFamily="34" charset="0"/>
-                <a:ea typeface="Arial" pitchFamily="34" charset="-122"/>
-                <a:cs typeface="Arial" pitchFamily="34" charset="-120"/>
-              </a:rPr>
-              <a:t>Microphones catch the thunder. </a:t>
-            </a:r>
-            <a:pPr indent="0" marL="0">
-              <a:lnSpc>
-                <a:spcPct val="120000"/>
-              </a:lnSpc>
-              <a:buNone/>
-            </a:pPr>
-            <a:r>
-              <a:rPr lang="en-US" sz="1500" b="1" i="1" dirty="0">
-                <a:solidFill>
-                  <a:srgbClr val="1BAF7A"/>
-                </a:solidFill>
-                <a:latin typeface="Arial" pitchFamily="34" charset="0"/>
-                <a:ea typeface="Arial" pitchFamily="34" charset="-122"/>
-                <a:cs typeface="Arial" pitchFamily="34" charset="-120"/>
-              </a:rPr>
-              <a:t>Weather decides when to listen.</a:t>
-            </a:r>
-            <a:endParaRPr lang="en-US" sz="1500" dirty="0"/>
-          </a:p>
-        </p:txBody>
-      </p:sp>
-      <p:sp>
-        <p:nvSpPr>
-          <p:cNvPr id="15" name="Shape 13"/>
-          <p:cNvSpPr/>
-          <p:nvPr/>
-        </p:nvSpPr>
-        <p:spPr>
-          <a:xfrm>
-            <a:off x="502920" y="4736592"/>
-            <a:ext cx="2651760" cy="777240"/>
-          </a:xfrm>
-          <a:prstGeom prst="roundRect">
-            <a:avLst>
-              <a:gd name="adj" fmla="val 9412"/>
-            </a:avLst>
-          </a:prstGeom>
-          <a:solidFill>
-            <a:srgbClr val="FFFFFF"/>
-          </a:solidFill>
-          <a:ln/>
-        </p:spPr>
-      </p:sp>
       <p:pic>
         <p:nvPicPr>
-          <p:cNvPr id="16" name="Image 0" descr="/home/user/sage-summer-camp-2026/flashpoint/deck/assets/sage-logo.png">    </p:cNvPr>
+          <p:cNvPr id="6" name="Image 0" descr="Lightning strike">    </p:cNvPr>
           <p:cNvPicPr>
             <a:picLocks noChangeAspect="1"/>
           </p:cNvPicPr>
@@ -2144,39 +1895,17 @@
         </p:blipFill>
         <p:spPr>
           <a:xfrm>
-            <a:off x="640080" y="4855464"/>
-            <a:ext cx="2377440" cy="530352"/>
+            <a:off x="8951976" y="2852928"/>
+            <a:ext cx="475488" cy="694944"/>
           </a:xfrm>
           <a:prstGeom prst="rect">
             <a:avLst/>
           </a:prstGeom>
         </p:spPr>
       </p:pic>
-      <p:sp>
-        <p:nvSpPr>
-          <p:cNvPr id="17" name="Shape 14"/>
-          <p:cNvSpPr/>
-          <p:nvPr/>
-        </p:nvSpPr>
-        <p:spPr>
-          <a:xfrm>
-            <a:off x="3337560" y="4736592"/>
-            <a:ext cx="1801368" cy="777240"/>
-          </a:xfrm>
-          <a:prstGeom prst="roundRect">
-            <a:avLst>
-              <a:gd name="adj" fmla="val 9412"/>
-            </a:avLst>
-          </a:prstGeom>
-          <a:solidFill>
-            <a:srgbClr val="FFFFFF"/>
-          </a:solidFill>
-          <a:ln/>
-        </p:spPr>
-      </p:sp>
       <p:pic>
         <p:nvPicPr>
-          <p:cNvPr id="18" name="Image 1" descr="/home/user/sage-summer-camp-2026/flashpoint/deck/assets/uh-manoa-logo.png">    </p:cNvPr>
+          <p:cNvPr id="7" name="Image 1" descr="Sage sensor node">    </p:cNvPr>
           <p:cNvPicPr>
             <a:picLocks noChangeAspect="1"/>
           </p:cNvPicPr>
@@ -2190,6 +1919,386 @@
         </p:blipFill>
         <p:spPr>
           <a:xfrm>
+            <a:off x="7269480" y="2093976"/>
+            <a:ext cx="365760" cy="603504"/>
+          </a:xfrm>
+          <a:prstGeom prst="rect">
+            <a:avLst/>
+          </a:prstGeom>
+        </p:spPr>
+      </p:pic>
+      <p:pic>
+        <p:nvPicPr>
+          <p:cNvPr id="8" name="Image 2" descr="Sage sensor node">    </p:cNvPr>
+          <p:cNvPicPr>
+            <a:picLocks noChangeAspect="1"/>
+          </p:cNvPicPr>
+          <p:nvPr/>
+        </p:nvPicPr>
+        <p:blipFill>
+          <a:blip r:embed="rId3"/>
+          <a:stretch>
+            <a:fillRect/>
+          </a:stretch>
+        </p:blipFill>
+        <p:spPr>
+          <a:xfrm>
+            <a:off x="10533888" y="2313432"/>
+            <a:ext cx="365760" cy="603504"/>
+          </a:xfrm>
+          <a:prstGeom prst="rect">
+            <a:avLst/>
+          </a:prstGeom>
+        </p:spPr>
+      </p:pic>
+      <p:pic>
+        <p:nvPicPr>
+          <p:cNvPr id="9" name="Image 3" descr="Sage sensor node">    </p:cNvPr>
+          <p:cNvPicPr>
+            <a:picLocks noChangeAspect="1"/>
+          </p:cNvPicPr>
+          <p:nvPr/>
+        </p:nvPicPr>
+        <p:blipFill>
+          <a:blip r:embed="rId4"/>
+          <a:stretch>
+            <a:fillRect/>
+          </a:stretch>
+        </p:blipFill>
+        <p:spPr>
+          <a:xfrm>
+            <a:off x="8046720" y="4178808"/>
+            <a:ext cx="365760" cy="603504"/>
+          </a:xfrm>
+          <a:prstGeom prst="rect">
+            <a:avLst/>
+          </a:prstGeom>
+        </p:spPr>
+      </p:pic>
+      <p:pic>
+        <p:nvPicPr>
+          <p:cNvPr id="10" name="Image 4" descr="Sage sensor node">    </p:cNvPr>
+          <p:cNvPicPr>
+            <a:picLocks noChangeAspect="1"/>
+          </p:cNvPicPr>
+          <p:nvPr/>
+        </p:nvPicPr>
+        <p:blipFill>
+          <a:blip r:embed="rId5"/>
+          <a:stretch>
+            <a:fillRect/>
+          </a:stretch>
+        </p:blipFill>
+        <p:spPr>
+          <a:xfrm>
+            <a:off x="11109960" y="3739896"/>
+            <a:ext cx="365760" cy="603504"/>
+          </a:xfrm>
+          <a:prstGeom prst="rect">
+            <a:avLst/>
+          </a:prstGeom>
+        </p:spPr>
+      </p:pic>
+      <p:sp>
+        <p:nvSpPr>
+          <p:cNvPr id="11" name="Text 4"/>
+          <p:cNvSpPr/>
+          <p:nvPr/>
+        </p:nvSpPr>
+        <p:spPr>
+          <a:xfrm>
+            <a:off x="9464040" y="3310128"/>
+            <a:ext cx="2377440" cy="274320"/>
+          </a:xfrm>
+          <a:prstGeom prst="rect">
+            <a:avLst/>
+          </a:prstGeom>
+          <a:noFill/>
+          <a:ln/>
+        </p:spPr>
+        <p:txBody>
+          <a:bodyPr wrap="square" lIns="0" tIns="0" rIns="0" bIns="0" rtlCol="0" anchor="ctr"/>
+          <a:lstStyle/>
+          <a:p>
+            <a:pPr indent="0" marL="0">
+              <a:buNone/>
+            </a:pPr>
+            <a:r>
+              <a:rPr lang="en-US" sz="1000" i="1" dirty="0">
+                <a:solidFill>
+                  <a:srgbClr val="8A97B0"/>
+                </a:solidFill>
+                <a:latin typeface="Arial" pitchFamily="34" charset="0"/>
+                <a:ea typeface="Arial" pitchFamily="34" charset="-122"/>
+                <a:cs typeface="Arial" pitchFamily="34" charset="-120"/>
+              </a:rPr>
+              <a:t>range = Δt × 343 m/s</a:t>
+            </a:r>
+            <a:endParaRPr lang="en-US" sz="1000" dirty="0"/>
+          </a:p>
+        </p:txBody>
+      </p:sp>
+      <p:sp>
+        <p:nvSpPr>
+          <p:cNvPr id="12" name="Text 5"/>
+          <p:cNvSpPr/>
+          <p:nvPr/>
+        </p:nvSpPr>
+        <p:spPr>
+          <a:xfrm>
+            <a:off x="502920" y="1554480"/>
+            <a:ext cx="6949440" cy="914400"/>
+          </a:xfrm>
+          <a:prstGeom prst="rect">
+            <a:avLst/>
+          </a:prstGeom>
+          <a:noFill/>
+          <a:ln/>
+        </p:spPr>
+        <p:txBody>
+          <a:bodyPr wrap="square" lIns="0" tIns="0" rIns="0" bIns="0" rtlCol="0" anchor="ctr"/>
+          <a:lstStyle/>
+          <a:p>
+            <a:pPr indent="0" marL="0">
+              <a:buNone/>
+            </a:pPr>
+            <a:r>
+              <a:rPr lang="en-US" sz="5000" b="1" dirty="0">
+                <a:solidFill>
+                  <a:srgbClr val="F5F7FA"/>
+                </a:solidFill>
+                <a:latin typeface="Arial" pitchFamily="34" charset="0"/>
+                <a:ea typeface="Arial" pitchFamily="34" charset="-122"/>
+                <a:cs typeface="Arial" pitchFamily="34" charset="-120"/>
+              </a:rPr>
+              <a:t>Sage FlashPoint</a:t>
+            </a:r>
+            <a:endParaRPr lang="en-US" sz="5000" dirty="0"/>
+          </a:p>
+        </p:txBody>
+      </p:sp>
+      <p:sp>
+        <p:nvSpPr>
+          <p:cNvPr id="13" name="Text 6"/>
+          <p:cNvSpPr/>
+          <p:nvPr/>
+        </p:nvSpPr>
+        <p:spPr>
+          <a:xfrm>
+            <a:off x="502920" y="2542032"/>
+            <a:ext cx="6400800" cy="868680"/>
+          </a:xfrm>
+          <a:prstGeom prst="rect">
+            <a:avLst/>
+          </a:prstGeom>
+          <a:noFill/>
+          <a:ln/>
+        </p:spPr>
+        <p:txBody>
+          <a:bodyPr wrap="square" lIns="0" tIns="0" rIns="0" bIns="0" rtlCol="0" anchor="ctr"/>
+          <a:lstStyle/>
+          <a:p>
+            <a:pPr indent="0" marL="0">
+              <a:lnSpc>
+                <a:spcPct val="115000"/>
+              </a:lnSpc>
+              <a:buNone/>
+            </a:pPr>
+            <a:r>
+              <a:rPr lang="en-US" sz="2000" dirty="0">
+                <a:solidFill>
+                  <a:srgbClr val="F5F7FA"/>
+                </a:solidFill>
+                <a:latin typeface="Arial" pitchFamily="34" charset="0"/>
+                <a:ea typeface="Arial" pitchFamily="34" charset="-122"/>
+                <a:cs typeface="Arial" pitchFamily="34" charset="-120"/>
+              </a:rPr>
+              <a:t>Multi-node lightning localization</a:t>
+            </a:r>
+            <a:endParaRPr lang="en-US" sz="2000" dirty="0"/>
+          </a:p>
+          <a:p>
+            <a:pPr indent="0" marL="0">
+              <a:lnSpc>
+                <a:spcPct val="115000"/>
+              </a:lnSpc>
+              <a:buNone/>
+            </a:pPr>
+            <a:r>
+              <a:rPr lang="en-US" sz="2000" dirty="0">
+                <a:solidFill>
+                  <a:srgbClr val="F5F7FA"/>
+                </a:solidFill>
+                <a:latin typeface="Arial" pitchFamily="34" charset="0"/>
+                <a:ea typeface="Arial" pitchFamily="34" charset="-122"/>
+                <a:cs typeface="Arial" pitchFamily="34" charset="-120"/>
+              </a:rPr>
+              <a:t>&amp; wildfire ignition watch on the Sage fleet</a:t>
+            </a:r>
+            <a:endParaRPr lang="en-US" sz="2000" dirty="0"/>
+          </a:p>
+        </p:txBody>
+      </p:sp>
+      <p:sp>
+        <p:nvSpPr>
+          <p:cNvPr id="14" name="Text 7"/>
+          <p:cNvSpPr/>
+          <p:nvPr/>
+        </p:nvSpPr>
+        <p:spPr>
+          <a:xfrm>
+            <a:off x="502920" y="3611880"/>
+            <a:ext cx="6583680" cy="685800"/>
+          </a:xfrm>
+          <a:prstGeom prst="rect">
+            <a:avLst/>
+          </a:prstGeom>
+          <a:noFill/>
+          <a:ln/>
+        </p:spPr>
+        <p:txBody>
+          <a:bodyPr wrap="square" lIns="0" tIns="0" rIns="0" bIns="0" rtlCol="0" anchor="ctr"/>
+          <a:lstStyle/>
+          <a:p>
+            <a:pPr indent="0" marL="0">
+              <a:lnSpc>
+                <a:spcPct val="120000"/>
+              </a:lnSpc>
+              <a:buNone/>
+            </a:pPr>
+            <a:r>
+              <a:rPr lang="en-US" sz="1500" b="1" i="1" dirty="0">
+                <a:solidFill>
+                  <a:srgbClr val="2A78D6"/>
+                </a:solidFill>
+                <a:latin typeface="Arial" pitchFamily="34" charset="0"/>
+                <a:ea typeface="Arial" pitchFamily="34" charset="-122"/>
+                <a:cs typeface="Arial" pitchFamily="34" charset="-120"/>
+              </a:rPr>
+              <a:t>Cameras catch the flash. </a:t>
+            </a:r>
+            <a:pPr indent="0" marL="0">
+              <a:lnSpc>
+                <a:spcPct val="120000"/>
+              </a:lnSpc>
+              <a:buNone/>
+            </a:pPr>
+            <a:r>
+              <a:rPr lang="en-US" sz="1500" b="1" i="1" dirty="0">
+                <a:solidFill>
+                  <a:srgbClr val="EB6834"/>
+                </a:solidFill>
+                <a:latin typeface="Arial" pitchFamily="34" charset="0"/>
+                <a:ea typeface="Arial" pitchFamily="34" charset="-122"/>
+                <a:cs typeface="Arial" pitchFamily="34" charset="-120"/>
+              </a:rPr>
+              <a:t>Microphones catch the thunder. </a:t>
+            </a:r>
+            <a:pPr indent="0" marL="0">
+              <a:lnSpc>
+                <a:spcPct val="120000"/>
+              </a:lnSpc>
+              <a:buNone/>
+            </a:pPr>
+            <a:r>
+              <a:rPr lang="en-US" sz="1500" b="1" i="1" dirty="0">
+                <a:solidFill>
+                  <a:srgbClr val="1BAF7A"/>
+                </a:solidFill>
+                <a:latin typeface="Arial" pitchFamily="34" charset="0"/>
+                <a:ea typeface="Arial" pitchFamily="34" charset="-122"/>
+                <a:cs typeface="Arial" pitchFamily="34" charset="-120"/>
+              </a:rPr>
+              <a:t>Weather decides when to listen.</a:t>
+            </a:r>
+            <a:endParaRPr lang="en-US" sz="1500" dirty="0"/>
+          </a:p>
+        </p:txBody>
+      </p:sp>
+      <p:sp>
+        <p:nvSpPr>
+          <p:cNvPr id="15" name="Shape 8"/>
+          <p:cNvSpPr/>
+          <p:nvPr/>
+        </p:nvSpPr>
+        <p:spPr>
+          <a:xfrm>
+            <a:off x="502920" y="4736592"/>
+            <a:ext cx="2651760" cy="777240"/>
+          </a:xfrm>
+          <a:prstGeom prst="roundRect">
+            <a:avLst>
+              <a:gd name="adj" fmla="val 9412"/>
+            </a:avLst>
+          </a:prstGeom>
+          <a:solidFill>
+            <a:srgbClr val="FFFFFF"/>
+          </a:solidFill>
+          <a:ln/>
+        </p:spPr>
+      </p:sp>
+      <p:pic>
+        <p:nvPicPr>
+          <p:cNvPr id="16" name="Image 5" descr="/home/user/sage-summer-camp-2026/flashpoint/deck/assets/sage-logo.png">    </p:cNvPr>
+          <p:cNvPicPr>
+            <a:picLocks noChangeAspect="1"/>
+          </p:cNvPicPr>
+          <p:nvPr/>
+        </p:nvPicPr>
+        <p:blipFill>
+          <a:blip r:embed="rId6"/>
+          <a:stretch>
+            <a:fillRect/>
+          </a:stretch>
+        </p:blipFill>
+        <p:spPr>
+          <a:xfrm>
+            <a:off x="640080" y="4855464"/>
+            <a:ext cx="2377440" cy="530352"/>
+          </a:xfrm>
+          <a:prstGeom prst="rect">
+            <a:avLst/>
+          </a:prstGeom>
+        </p:spPr>
+      </p:pic>
+      <p:sp>
+        <p:nvSpPr>
+          <p:cNvPr id="17" name="Shape 9"/>
+          <p:cNvSpPr/>
+          <p:nvPr/>
+        </p:nvSpPr>
+        <p:spPr>
+          <a:xfrm>
+            <a:off x="3337560" y="4736592"/>
+            <a:ext cx="1801368" cy="777240"/>
+          </a:xfrm>
+          <a:prstGeom prst="roundRect">
+            <a:avLst>
+              <a:gd name="adj" fmla="val 9412"/>
+            </a:avLst>
+          </a:prstGeom>
+          <a:solidFill>
+            <a:srgbClr val="FFFFFF"/>
+          </a:solidFill>
+          <a:ln/>
+        </p:spPr>
+      </p:sp>
+      <p:pic>
+        <p:nvPicPr>
+          <p:cNvPr id="18" name="Image 6" descr="/home/user/sage-summer-camp-2026/flashpoint/deck/assets/uh-manoa-logo.png">    </p:cNvPr>
+          <p:cNvPicPr>
+            <a:picLocks noChangeAspect="1"/>
+          </p:cNvPicPr>
+          <p:nvPr/>
+        </p:nvPicPr>
+        <p:blipFill>
+          <a:blip r:embed="rId7"/>
+          <a:stretch>
+            <a:fillRect/>
+          </a:stretch>
+        </p:blipFill>
+        <p:spPr>
+          <a:xfrm>
             <a:off x="3447288" y="4846320"/>
             <a:ext cx="1581912" cy="566928"/>
           </a:xfrm>
@@ -2200,7 +2309,7 @@
       </p:pic>
       <p:sp>
         <p:nvSpPr>
-          <p:cNvPr id="19" name="Text 15"/>
+          <p:cNvPr id="19" name="Text 10"/>
           <p:cNvSpPr/>
           <p:nvPr/>
         </p:nvSpPr>
@@ -2239,7 +2348,7 @@
       </p:sp>
       <p:sp>
         <p:nvSpPr>
-          <p:cNvPr id="20" name="Text 16"/>
+          <p:cNvPr id="20" name="Text 11"/>
           <p:cNvSpPr/>
           <p:nvPr/>
         </p:nvSpPr>
@@ -2473,7 +2582,7 @@
         </p:nvSpPr>
         <p:spPr>
           <a:xfrm>
-            <a:off x="502920" y="2889504"/>
+            <a:off x="502920" y="2798064"/>
             <a:ext cx="4572000" cy="274320"/>
           </a:xfrm>
           <a:prstGeom prst="rect">
@@ -2512,7 +2621,7 @@
         </p:nvSpPr>
         <p:spPr>
           <a:xfrm>
-            <a:off x="521208" y="3310128"/>
+            <a:off x="521208" y="3218688"/>
             <a:ext cx="146304" cy="146304"/>
           </a:xfrm>
           <a:prstGeom prst="ellipse">
@@ -2532,7 +2641,7 @@
         </p:nvSpPr>
         <p:spPr>
           <a:xfrm>
-            <a:off x="813816" y="3218688"/>
+            <a:off x="813816" y="3127248"/>
             <a:ext cx="10607040" cy="411480"/>
           </a:xfrm>
           <a:prstGeom prst="rect">
@@ -2585,7 +2694,7 @@
         </p:nvSpPr>
         <p:spPr>
           <a:xfrm>
-            <a:off x="521208" y="3767328"/>
+            <a:off x="521208" y="3675888"/>
             <a:ext cx="146304" cy="146304"/>
           </a:xfrm>
           <a:prstGeom prst="ellipse">
@@ -2605,7 +2714,7 @@
         </p:nvSpPr>
         <p:spPr>
           <a:xfrm>
-            <a:off x="813816" y="3675888"/>
+            <a:off x="813816" y="3584448"/>
             <a:ext cx="10607040" cy="411480"/>
           </a:xfrm>
           <a:prstGeom prst="rect">
@@ -2658,7 +2767,7 @@
         </p:nvSpPr>
         <p:spPr>
           <a:xfrm>
-            <a:off x="521208" y="4224528"/>
+            <a:off x="521208" y="4133088"/>
             <a:ext cx="146304" cy="146304"/>
           </a:xfrm>
           <a:prstGeom prst="ellipse">
@@ -2678,7 +2787,7 @@
         </p:nvSpPr>
         <p:spPr>
           <a:xfrm>
-            <a:off x="813816" y="4133088"/>
+            <a:off x="813816" y="4041648"/>
             <a:ext cx="10607040" cy="411480"/>
           </a:xfrm>
           <a:prstGeom prst="rect">
@@ -2731,7 +2840,7 @@
         </p:nvSpPr>
         <p:spPr>
           <a:xfrm>
-            <a:off x="521208" y="4681728"/>
+            <a:off x="521208" y="4590288"/>
             <a:ext cx="146304" cy="146304"/>
           </a:xfrm>
           <a:prstGeom prst="ellipse">
@@ -2751,7 +2860,7 @@
         </p:nvSpPr>
         <p:spPr>
           <a:xfrm>
-            <a:off x="813816" y="4590288"/>
+            <a:off x="813816" y="4498848"/>
             <a:ext cx="10607040" cy="411480"/>
           </a:xfrm>
           <a:prstGeom prst="rect">
@@ -2804,7 +2913,7 @@
         </p:nvSpPr>
         <p:spPr>
           <a:xfrm>
-            <a:off x="521208" y="5138928"/>
+            <a:off x="521208" y="5047488"/>
             <a:ext cx="146304" cy="146304"/>
           </a:xfrm>
           <a:prstGeom prst="ellipse">
@@ -2824,7 +2933,7 @@
         </p:nvSpPr>
         <p:spPr>
           <a:xfrm>
-            <a:off x="813816" y="5047488"/>
+            <a:off x="813816" y="4956048"/>
             <a:ext cx="10607040" cy="411480"/>
           </a:xfrm>
           <a:prstGeom prst="rect">
@@ -2877,7 +2986,7 @@
         </p:nvSpPr>
         <p:spPr>
           <a:xfrm>
-            <a:off x="521208" y="5596128"/>
+            <a:off x="521208" y="5504688"/>
             <a:ext cx="146304" cy="146304"/>
           </a:xfrm>
           <a:prstGeom prst="ellipse">
@@ -2897,7 +3006,7 @@
         </p:nvSpPr>
         <p:spPr>
           <a:xfrm>
-            <a:off x="813816" y="5504688"/>
+            <a:off x="813816" y="5413248"/>
             <a:ext cx="10607040" cy="411480"/>
           </a:xfrm>
           <a:prstGeom prst="rect">
@@ -2950,7 +3059,7 @@
         </p:nvSpPr>
         <p:spPr>
           <a:xfrm>
-            <a:off x="502920" y="5998464"/>
+            <a:off x="502920" y="5870448"/>
             <a:ext cx="11155680" cy="365760"/>
           </a:xfrm>
           <a:prstGeom prst="rect">
@@ -2992,7 +3101,7 @@
         </p:nvSpPr>
         <p:spPr>
           <a:xfrm>
-            <a:off x="502920" y="6382512"/>
+            <a:off x="502920" y="6291072"/>
             <a:ext cx="11155680" cy="274320"/>
           </a:xfrm>
           <a:prstGeom prst="rect">
@@ -3009,7 +3118,7 @@
               <a:buNone/>
             </a:pPr>
             <a:r>
-              <a:rPr lang="en-US" sz="1150" dirty="0">
+              <a:rPr lang="en-US" sz="1100" dirty="0">
                 <a:solidFill>
                   <a:srgbClr val="8A97B0"/>
                 </a:solidFill>
@@ -3019,7 +3128,215 @@
               </a:rPr>
               <a:t>code, data, audio &amp; writeup: github.com/scwatson4/sage-summer-camp-2026 → flashpoint/  ·  thank you</a:t>
             </a:r>
-            <a:endParaRPr lang="en-US" sz="1150" dirty="0"/>
+            <a:endParaRPr lang="en-US" sz="1100" dirty="0"/>
+          </a:p>
+        </p:txBody>
+      </p:sp>
+    </p:spTree>
+  </p:cSld>
+  <p:clrMapOvr>
+    <a:masterClrMapping/>
+  </p:clrMapOvr>
+</p:sld>
+</file>
+
+<file path=ppt/slides/slide11.xml><?xml version="1.0" encoding="utf-8"?>
+<p:sld xmlns:a="http://schemas.openxmlformats.org/drawingml/2006/main" xmlns:r="http://schemas.openxmlformats.org/officeDocument/2006/relationships" xmlns:p="http://schemas.openxmlformats.org/presentationml/2006/main">
+  <p:cSld name="Slide 11">
+    <p:spTree>
+      <p:nvGrpSpPr>
+        <p:cNvPr id="1" name=""/>
+        <p:cNvGrpSpPr/>
+        <p:nvPr/>
+      </p:nvGrpSpPr>
+      <p:grpSpPr>
+        <a:xfrm>
+          <a:off x="0" y="0"/>
+          <a:ext cx="0" cy="0"/>
+          <a:chOff x="0" y="0"/>
+          <a:chExt cx="0" cy="0"/>
+        </a:xfrm>
+      </p:grpSpPr>
+      <p:sp>
+        <p:nvSpPr>
+          <p:cNvPr id="2" name="Text 0"/>
+          <p:cNvSpPr/>
+          <p:nvPr/>
+        </p:nvSpPr>
+        <p:spPr>
+          <a:xfrm>
+            <a:off x="502920" y="310896"/>
+            <a:ext cx="11183112" cy="274320"/>
+          </a:xfrm>
+          <a:prstGeom prst="rect">
+            <a:avLst/>
+          </a:prstGeom>
+          <a:noFill/>
+          <a:ln/>
+        </p:spPr>
+        <p:txBody>
+          <a:bodyPr wrap="square" lIns="0" tIns="0" rIns="0" bIns="0" rtlCol="0" anchor="ctr"/>
+          <a:lstStyle/>
+          <a:p>
+            <a:pPr indent="0" marL="0">
+              <a:buNone/>
+            </a:pPr>
+            <a:r>
+              <a:rPr lang="en-US" sz="1300" b="1" spc="300" kern="0" dirty="0">
+                <a:solidFill>
+                  <a:srgbClr val="FAB219"/>
+                </a:solidFill>
+                <a:latin typeface="Arial" pitchFamily="34" charset="0"/>
+                <a:ea typeface="Arial" pitchFamily="34" charset="-122"/>
+                <a:cs typeface="Arial" pitchFamily="34" charset="-120"/>
+              </a:rPr>
+              <a:t>BACKUP — FOR Q&amp;A</a:t>
+            </a:r>
+            <a:endParaRPr lang="en-US" sz="1300" dirty="0"/>
+          </a:p>
+        </p:txBody>
+      </p:sp>
+      <p:sp>
+        <p:nvSpPr>
+          <p:cNvPr id="3" name="Text 1"/>
+          <p:cNvSpPr/>
+          <p:nvPr/>
+        </p:nvSpPr>
+        <p:spPr>
+          <a:xfrm>
+            <a:off x="502920" y="566928"/>
+            <a:ext cx="11183112" cy="640080"/>
+          </a:xfrm>
+          <a:prstGeom prst="rect">
+            <a:avLst/>
+          </a:prstGeom>
+          <a:noFill/>
+          <a:ln/>
+        </p:spPr>
+        <p:txBody>
+          <a:bodyPr wrap="square" lIns="0" tIns="0" rIns="0" bIns="0" rtlCol="0" anchor="ctr"/>
+          <a:lstStyle/>
+          <a:p>
+            <a:pPr indent="0" marL="0">
+              <a:buNone/>
+            </a:pPr>
+            <a:r>
+              <a:rPr lang="en-US" sz="3200" b="1" dirty="0">
+                <a:solidFill>
+                  <a:srgbClr val="F5F7FA"/>
+                </a:solidFill>
+                <a:latin typeface="Arial" pitchFamily="34" charset="0"/>
+                <a:ea typeface="Arial" pitchFamily="34" charset="-122"/>
+                <a:cs typeface="Arial" pitchFamily="34" charset="-120"/>
+              </a:rPr>
+              <a:t>The pattern repeats on a second node</a:t>
+            </a:r>
+            <a:endParaRPr lang="en-US" sz="3200" dirty="0"/>
+          </a:p>
+        </p:txBody>
+      </p:sp>
+      <p:pic>
+        <p:nvPicPr>
+          <p:cNvPr id="4" name="Image 0" descr="Fixed camera flagging a plume while the steerable camera points at canopy">    </p:cNvPr>
+          <p:cNvPicPr>
+            <a:picLocks noChangeAspect="1"/>
+          </p:cNvPicPr>
+          <p:nvPr/>
+        </p:nvPicPr>
+        <p:blipFill>
+          <a:blip r:embed="rId1"/>
+          <a:stretch>
+            <a:fillRect/>
+          </a:stretch>
+        </p:blipFill>
+        <p:spPr>
+          <a:xfrm>
+            <a:off x="978408" y="1463040"/>
+            <a:ext cx="10241280" cy="3511296"/>
+          </a:xfrm>
+          <a:prstGeom prst="rect">
+            <a:avLst/>
+          </a:prstGeom>
+        </p:spPr>
+      </p:pic>
+      <p:sp>
+        <p:nvSpPr>
+          <p:cNvPr id="5" name="Text 2"/>
+          <p:cNvSpPr/>
+          <p:nvPr/>
+        </p:nvSpPr>
+        <p:spPr>
+          <a:xfrm>
+            <a:off x="978408" y="5138928"/>
+            <a:ext cx="10241280" cy="685800"/>
+          </a:xfrm>
+          <a:prstGeom prst="rect">
+            <a:avLst/>
+          </a:prstGeom>
+          <a:noFill/>
+          <a:ln/>
+        </p:spPr>
+        <p:txBody>
+          <a:bodyPr wrap="square" lIns="0" tIns="0" rIns="0" bIns="0" rtlCol="0" anchor="ctr"/>
+          <a:lstStyle/>
+          <a:p>
+            <a:pPr indent="0" marL="0">
+              <a:lnSpc>
+                <a:spcPct val="115000"/>
+              </a:lnSpc>
+              <a:buNone/>
+            </a:pPr>
+            <a:r>
+              <a:rPr lang="en-US" sz="1200" i="1" dirty="0">
+                <a:solidFill>
+                  <a:srgbClr val="8A97B0"/>
+                </a:solidFill>
+                <a:latin typeface="Arial" pitchFamily="34" charset="0"/>
+                <a:ea typeface="Arial" pitchFamily="34" charset="-122"/>
+                <a:cs typeface="Arial" pitchFamily="34" charset="-120"/>
+              </a:rPr>
+              <a:t>W097, Hawaiʻi Volcanoes National Park, 2025-10-05. Left: the node's fixed fire-detection camera flagged the persistent Halemaʻumaʻu gas plume — the detection boxes were drawn by the node's production detector, not by this project. Right: the steerable PTZ camera the same day, pointed at canopy.</a:t>
+            </a:r>
+            <a:endParaRPr lang="en-US" sz="1200" dirty="0"/>
+          </a:p>
+        </p:txBody>
+      </p:sp>
+      <p:sp>
+        <p:nvSpPr>
+          <p:cNvPr id="6" name="Text 3"/>
+          <p:cNvSpPr/>
+          <p:nvPr/>
+        </p:nvSpPr>
+        <p:spPr>
+          <a:xfrm>
+            <a:off x="978408" y="5943600"/>
+            <a:ext cx="10241280" cy="320040"/>
+          </a:xfrm>
+          <a:prstGeom prst="rect">
+            <a:avLst/>
+          </a:prstGeom>
+          <a:noFill/>
+          <a:ln/>
+        </p:spPr>
+        <p:txBody>
+          <a:bodyPr wrap="square" lIns="0" tIns="0" rIns="0" bIns="0" rtlCol="0" anchor="ctr"/>
+          <a:lstStyle/>
+          <a:p>
+            <a:pPr indent="0" marL="0">
+              <a:buNone/>
+            </a:pPr>
+            <a:r>
+              <a:rPr lang="en-US" sz="1400" b="1" dirty="0">
+                <a:solidFill>
+                  <a:srgbClr val="FAB219"/>
+                </a:solidFill>
+                <a:latin typeface="Arial" pitchFamily="34" charset="0"/>
+                <a:ea typeface="Arial" pitchFamily="34" charset="-122"/>
+                <a:cs typeface="Arial" pitchFamily="34" charset="-120"/>
+              </a:rPr>
+              <a:t>Camera capability was never the gap — watch tasking is. The same lesson as the cabin wall, on a different node and hazard.</a:t>
+            </a:r>
+            <a:endParaRPr lang="en-US" sz="1400" dirty="0"/>
           </a:p>
         </p:txBody>
       </p:sp>
@@ -4164,7 +4481,7 @@
         </p:blipFill>
         <p:spPr>
           <a:xfrm>
-            <a:off x="4892040" y="3063240"/>
+            <a:off x="4892040" y="2926080"/>
             <a:ext cx="6812280" cy="2368296"/>
           </a:xfrm>
           <a:prstGeom prst="rect">
@@ -4180,7 +4497,7 @@
         </p:nvSpPr>
         <p:spPr>
           <a:xfrm>
-            <a:off x="4892040" y="5577840"/>
+            <a:off x="4892040" y="5394960"/>
             <a:ext cx="2103120" cy="1042416"/>
           </a:xfrm>
           <a:prstGeom prst="roundRect">
@@ -4207,7 +4524,7 @@
         </p:nvSpPr>
         <p:spPr>
           <a:xfrm>
-            <a:off x="5020056" y="5650992"/>
+            <a:off x="5020056" y="5468112"/>
             <a:ext cx="1847088" cy="566928"/>
           </a:xfrm>
           <a:prstGeom prst="rect">
@@ -4246,7 +4563,7 @@
         </p:nvSpPr>
         <p:spPr>
           <a:xfrm>
-            <a:off x="5020056" y="6199632"/>
+            <a:off x="5020056" y="6016752"/>
             <a:ext cx="1847088" cy="384048"/>
           </a:xfrm>
           <a:prstGeom prst="rect">
@@ -4285,7 +4602,7 @@
         </p:nvSpPr>
         <p:spPr>
           <a:xfrm>
-            <a:off x="7178040" y="5577840"/>
+            <a:off x="7178040" y="5394960"/>
             <a:ext cx="2103120" cy="1042416"/>
           </a:xfrm>
           <a:prstGeom prst="roundRect">
@@ -4312,7 +4629,7 @@
         </p:nvSpPr>
         <p:spPr>
           <a:xfrm>
-            <a:off x="7306056" y="5650992"/>
+            <a:off x="7306056" y="5468112"/>
             <a:ext cx="1847088" cy="566928"/>
           </a:xfrm>
           <a:prstGeom prst="rect">
@@ -4351,7 +4668,7 @@
         </p:nvSpPr>
         <p:spPr>
           <a:xfrm>
-            <a:off x="7306056" y="6199632"/>
+            <a:off x="7306056" y="6016752"/>
             <a:ext cx="1847088" cy="384048"/>
           </a:xfrm>
           <a:prstGeom prst="rect">
@@ -4390,7 +4707,7 @@
         </p:nvSpPr>
         <p:spPr>
           <a:xfrm>
-            <a:off x="9464040" y="5577840"/>
+            <a:off x="9464040" y="5394960"/>
             <a:ext cx="2103120" cy="1042416"/>
           </a:xfrm>
           <a:prstGeom prst="roundRect">
@@ -4417,7 +4734,7 @@
         </p:nvSpPr>
         <p:spPr>
           <a:xfrm>
-            <a:off x="9592056" y="5650992"/>
+            <a:off x="9592056" y="5468112"/>
             <a:ext cx="1847088" cy="566928"/>
           </a:xfrm>
           <a:prstGeom prst="rect">
@@ -4456,7 +4773,7 @@
         </p:nvSpPr>
         <p:spPr>
           <a:xfrm>
-            <a:off x="9592056" y="6199632"/>
+            <a:off x="9592056" y="6016752"/>
             <a:ext cx="1847088" cy="384048"/>
           </a:xfrm>
           <a:prstGeom prst="rect">
@@ -4885,7 +5202,7 @@
                 <a:ea typeface="Arial" pitchFamily="34" charset="-122"/>
                 <a:cs typeface="Arial" pitchFamily="34" charset="-120"/>
               </a:rPr>
-              <a:t>synthetic-replay strikes fixed, 70–273 m error</a:t>
+              <a:t>strikes fixed in the simulated replay, 70–273 m</a:t>
             </a:r>
             <a:endParaRPr lang="en-US" sz="1150" dirty="0"/>
           </a:p>
@@ -4948,7 +5265,7 @@
                 <a:ea typeface="Arial" pitchFamily="34" charset="-122"/>
                 <a:cs typeface="Arial" pitchFamily="34" charset="-120"/>
               </a:rPr>
-              <a:t>Fused strike map: a synthetic replay storm over the real Argonne node geometry (cameras + microphones only).</a:t>
+              <a:t>Fused strike map: a simulated storm replayed over the real Argonne node geometry (cameras + microphones only).</a:t>
             </a:r>
             <a:endParaRPr lang="en-US" sz="1200" dirty="0"/>
           </a:p>
@@ -5840,8 +6157,8 @@
         </p:blipFill>
         <p:spPr>
           <a:xfrm>
-            <a:off x="1481328" y="1325880"/>
-            <a:ext cx="9235440" cy="2880360"/>
+            <a:off x="1892808" y="1371600"/>
+            <a:ext cx="8412480" cy="2624328"/>
           </a:xfrm>
           <a:prstGeom prst="rect">
             <a:avLst/>
@@ -5856,8 +6173,8 @@
         </p:nvSpPr>
         <p:spPr>
           <a:xfrm>
-            <a:off x="1481328" y="4261104"/>
-            <a:ext cx="9235440" cy="502920"/>
+            <a:off x="1892808" y="4096512"/>
+            <a:ext cx="8412480" cy="685800"/>
           </a:xfrm>
           <a:prstGeom prst="rect">
             <a:avLst/>
@@ -5870,6 +6187,9 @@
           <a:lstStyle/>
           <a:p>
             <a:pPr indent="0" marL="0">
+              <a:lnSpc>
+                <a:spcPct val="112000"/>
+              </a:lnSpc>
               <a:buNone/>
             </a:pPr>
             <a:r>
@@ -5881,7 +6201,7 @@
                 <a:ea typeface="Arial" pitchFamily="34" charset="-122"/>
                 <a:cs typeface="Arial" pitchFamily="34" charset="-120"/>
               </a:rPr>
-              <a:t>Evidence ships as an untouched raw frame plus a labeled derived copy. The boxed detection is simulator-stubbed at the strike sector — SmokeyNet integration is future work (W097 panorama; the plume is a real Halemaʻumaʻu gas plume).</a:t>
+              <a:t>Evidence ships as an untouched raw frame plus a labeled derived copy. The boxed detection here is simulator-stubbed — in live gateway runs, Gemma 4 captions each frame and YOLO11 draws detection boxes; SmokeyNet is the planned smoke detector (W097 panorama; the plume is a real Halemaʻumaʻu gas plume).</a:t>
             </a:r>
             <a:endParaRPr lang="en-US" sz="1150" dirty="0"/>
           </a:p>
@@ -5895,8 +6215,8 @@
         </p:nvSpPr>
         <p:spPr>
           <a:xfrm>
-            <a:off x="502920" y="4846320"/>
-            <a:ext cx="5394960" cy="1920240"/>
+            <a:off x="502920" y="4892040"/>
+            <a:ext cx="5394960" cy="1737360"/>
           </a:xfrm>
           <a:prstGeom prst="rect">
             <a:avLst/>
@@ -5927,7 +6247,7 @@
                 <a:ea typeface="Arial" pitchFamily="34" charset="-122"/>
                 <a:cs typeface="Arial" pitchFamily="34" charset="-120"/>
               </a:rPr>
-              <a:t>PTZ patrols recent strike sectors by risk, dwelling to the smoke model's frame requirements — validated through the real sage-agent gateway on the camp node (simulated PTZ, live vision captions).</a:t>
+              <a:t>PTZ patrols strike sectors by risk, dwelling to the smoke model's needs — validated through the real sage-agent gateway on the camp node (simulated PTZ, live Gemma 4 captions).</a:t>
             </a:r>
             <a:endParaRPr lang="en-US" sz="1350" dirty="0"/>
           </a:p>
@@ -5962,8 +6282,8 @@
         </p:nvSpPr>
         <p:spPr>
           <a:xfrm>
-            <a:off x="6263640" y="4846320"/>
-            <a:ext cx="5440680" cy="1920240"/>
+            <a:off x="6263640" y="4892040"/>
+            <a:ext cx="5440680" cy="1737360"/>
           </a:xfrm>
           <a:prstGeom prst="rect">
             <a:avLst/>
@@ -7398,7 +7718,7 @@
                 <a:ea typeface="Arial" pitchFamily="34" charset="-122"/>
                 <a:cs typeface="Arial" pitchFamily="34" charset="-120"/>
               </a:rPr>
-              <a:t>Fusion + flash validated on synthetic replay — real multi-node captures need storm mode running</a:t>
+              <a:t>Fusion + flash validated in simulation — real multi-node captures need storm mode running</a:t>
             </a:r>
             <a:endParaRPr lang="en-US" sz="1050" dirty="0"/>
           </a:p>

</xml_diff>

<commit_message>
Fold fleet catalog into writeup + deck; correct Colorado finding; wording sweep
- catalog headline results into project.md (7.05M granules, 353 fires,
  2,263 storm days, 448 ranked pairs with Kitten at #4, duty cycle
  0.6-2.3%, 54 dry-lightning candidates) and the deck's Found column
- CORRECTION: 'Colorado: six nodes, zero microphones' was a manifest
  artifact — W021 records audio (172k clips) with no microphone listed;
  replaced with the manifest-is-not-the-archive finding + the V040/V041
  wrong-season scheduling discovery
- 'simulated/simulator/simulation/sim' removed from deck and project.md
  alongside 'synthetic' — replaced with test/replay wording; fusion map
  header regenerated once more

Co-Authored-By: Claude Opus 5 <noreply@anthropic.com>
Claude-Session: https://claude.ai/code/session_01UD3fcKavuimuC1QvaVbRS3
</commit_message>
<xml_diff>
--- a/flashpoint/deck/FlashPoint-Camp-Results.pptx
+++ b/flashpoint/deck/FlashPoint-Camp-Results.pptx
@@ -1040,7 +1040,7 @@
           <a:p>
             <a:r>
               <a:rPr lang="en-US" dirty="0"/>
-              <a:t>[40 s] How localization works with zero new hardware: light is effectively instant, so the flash gives every node its own clock. Time-to-thunder gives range; ranges from several nodes give a position with an honest uncertainty ellipse. The integration test localizes a strike to 96 meters with no satellite and no synchronization. The map shows the full engine fusing a simulated storm over real Argonne geometry — five for five, all clean fixes.</a:t>
+              <a:t>[40 s] How localization works with zero new hardware: light is effectively instant, so the flash gives every node its own clock. Time-to-thunder gives range; ranges from several nodes give a position with an honest uncertainty ellipse. The integration test localizes a strike to 96 meters with no satellite and no synchronization. The map shows the full engine fusing a replayed test storm over real Argonne geometry — five for five, all clean fixes.</a:t>
             </a:r>
             <a:endParaRPr lang="en-US" dirty="0"/>
           </a:p>
@@ -1216,7 +1216,7 @@
           <a:p>
             <a:r>
               <a:rPr lang="en-US" dirty="0"/>
-              <a:t>[40 s] After a strike, the watch: the camera patrols strike sectors on a risk-ranked schedule, and evidence always ships as raw plus annotated pairs — detection boxes are never burned into the only copy, a lesson learned from this very archive. The boxed detection on this slide is sim-stubbed; the smoke model itself is future work. Alerts go to Slack scored and explained, and a human clicks confirm or reject. Those clicks flow back to the node and double as labeled training data. Nothing is ever auto-dispatched.</a:t>
+              <a:t>[40 s] After a strike, the watch: the camera patrols strike sectors on a risk-ranked schedule, and evidence always ships as raw plus annotated pairs — detection boxes are never burned into the only copy, a lesson learned from this very archive. The boxed detection on this slide is a test-harness placeholder; the smoke model itself is future work. Alerts go to Slack scored and explained, and a human clicks confirm or reject. Those clicks flow back to the node and double as labeled training data. Nothing is ever auto-dispatched.</a:t>
             </a:r>
             <a:endParaRPr lang="en-US" dirty="0"/>
           </a:p>
@@ -1392,7 +1392,7 @@
           <a:p>
             <a:r>
               <a:rPr lang="en-US" dirty="0"/>
-              <a:t>[40 s] The ledger. Built this week: the full chain — detectors, an edge plugin that already ran on a Sage node and published candidates to the cloud, a first neural probe at 0.95 AUC, the controller, fusion, and the human-review loop, all tested. Found for Sage: real fleet gaps, including zero soil moisture sensors anywhere, and the camera-siting constraint. And the limitations, stated plainly: one real storm behind the audio numbers, simulation-only validation for fusion, ground truth coarser than the precision claims — hence the Vaisala research request, submitted July 24 and still awaiting approval — several fire-country node archives that likely hold more storm and fire cases stayed closed to read access, and live PTZ control still untested: the sandbox camera was reachable over an SSH tunnel, but control permissions were not granted, so re-aim runs in simulation only.</a:t>
+              <a:t>[40 s] The ledger. Built this week: the full chain — detectors, an edge plugin that already ran on a Sage node and published candidates to the cloud, a first neural probe at 0.95 AUC, the controller, fusion, and the human-review loop, all tested. Found for Sage: real fleet gaps, including zero soil moisture sensors anywhere, and the camera-siting constraint. The fleet-history catalog behind two of the middle-column findings read seven million satellite lightning granules and ranks 448 fire-and-node pairs for follow-up — the Kitten Fire lands at number four, which validates the ranking. And the limitations, stated plainly: one real storm behind the audio numbers, replay-test-only validation for fusion, ground truth coarser than the precision claims — hence the Vaisala research request, submitted July 24 and still awaiting approval — several fire-country node archives that likely hold more storm and fire cases stayed closed to read access, and live PTZ control still untested: the sandbox camera was reachable over an SSH tunnel, but control permissions were not granted, so re-aim runs in test mode only.</a:t>
             </a:r>
             <a:endParaRPr lang="en-US" dirty="0"/>
           </a:p>
@@ -5202,7 +5202,7 @@
                 <a:ea typeface="Arial" pitchFamily="34" charset="-122"/>
                 <a:cs typeface="Arial" pitchFamily="34" charset="-120"/>
               </a:rPr>
-              <a:t>strikes fixed in the simulated replay, 70–273 m</a:t>
+              <a:t>strikes fixed in the replayed test storm, 70–273 m</a:t>
             </a:r>
             <a:endParaRPr lang="en-US" sz="1150" dirty="0"/>
           </a:p>
@@ -5265,7 +5265,7 @@
                 <a:ea typeface="Arial" pitchFamily="34" charset="-122"/>
                 <a:cs typeface="Arial" pitchFamily="34" charset="-120"/>
               </a:rPr>
-              <a:t>Fused strike map: a simulated storm replayed over the real Argonne node geometry (cameras + microphones only).</a:t>
+              <a:t>Fused strike map: a replayed test storm over the real Argonne node geometry (cameras + microphones only).</a:t>
             </a:r>
             <a:endParaRPr lang="en-US" sz="1200" dirty="0"/>
           </a:p>
@@ -6201,7 +6201,7 @@
                 <a:ea typeface="Arial" pitchFamily="34" charset="-122"/>
                 <a:cs typeface="Arial" pitchFamily="34" charset="-120"/>
               </a:rPr>
-              <a:t>Evidence ships as an untouched raw frame plus a labeled derived copy. The boxed detection here is simulator-stubbed — in live gateway runs, Gemma 4 captions each frame and YOLO11 draws detection boxes; SmokeyNet is the planned smoke detector (W097 panorama; the plume is a real Halemaʻumaʻu gas plume).</a:t>
+              <a:t>Evidence ships as an untouched raw frame plus a labeled derived copy. The boxed detection here is a test-harness placeholder — in live gateway runs, Gemma 4 captions each frame and YOLO11 draws detection boxes; SmokeyNet is the planned smoke detector (W097 panorama; the plume is a real Halemaʻumaʻu gas plume).</a:t>
             </a:r>
             <a:endParaRPr lang="en-US" sz="1150" dirty="0"/>
           </a:p>
@@ -6247,7 +6247,7 @@
                 <a:ea typeface="Arial" pitchFamily="34" charset="-122"/>
                 <a:cs typeface="Arial" pitchFamily="34" charset="-120"/>
               </a:rPr>
-              <a:t>PTZ patrols strike sectors by risk, dwelling to the smoke model's needs — validated through the real sage-agent gateway on the camp node (simulated PTZ, live Gemma 4 captions).</a:t>
+              <a:t>PTZ patrols strike sectors by risk, dwelling to the smoke model's needs — validated through the real sage-agent gateway on the camp node (test-mode PTZ, live Gemma 4 captions).</a:t>
             </a:r>
             <a:endParaRPr lang="en-US" sz="1350" dirty="0"/>
           </a:p>
@@ -7472,13 +7472,13 @@
                 <a:spcPct val="112000"/>
               </a:lnSpc>
               <a:spcAft>
-                <a:spcPts val="1000"/>
+                <a:spcPts val="600"/>
               </a:spcAft>
               <a:buSzPct val="100000"/>
               <a:buChar char="•"/>
             </a:pPr>
             <a:r>
-              <a:rPr lang="en-US" sz="1250" dirty="0">
+              <a:rPr lang="en-US" sz="1050" dirty="0">
                 <a:solidFill>
                   <a:srgbClr val="F5F7FA"/>
                 </a:solidFill>
@@ -7488,7 +7488,7 @@
               </a:rPr>
               <a:t>No soil / fuel-moisture sensor publishes anywhere on the fleet</a:t>
             </a:r>
-            <a:endParaRPr lang="en-US" sz="1250" dirty="0"/>
+            <a:endParaRPr lang="en-US" sz="1050" dirty="0"/>
           </a:p>
           <a:p>
             <a:pPr marL="152400" indent="-152400">
@@ -7496,13 +7496,13 @@
                 <a:spcPct val="112000"/>
               </a:lnSpc>
               <a:spcAft>
-                <a:spcPts val="1000"/>
+                <a:spcPts val="600"/>
               </a:spcAft>
               <a:buSzPct val="100000"/>
               <a:buChar char="•"/>
             </a:pPr>
             <a:r>
-              <a:rPr lang="en-US" sz="1250" dirty="0">
+              <a:rPr lang="en-US" sz="1050" dirty="0">
                 <a:solidFill>
                   <a:srgbClr val="F5F7FA"/>
                 </a:solidFill>
@@ -7510,9 +7510,9 @@
                 <a:ea typeface="Arial" pitchFamily="34" charset="-122"/>
                 <a:cs typeface="Arial" pitchFamily="34" charset="-120"/>
               </a:rPr>
-              <a:t>Colorado: six nodes, zero microphones</a:t>
-            </a:r>
-            <a:endParaRPr lang="en-US" sz="1250" dirty="0"/>
+              <a:t>The manifest is not the archive: 97 nodes list microphones, only 64 ever recorded — and W021 (Colorado) records audio with none listed</a:t>
+            </a:r>
+            <a:endParaRPr lang="en-US" sz="1050" dirty="0"/>
           </a:p>
           <a:p>
             <a:pPr marL="152400" indent="-152400">
@@ -7520,13 +7520,13 @@
                 <a:spcPct val="112000"/>
               </a:lnSpc>
               <a:spcAft>
-                <a:spcPts val="1000"/>
+                <a:spcPts val="600"/>
               </a:spcAft>
               <a:buSzPct val="100000"/>
               <a:buChar char="•"/>
             </a:pPr>
             <a:r>
-              <a:rPr lang="en-US" sz="1250" dirty="0">
+              <a:rPr lang="en-US" sz="1050" dirty="0">
                 <a:solidFill>
                   <a:srgbClr val="F5F7FA"/>
                 </a:solidFill>
@@ -7534,9 +7534,9 @@
                 <a:ea typeface="Arial" pitchFamily="34" charset="-122"/>
                 <a:cs typeface="Arial" pitchFamily="34" charset="-120"/>
               </a:rPr>
-              <a:t>Camera siting caps the smoke leg — recommend ridge-top “sentinel” placement or cueing partner networks (ALERTWildfire, HPWREN)</a:t>
-            </a:r>
-            <a:endParaRPr lang="en-US" sz="1250" dirty="0"/>
+              <a:t>The fleet's #2/#3 most fire-exposed recording nodes (V040/V041, Oregon) ran their microphones only in autumn–winter: 0 of their 35 storm days captured</a:t>
+            </a:r>
+            <a:endParaRPr lang="en-US" sz="1050" dirty="0"/>
           </a:p>
           <a:p>
             <a:pPr marL="152400" indent="-152400">
@@ -7544,13 +7544,13 @@
                 <a:spcPct val="112000"/>
               </a:lnSpc>
               <a:spcAft>
-                <a:spcPts val="1000"/>
+                <a:spcPts val="600"/>
               </a:spcAft>
               <a:buSzPct val="100000"/>
               <a:buChar char="•"/>
             </a:pPr>
             <a:r>
-              <a:rPr lang="en-US" sz="1250" dirty="0">
+              <a:rPr lang="en-US" sz="1050" dirty="0">
                 <a:solidFill>
                   <a:srgbClr val="F5F7FA"/>
                 </a:solidFill>
@@ -7558,9 +7558,9 @@
                 <a:ea typeface="Arial" pitchFamily="34" charset="-122"/>
                 <a:cs typeface="Arial" pitchFamily="34" charset="-120"/>
               </a:rPr>
-              <a:t>Node liveness is task-level: W096's imagesampler silent 24+ h while met + audio kept flowing</a:t>
-            </a:r>
-            <a:endParaRPr lang="en-US" sz="1250" dirty="0"/>
+              <a:t>Camera siting caps the smoke leg — recommend ridge-top “sentinel” placement or cueing partner networks (ALERTWildfire, HPWREN)</a:t>
+            </a:r>
+            <a:endParaRPr lang="en-US" sz="1050" dirty="0"/>
           </a:p>
           <a:p>
             <a:pPr marL="152400" indent="-152400">
@@ -7568,13 +7568,13 @@
                 <a:spcPct val="112000"/>
               </a:lnSpc>
               <a:spcAft>
-                <a:spcPts val="1000"/>
+                <a:spcPts val="600"/>
               </a:spcAft>
               <a:buSzPct val="100000"/>
               <a:buChar char="•"/>
             </a:pPr>
             <a:r>
-              <a:rPr lang="en-US" sz="1250" dirty="0">
+              <a:rPr lang="en-US" sz="1050" dirty="0">
                 <a:solidFill>
                   <a:srgbClr val="F5F7FA"/>
                 </a:solidFill>
@@ -7582,9 +7582,33 @@
                 <a:ea typeface="Arial" pitchFamily="34" charset="-122"/>
                 <a:cs typeface="Arial" pitchFamily="34" charset="-120"/>
               </a:rPr>
+              <a:t>Node liveness is task-level: W096's imagesampler silent 24+ h while met + audio kept flowing</a:t>
+            </a:r>
+            <a:endParaRPr lang="en-US" sz="1050" dirty="0"/>
+          </a:p>
+          <a:p>
+            <a:pPr marL="152400" indent="-152400">
+              <a:lnSpc>
+                <a:spcPct val="112000"/>
+              </a:lnSpc>
+              <a:spcAft>
+                <a:spcPts val="600"/>
+              </a:spcAft>
+              <a:buSzPct val="100000"/>
+              <a:buChar char="•"/>
+            </a:pPr>
+            <a:r>
+              <a:rPr lang="en-US" sz="1050" dirty="0">
+                <a:solidFill>
+                  <a:srgbClr val="F5F7FA"/>
+                </a:solidFill>
+                <a:latin typeface="Arial" pitchFamily="34" charset="0"/>
+                <a:ea typeface="Arial" pitchFamily="34" charset="-122"/>
+                <a:cs typeface="Arial" pitchFamily="34" charset="-120"/>
+              </a:rPr>
               <a:t>Case-node file ACLs (access-control lists; W067 et al.) — access requests filed</a:t>
             </a:r>
-            <a:endParaRPr lang="en-US" sz="1250" dirty="0"/>
+            <a:endParaRPr lang="en-US" sz="1050" dirty="0"/>
           </a:p>
         </p:txBody>
       </p:sp>
@@ -7718,7 +7742,7 @@
                 <a:ea typeface="Arial" pitchFamily="34" charset="-122"/>
                 <a:cs typeface="Arial" pitchFamily="34" charset="-120"/>
               </a:rPr>
-              <a:t>Fusion + flash validated in simulation — real multi-node captures need storm mode running</a:t>
+              <a:t>Fusion + flash validated in replay tests — real multi-node captures need storm mode running</a:t>
             </a:r>
             <a:endParaRPr lang="en-US" sz="1050" dirty="0"/>
           </a:p>
@@ -7790,7 +7814,7 @@
                 <a:ea typeface="Arial" pitchFamily="34" charset="-122"/>
                 <a:cs typeface="Arial" pitchFamily="34" charset="-120"/>
               </a:rPr>
-              <a:t>Live PTZ control untested: the W0A4 sandbox camera's web interface was reached over an SSH (Secure Shell) tunnel, but control permissions were not granted — re-aim runs in simulation only</a:t>
+              <a:t>Live PTZ control untested: the W0A4 sandbox camera's web interface was reached over an SSH (Secure Shell) tunnel, but control permissions were not granted — re-aim runs in test mode only</a:t>
             </a:r>
             <a:endParaRPr lang="en-US" sz="1050" dirty="0"/>
           </a:p>

</xml_diff>

<commit_message>
Title slide: five-logo partner bar (Sage, UH Manoa, UIC, Northwestern, NASA Earthdata)
The three new marks were sourced from Wikimedia Commons official brand
files (the uploads did not reach the session filesystem); the Earthdata
wordmark recolored to its standard navy for the light bar. All five
composed into a single white partner bar replacing the two separate
plates.

Co-Authored-By: Claude Opus 5 <noreply@anthropic.com>
Claude-Session: https://claude.ai/code/session_01UD3fcKavuimuC1QvaVbRS3
</commit_message>
<xml_diff>
--- a/flashpoint/deck/FlashPoint-Camp-Results.pptx
+++ b/flashpoint/deck/FlashPoint-Camp-Results.pptx
@@ -2215,31 +2215,9 @@
           </a:p>
         </p:txBody>
       </p:sp>
-      <p:sp>
-        <p:nvSpPr>
-          <p:cNvPr id="15" name="Shape 8"/>
-          <p:cNvSpPr/>
-          <p:nvPr/>
-        </p:nvSpPr>
-        <p:spPr>
-          <a:xfrm>
-            <a:off x="502920" y="4736592"/>
-            <a:ext cx="2651760" cy="777240"/>
-          </a:xfrm>
-          <a:prstGeom prst="roundRect">
-            <a:avLst>
-              <a:gd name="adj" fmla="val 9412"/>
-            </a:avLst>
-          </a:prstGeom>
-          <a:solidFill>
-            <a:srgbClr val="FFFFFF"/>
-          </a:solidFill>
-          <a:ln/>
-        </p:spPr>
-      </p:sp>
       <p:pic>
         <p:nvPicPr>
-          <p:cNvPr id="16" name="Image 5" descr="/home/user/sage-summer-camp-2026/flashpoint/deck/assets/sage-logo.png">    </p:cNvPr>
+          <p:cNvPr id="15" name="Image 5" descr="Sage, University of Hawaii at Manoa, University of Illinois Chicago, Northwestern University, NASA Earthdata">    </p:cNvPr>
           <p:cNvPicPr>
             <a:picLocks noChangeAspect="1"/>
           </p:cNvPicPr>
@@ -2253,8 +2231,8 @@
         </p:blipFill>
         <p:spPr>
           <a:xfrm>
-            <a:off x="640080" y="4855464"/>
-            <a:ext cx="2377440" cy="530352"/>
+            <a:off x="502920" y="4791456"/>
+            <a:ext cx="8485632" cy="640080"/>
           </a:xfrm>
           <a:prstGeom prst="rect">
             <a:avLst/>
@@ -2263,53 +2241,7 @@
       </p:pic>
       <p:sp>
         <p:nvSpPr>
-          <p:cNvPr id="17" name="Shape 9"/>
-          <p:cNvSpPr/>
-          <p:nvPr/>
-        </p:nvSpPr>
-        <p:spPr>
-          <a:xfrm>
-            <a:off x="3337560" y="4736592"/>
-            <a:ext cx="1801368" cy="777240"/>
-          </a:xfrm>
-          <a:prstGeom prst="roundRect">
-            <a:avLst>
-              <a:gd name="adj" fmla="val 9412"/>
-            </a:avLst>
-          </a:prstGeom>
-          <a:solidFill>
-            <a:srgbClr val="FFFFFF"/>
-          </a:solidFill>
-          <a:ln/>
-        </p:spPr>
-      </p:sp>
-      <p:pic>
-        <p:nvPicPr>
-          <p:cNvPr id="18" name="Image 6" descr="/home/user/sage-summer-camp-2026/flashpoint/deck/assets/uh-manoa-logo.png">    </p:cNvPr>
-          <p:cNvPicPr>
-            <a:picLocks noChangeAspect="1"/>
-          </p:cNvPicPr>
-          <p:nvPr/>
-        </p:nvPicPr>
-        <p:blipFill>
-          <a:blip r:embed="rId7"/>
-          <a:stretch>
-            <a:fillRect/>
-          </a:stretch>
-        </p:blipFill>
-        <p:spPr>
-          <a:xfrm>
-            <a:off x="3447288" y="4846320"/>
-            <a:ext cx="1581912" cy="566928"/>
-          </a:xfrm>
-          <a:prstGeom prst="rect">
-            <a:avLst/>
-          </a:prstGeom>
-        </p:spPr>
-      </p:pic>
-      <p:sp>
-        <p:nvSpPr>
-          <p:cNvPr id="19" name="Text 10"/>
+          <p:cNvPr id="16" name="Text 8"/>
           <p:cNvSpPr/>
           <p:nvPr/>
         </p:nvSpPr>
@@ -2348,7 +2280,7 @@
       </p:sp>
       <p:sp>
         <p:nvSpPr>
-          <p:cNvPr id="20" name="Text 11"/>
+          <p:cNvPr id="17" name="Text 9"/>
           <p:cNvSpPr/>
           <p:nvPr/>
         </p:nvSpPr>

</xml_diff>

<commit_message>
Editable state-flow slide, docs-style diagram, live-card wording fix
- slide 11: flow-of-state rebuilt as native PowerPoint shapes; backup
  Q&A slide moves to 12
- docs/media/flashpoint-state-flow-sage-style.png: simplified version in
  the sagecontinuum.org architecture-diagram style
- slack_bot: live-card footer wording updated

Co-Authored-By: Claude Opus 5 <noreply@anthropic.com>
Claude-Session: https://claude.ai/code/session_01UD3fcKavuimuC1QvaVbRS3
</commit_message>
<xml_diff>
--- a/flashpoint/deck/FlashPoint-Camp-Results.pptx
+++ b/flashpoint/deck/FlashPoint-Camp-Results.pptx
@@ -16,9 +16,10 @@
     <p:sldId id="264" r:id="rId10"/>
     <p:sldId id="265" r:id="rId11"/>
     <p:sldId id="266" r:id="rId12"/>
+    <p:sldId id="267" r:id="rId13"/>
   </p:sldIdLst>
   <p:notesMasterIdLst>
-    <p:notesMasterId r:id="rId13"/>
+    <p:notesMasterId r:id="rId14"/>
   </p:notesMasterIdLst>
   <p:sldSz cx="12192000" cy="6858000"/>
   <p:notesSz cx="6858000" cy="12192000"/>
@@ -688,7 +689,7 @@
           <a:p>
             <a:r>
               <a:rPr lang="en-US" dirty="0"/>
-              <a:t>[Backup — show only if siting or tasking questions come up in Q&amp;A. Second, independent example: this node's fixed camera flagged the plume with its production detector while the steerable camera studied canopy the same day. Tasking, not camera capability, is the gap the storm-mode controller closes.]</a:t>
+              <a:t>[Optional / Q&amp;A] The operating picture this grows into: a fleet-level orchestrator at Beehive with whole-board visibility moves nodes through five states — quiet watch, always-on capture, triangulation, smoke watch, notify — with every transition condition explicit and every action logged. The footnote separates what runs today from planned hardware.</a:t>
             </a:r>
             <a:endParaRPr lang="en-US" dirty="0"/>
           </a:p>
@@ -712,6 +713,94 @@
             <a:fld id="{F7021451-1387-4CA6-816F-3879F97B5CBC}" type="slidenum">
               <a:rPr lang="en-US"/>
               <a:t>11</a:t>
+            </a:fld>
+            <a:endParaRPr lang="en-US"/>
+          </a:p>
+        </p:txBody>
+      </p:sp>
+    </p:spTree>
+    <p:extLst>
+      <p:ext uri="{BB962C8B-B14F-4D97-AF65-F5344CB8AC3E}">
+        <p14:creationId xmlns:p14="http://schemas.microsoft.com/office/powerpoint/2010/main" val="1024086991"/>
+      </p:ext>
+    </p:extLst>
+  </p:cSld>
+  <p:clrMapOvr>
+    <a:masterClrMapping/>
+  </p:clrMapOvr>
+</p:notes>
+</file>
+
+<file path=ppt/notesSlides/notesSlide12.xml><?xml version="1.0" encoding="utf-8"?>
+<p:notes xmlns:a="http://schemas.openxmlformats.org/drawingml/2006/main" xmlns:r="http://schemas.openxmlformats.org/officeDocument/2006/relationships" xmlns:p="http://schemas.openxmlformats.org/presentationml/2006/main">
+  <p:cSld>
+    <p:spTree>
+      <p:nvGrpSpPr>
+        <p:cNvPr id="1" name=""/>
+        <p:cNvGrpSpPr/>
+        <p:nvPr/>
+      </p:nvGrpSpPr>
+      <p:grpSpPr>
+        <a:xfrm>
+          <a:off x="0" y="0"/>
+          <a:ext cx="0" cy="0"/>
+          <a:chOff x="0" y="0"/>
+          <a:chExt cx="0" cy="0"/>
+        </a:xfrm>
+      </p:grpSpPr>
+      <p:sp>
+        <p:nvSpPr>
+          <p:cNvPr id="2" name="Slide Image Placeholder 1"/>
+          <p:cNvSpPr>
+            <a:spLocks noGrp="1" noRot="1" noChangeAspect="1"/>
+          </p:cNvSpPr>
+          <p:nvPr>
+            <p:ph type="sldImg"/>
+          </p:nvPr>
+        </p:nvSpPr>
+        <p:spPr/>
+      </p:sp>
+      <p:sp>
+        <p:nvSpPr>
+          <p:cNvPr id="3" name="Notes Placeholder 2"/>
+          <p:cNvSpPr>
+            <a:spLocks noGrp="1"/>
+          </p:cNvSpPr>
+          <p:nvPr>
+            <p:ph type="body" idx="1"/>
+          </p:nvPr>
+        </p:nvSpPr>
+        <p:spPr/>
+        <p:txBody>
+          <a:bodyPr/>
+          <a:lstStyle/>
+          <a:p>
+            <a:r>
+              <a:rPr lang="en-US" dirty="0"/>
+              <a:t>[Backup — show only if siting or tasking questions come up in Q&amp;A. Second, independent example: this node's fixed camera flagged the plume with its production detector while the steerable camera studied canopy the same day. Tasking, not camera capability, is the gap the storm-mode controller closes.]</a:t>
+            </a:r>
+            <a:endParaRPr lang="en-US" dirty="0"/>
+          </a:p>
+        </p:txBody>
+      </p:sp>
+      <p:sp>
+        <p:nvSpPr>
+          <p:cNvPr id="4" name="Slide Number Placeholder 3"/>
+          <p:cNvSpPr>
+            <a:spLocks noGrp="1"/>
+          </p:cNvSpPr>
+          <p:nvPr>
+            <p:ph type="sldNum" sz="quarter" idx="10"/>
+          </p:nvPr>
+        </p:nvSpPr>
+        <p:spPr/>
+        <p:txBody>
+          <a:bodyPr/>
+          <a:lstStyle/>
+          <a:p>
+            <a:fld id="{F7021451-1387-4CA6-816F-3879F97B5CBC}" type="slidenum">
+              <a:rPr lang="en-US"/>
+              <a:t>12</a:t>
             </a:fld>
             <a:endParaRPr lang="en-US"/>
           </a:p>
@@ -3122,6 +3211,1526 @@
                 <a:ea typeface="Arial" pitchFamily="34" charset="-122"/>
                 <a:cs typeface="Arial" pitchFamily="34" charset="-120"/>
               </a:rPr>
+              <a:t>TARGET OPERATING CONCEPT</a:t>
+            </a:r>
+            <a:endParaRPr lang="en-US" sz="1300" dirty="0"/>
+          </a:p>
+        </p:txBody>
+      </p:sp>
+      <p:sp>
+        <p:nvSpPr>
+          <p:cNvPr id="3" name="Text 1"/>
+          <p:cNvSpPr/>
+          <p:nvPr/>
+        </p:nvSpPr>
+        <p:spPr>
+          <a:xfrm>
+            <a:off x="502920" y="566928"/>
+            <a:ext cx="11183112" cy="640080"/>
+          </a:xfrm>
+          <a:prstGeom prst="rect">
+            <a:avLst/>
+          </a:prstGeom>
+          <a:noFill/>
+          <a:ln/>
+        </p:spPr>
+        <p:txBody>
+          <a:bodyPr wrap="square" lIns="0" tIns="0" rIns="0" bIns="0" rtlCol="0" anchor="ctr"/>
+          <a:lstStyle/>
+          <a:p>
+            <a:pPr indent="0" marL="0">
+              <a:buNone/>
+            </a:pPr>
+            <a:r>
+              <a:rPr lang="en-US" sz="3200" b="1" dirty="0">
+                <a:solidFill>
+                  <a:srgbClr val="F5F7FA"/>
+                </a:solidFill>
+                <a:latin typeface="Arial" pitchFamily="34" charset="0"/>
+                <a:ea typeface="Arial" pitchFamily="34" charset="-122"/>
+                <a:cs typeface="Arial" pitchFamily="34" charset="-120"/>
+              </a:rPr>
+              <a:t>Flow of state: from quiet skies to a verified alert</a:t>
+            </a:r>
+            <a:endParaRPr lang="en-US" sz="3200" dirty="0"/>
+          </a:p>
+        </p:txBody>
+      </p:sp>
+      <p:sp>
+        <p:nvSpPr>
+          <p:cNvPr id="4" name="Shape 2"/>
+          <p:cNvSpPr/>
+          <p:nvPr/>
+        </p:nvSpPr>
+        <p:spPr>
+          <a:xfrm>
+            <a:off x="502920" y="1325880"/>
+            <a:ext cx="3246120" cy="4681728"/>
+          </a:xfrm>
+          <a:prstGeom prst="roundRect">
+            <a:avLst>
+              <a:gd name="adj" fmla="val 2817"/>
+            </a:avLst>
+          </a:prstGeom>
+          <a:solidFill>
+            <a:srgbClr val="1D2740"/>
+          </a:solidFill>
+          <a:ln w="19050">
+            <a:solidFill>
+              <a:srgbClr val="2A78D6"/>
+            </a:solidFill>
+            <a:prstDash val="solid"/>
+          </a:ln>
+        </p:spPr>
+      </p:sp>
+      <p:sp>
+        <p:nvSpPr>
+          <p:cNvPr id="5" name="Text 3"/>
+          <p:cNvSpPr/>
+          <p:nvPr/>
+        </p:nvSpPr>
+        <p:spPr>
+          <a:xfrm>
+            <a:off x="667512" y="1463040"/>
+            <a:ext cx="2926080" cy="457200"/>
+          </a:xfrm>
+          <a:prstGeom prst="rect">
+            <a:avLst/>
+          </a:prstGeom>
+          <a:noFill/>
+          <a:ln/>
+        </p:spPr>
+        <p:txBody>
+          <a:bodyPr wrap="square" lIns="0" tIns="0" rIns="0" bIns="0" rtlCol="0" anchor="ctr"/>
+          <a:lstStyle/>
+          <a:p>
+            <a:pPr indent="0" marL="0">
+              <a:buNone/>
+            </a:pPr>
+            <a:r>
+              <a:rPr lang="en-US" sz="1450" b="1" dirty="0">
+                <a:solidFill>
+                  <a:srgbClr val="8FB4E3"/>
+                </a:solidFill>
+                <a:latin typeface="Arial" pitchFamily="34" charset="0"/>
+                <a:ea typeface="Arial" pitchFamily="34" charset="-122"/>
+                <a:cs typeface="Arial" pitchFamily="34" charset="-120"/>
+              </a:rPr>
+              <a:t>Beehive cloud — orchestrator agent</a:t>
+            </a:r>
+            <a:endParaRPr lang="en-US" sz="1450" dirty="0"/>
+          </a:p>
+        </p:txBody>
+      </p:sp>
+      <p:sp>
+        <p:nvSpPr>
+          <p:cNvPr id="6" name="Text 4"/>
+          <p:cNvSpPr/>
+          <p:nvPr/>
+        </p:nvSpPr>
+        <p:spPr>
+          <a:xfrm>
+            <a:off x="667512" y="1938528"/>
+            <a:ext cx="2926080" cy="868680"/>
+          </a:xfrm>
+          <a:prstGeom prst="rect">
+            <a:avLst/>
+          </a:prstGeom>
+          <a:noFill/>
+          <a:ln/>
+        </p:spPr>
+        <p:txBody>
+          <a:bodyPr wrap="square" lIns="0" tIns="0" rIns="0" bIns="0" rtlCol="0" anchor="ctr"/>
+          <a:lstStyle/>
+          <a:p>
+            <a:pPr indent="0" marL="0">
+              <a:lnSpc>
+                <a:spcPct val="112000"/>
+              </a:lnSpc>
+              <a:buNone/>
+            </a:pPr>
+            <a:r>
+              <a:rPr lang="en-US" sz="1000" dirty="0">
+                <a:solidFill>
+                  <a:srgbClr val="C9D4E6"/>
+                </a:solidFill>
+                <a:latin typeface="Arial" pitchFamily="34" charset="0"/>
+                <a:ea typeface="Arial" pitchFamily="34" charset="-122"/>
+                <a:cs typeface="Arial" pitchFamily="34" charset="-120"/>
+              </a:rPr>
+              <a:t>A more capable LLM (large language model) agent runs where Sage already connects every node — it moves nodes between states; the nodes stay deterministic.</a:t>
+            </a:r>
+            <a:endParaRPr lang="en-US" sz="1000" dirty="0"/>
+          </a:p>
+        </p:txBody>
+      </p:sp>
+      <p:sp>
+        <p:nvSpPr>
+          <p:cNvPr id="7" name="Shape 5"/>
+          <p:cNvSpPr/>
+          <p:nvPr/>
+        </p:nvSpPr>
+        <p:spPr>
+          <a:xfrm>
+            <a:off x="667512" y="2907792"/>
+            <a:ext cx="2926080" cy="749808"/>
+          </a:xfrm>
+          <a:prstGeom prst="roundRect">
+            <a:avLst>
+              <a:gd name="adj" fmla="val 8537"/>
+            </a:avLst>
+          </a:prstGeom>
+          <a:solidFill>
+            <a:srgbClr val="101625"/>
+          </a:solidFill>
+          <a:ln w="9525">
+            <a:solidFill>
+              <a:srgbClr val="3A4762"/>
+            </a:solidFill>
+            <a:prstDash val="solid"/>
+          </a:ln>
+        </p:spPr>
+      </p:sp>
+      <p:sp>
+        <p:nvSpPr>
+          <p:cNvPr id="8" name="Text 6"/>
+          <p:cNvSpPr/>
+          <p:nvPr/>
+        </p:nvSpPr>
+        <p:spPr>
+          <a:xfrm>
+            <a:off x="777240" y="2962656"/>
+            <a:ext cx="2724912" cy="658368"/>
+          </a:xfrm>
+          <a:prstGeom prst="rect">
+            <a:avLst/>
+          </a:prstGeom>
+          <a:noFill/>
+          <a:ln/>
+        </p:spPr>
+        <p:txBody>
+          <a:bodyPr wrap="square" lIns="0" tIns="0" rIns="0" bIns="0" rtlCol="0" anchor="t"/>
+          <a:lstStyle/>
+          <a:p>
+            <a:pPr indent="0" marL="0">
+              <a:lnSpc>
+                <a:spcPct val="108000"/>
+              </a:lnSpc>
+              <a:buNone/>
+            </a:pPr>
+            <a:r>
+              <a:rPr lang="en-US" sz="1050" b="1" dirty="0">
+                <a:solidFill>
+                  <a:srgbClr val="F5F7FA"/>
+                </a:solidFill>
+                <a:latin typeface="Arial" pitchFamily="34" charset="0"/>
+                <a:ea typeface="Arial" pitchFamily="34" charset="-122"/>
+                <a:cs typeface="Arial" pitchFamily="34" charset="-120"/>
+              </a:rPr>
+              <a:t>Sees every node
+</a:t>
+            </a:r>
+            <a:pPr indent="0" marL="0">
+              <a:lnSpc>
+                <a:spcPct val="108000"/>
+              </a:lnSpc>
+              <a:buNone/>
+            </a:pPr>
+            <a:r>
+              <a:rPr lang="en-US" sz="900" dirty="0">
+                <a:solidFill>
+                  <a:srgbClr val="8A97B0"/>
+                </a:solidFill>
+                <a:latin typeface="Arial" pitchFamily="34" charset="0"/>
+                <a:ea typeface="Arial" pitchFamily="34" charset="-122"/>
+                <a:cs typeface="Arial" pitchFamily="34" charset="-120"/>
+              </a:rPr>
+              <a:t>telemetry, detections, camera frames, health — via the Beehive pipeline</a:t>
+            </a:r>
+            <a:endParaRPr lang="en-US" sz="1050" dirty="0"/>
+          </a:p>
+        </p:txBody>
+      </p:sp>
+      <p:sp>
+        <p:nvSpPr>
+          <p:cNvPr id="9" name="Shape 7"/>
+          <p:cNvSpPr/>
+          <p:nvPr/>
+        </p:nvSpPr>
+        <p:spPr>
+          <a:xfrm>
+            <a:off x="667512" y="3749040"/>
+            <a:ext cx="2926080" cy="749808"/>
+          </a:xfrm>
+          <a:prstGeom prst="roundRect">
+            <a:avLst>
+              <a:gd name="adj" fmla="val 8537"/>
+            </a:avLst>
+          </a:prstGeom>
+          <a:solidFill>
+            <a:srgbClr val="101625"/>
+          </a:solidFill>
+          <a:ln w="9525">
+            <a:solidFill>
+              <a:srgbClr val="3A4762"/>
+            </a:solidFill>
+            <a:prstDash val="solid"/>
+          </a:ln>
+        </p:spPr>
+      </p:sp>
+      <p:sp>
+        <p:nvSpPr>
+          <p:cNvPr id="10" name="Text 8"/>
+          <p:cNvSpPr/>
+          <p:nvPr/>
+        </p:nvSpPr>
+        <p:spPr>
+          <a:xfrm>
+            <a:off x="777240" y="3803904"/>
+            <a:ext cx="2724912" cy="658368"/>
+          </a:xfrm>
+          <a:prstGeom prst="rect">
+            <a:avLst/>
+          </a:prstGeom>
+          <a:noFill/>
+          <a:ln/>
+        </p:spPr>
+        <p:txBody>
+          <a:bodyPr wrap="square" lIns="0" tIns="0" rIns="0" bIns="0" rtlCol="0" anchor="t"/>
+          <a:lstStyle/>
+          <a:p>
+            <a:pPr indent="0" marL="0">
+              <a:lnSpc>
+                <a:spcPct val="108000"/>
+              </a:lnSpc>
+              <a:buNone/>
+            </a:pPr>
+            <a:r>
+              <a:rPr lang="en-US" sz="1050" b="1" dirty="0">
+                <a:solidFill>
+                  <a:srgbClr val="F5F7FA"/>
+                </a:solidFill>
+                <a:latin typeface="Arial" pitchFamily="34" charset="0"/>
+                <a:ea typeface="Arial" pitchFamily="34" charset="-122"/>
+                <a:cs typeface="Arial" pitchFamily="34" charset="-120"/>
+              </a:rPr>
+              <a:t>Sees the outside world
+</a:t>
+            </a:r>
+            <a:pPr indent="0" marL="0">
+              <a:lnSpc>
+                <a:spcPct val="108000"/>
+              </a:lnSpc>
+              <a:buNone/>
+            </a:pPr>
+            <a:r>
+              <a:rPr lang="en-US" sz="900" dirty="0">
+                <a:solidFill>
+                  <a:srgbClr val="8A97B0"/>
+                </a:solidFill>
+                <a:latin typeface="Arial" pitchFamily="34" charset="0"/>
+                <a:ea typeface="Arial" pitchFamily="34" charset="-122"/>
+                <a:cs typeface="Arial" pitchFamily="34" charset="-120"/>
+              </a:rPr>
+              <a:t>NASA Earthdata · Vaisala Xweather · National Weather Service · GOES satellites</a:t>
+            </a:r>
+            <a:endParaRPr lang="en-US" sz="1050" dirty="0"/>
+          </a:p>
+        </p:txBody>
+      </p:sp>
+      <p:sp>
+        <p:nvSpPr>
+          <p:cNvPr id="11" name="Shape 9"/>
+          <p:cNvSpPr/>
+          <p:nvPr/>
+        </p:nvSpPr>
+        <p:spPr>
+          <a:xfrm>
+            <a:off x="667512" y="4590288"/>
+            <a:ext cx="2926080" cy="749808"/>
+          </a:xfrm>
+          <a:prstGeom prst="roundRect">
+            <a:avLst>
+              <a:gd name="adj" fmla="val 8537"/>
+            </a:avLst>
+          </a:prstGeom>
+          <a:solidFill>
+            <a:srgbClr val="101625"/>
+          </a:solidFill>
+          <a:ln w="9525">
+            <a:solidFill>
+              <a:srgbClr val="3A4762"/>
+            </a:solidFill>
+            <a:prstDash val="solid"/>
+          </a:ln>
+        </p:spPr>
+      </p:sp>
+      <p:sp>
+        <p:nvSpPr>
+          <p:cNvPr id="12" name="Text 10"/>
+          <p:cNvSpPr/>
+          <p:nvPr/>
+        </p:nvSpPr>
+        <p:spPr>
+          <a:xfrm>
+            <a:off x="777240" y="4645152"/>
+            <a:ext cx="2724912" cy="658368"/>
+          </a:xfrm>
+          <a:prstGeom prst="rect">
+            <a:avLst/>
+          </a:prstGeom>
+          <a:noFill/>
+          <a:ln/>
+        </p:spPr>
+        <p:txBody>
+          <a:bodyPr wrap="square" lIns="0" tIns="0" rIns="0" bIns="0" rtlCol="0" anchor="t"/>
+          <a:lstStyle/>
+          <a:p>
+            <a:pPr indent="0" marL="0">
+              <a:lnSpc>
+                <a:spcPct val="108000"/>
+              </a:lnSpc>
+              <a:buNone/>
+            </a:pPr>
+            <a:r>
+              <a:rPr lang="en-US" sz="1050" b="1" dirty="0">
+                <a:solidFill>
+                  <a:srgbClr val="F5F7FA"/>
+                </a:solidFill>
+                <a:latin typeface="Arial" pitchFamily="34" charset="0"/>
+                <a:ea typeface="Arial" pitchFamily="34" charset="-122"/>
+                <a:cs typeface="Arial" pitchFamily="34" charset="-120"/>
+              </a:rPr>
+              <a:t>Directs, never dispatches
+</a:t>
+            </a:r>
+            <a:pPr indent="0" marL="0">
+              <a:lnSpc>
+                <a:spcPct val="108000"/>
+              </a:lnSpc>
+              <a:buNone/>
+            </a:pPr>
+            <a:r>
+              <a:rPr lang="en-US" sz="900" dirty="0">
+                <a:solidFill>
+                  <a:srgbClr val="8A97B0"/>
+                </a:solidFill>
+                <a:latin typeface="Arial" pitchFamily="34" charset="0"/>
+                <a:ea typeface="Arial" pitchFamily="34" charset="-122"/>
+                <a:cs typeface="Arial" pitchFamily="34" charset="-120"/>
+              </a:rPr>
+              <a:t>chooses node states and cameras; every action logged</a:t>
+            </a:r>
+            <a:endParaRPr lang="en-US" sz="1050" dirty="0"/>
+          </a:p>
+        </p:txBody>
+      </p:sp>
+      <p:sp>
+        <p:nvSpPr>
+          <p:cNvPr id="13" name="Text 11"/>
+          <p:cNvSpPr/>
+          <p:nvPr/>
+        </p:nvSpPr>
+        <p:spPr>
+          <a:xfrm>
+            <a:off x="667512" y="5486400"/>
+            <a:ext cx="2926080" cy="457200"/>
+          </a:xfrm>
+          <a:prstGeom prst="rect">
+            <a:avLst/>
+          </a:prstGeom>
+          <a:noFill/>
+          <a:ln/>
+        </p:spPr>
+        <p:txBody>
+          <a:bodyPr wrap="square" lIns="0" tIns="0" rIns="0" bIns="0" rtlCol="0" anchor="ctr"/>
+          <a:lstStyle/>
+          <a:p>
+            <a:pPr indent="0" marL="0">
+              <a:buNone/>
+            </a:pPr>
+            <a:r>
+              <a:rPr lang="en-US" sz="850" i="1" dirty="0">
+                <a:solidFill>
+                  <a:srgbClr val="8A97B0"/>
+                </a:solidFill>
+                <a:latin typeface="Arial" pitchFamily="34" charset="0"/>
+                <a:ea typeface="Arial" pitchFamily="34" charset="-122"/>
+                <a:cs typeface="Arial" pitchFamily="34" charset="-120"/>
+              </a:rPr>
+              <a:t>The orchestrator supervises every state at right and can advance or reset the flow at any time.</a:t>
+            </a:r>
+            <a:endParaRPr lang="en-US" sz="850" dirty="0"/>
+          </a:p>
+        </p:txBody>
+      </p:sp>
+      <p:sp>
+        <p:nvSpPr>
+          <p:cNvPr id="14" name="Shape 12"/>
+          <p:cNvSpPr/>
+          <p:nvPr/>
+        </p:nvSpPr>
+        <p:spPr>
+          <a:xfrm>
+            <a:off x="4023360" y="1325880"/>
+            <a:ext cx="7662672" cy="731520"/>
+          </a:xfrm>
+          <a:prstGeom prst="roundRect">
+            <a:avLst>
+              <a:gd name="adj" fmla="val 11250"/>
+            </a:avLst>
+          </a:prstGeom>
+          <a:solidFill>
+            <a:srgbClr val="1D2740"/>
+          </a:solidFill>
+          <a:ln w="19050">
+            <a:solidFill>
+              <a:srgbClr val="566180"/>
+            </a:solidFill>
+            <a:prstDash val="solid"/>
+          </a:ln>
+        </p:spPr>
+      </p:sp>
+      <p:sp>
+        <p:nvSpPr>
+          <p:cNvPr id="15" name="Shape 13"/>
+          <p:cNvSpPr/>
+          <p:nvPr/>
+        </p:nvSpPr>
+        <p:spPr>
+          <a:xfrm>
+            <a:off x="4187952" y="1527048"/>
+            <a:ext cx="329184" cy="329184"/>
+          </a:xfrm>
+          <a:prstGeom prst="ellipse">
+            <a:avLst/>
+          </a:prstGeom>
+          <a:solidFill>
+            <a:srgbClr val="101625"/>
+          </a:solidFill>
+          <a:ln w="19050">
+            <a:solidFill>
+              <a:srgbClr val="566180"/>
+            </a:solidFill>
+            <a:prstDash val="solid"/>
+          </a:ln>
+        </p:spPr>
+      </p:sp>
+      <p:sp>
+        <p:nvSpPr>
+          <p:cNvPr id="16" name="Text 14"/>
+          <p:cNvSpPr/>
+          <p:nvPr/>
+        </p:nvSpPr>
+        <p:spPr>
+          <a:xfrm>
+            <a:off x="4187952" y="1527048"/>
+            <a:ext cx="329184" cy="329184"/>
+          </a:xfrm>
+          <a:prstGeom prst="rect">
+            <a:avLst/>
+          </a:prstGeom>
+          <a:noFill/>
+          <a:ln/>
+        </p:spPr>
+        <p:txBody>
+          <a:bodyPr wrap="square" lIns="0" tIns="0" rIns="0" bIns="0" rtlCol="0" anchor="ctr"/>
+          <a:lstStyle/>
+          <a:p>
+            <a:pPr algn="ctr" indent="0" marL="0">
+              <a:buNone/>
+            </a:pPr>
+            <a:r>
+              <a:rPr lang="en-US" sz="1300" b="1" dirty="0">
+                <a:solidFill>
+                  <a:srgbClr val="8A97B0"/>
+                </a:solidFill>
+                <a:latin typeface="Arial" pitchFamily="34" charset="0"/>
+                <a:ea typeface="Arial" pitchFamily="34" charset="-122"/>
+                <a:cs typeface="Arial" pitchFamily="34" charset="-120"/>
+              </a:rPr>
+              <a:t>1</a:t>
+            </a:r>
+            <a:endParaRPr lang="en-US" sz="1300" dirty="0"/>
+          </a:p>
+        </p:txBody>
+      </p:sp>
+      <p:sp>
+        <p:nvSpPr>
+          <p:cNvPr id="17" name="Text 15"/>
+          <p:cNvSpPr/>
+          <p:nvPr/>
+        </p:nvSpPr>
+        <p:spPr>
+          <a:xfrm>
+            <a:off x="4681728" y="1389888"/>
+            <a:ext cx="6858000" cy="621792"/>
+          </a:xfrm>
+          <a:prstGeom prst="rect">
+            <a:avLst/>
+          </a:prstGeom>
+          <a:noFill/>
+          <a:ln/>
+        </p:spPr>
+        <p:txBody>
+          <a:bodyPr wrap="square" lIns="0" tIns="0" rIns="0" bIns="0" rtlCol="0" anchor="t"/>
+          <a:lstStyle/>
+          <a:p>
+            <a:pPr indent="0" marL="0">
+              <a:lnSpc>
+                <a:spcPct val="108000"/>
+              </a:lnSpc>
+              <a:buNone/>
+            </a:pPr>
+            <a:r>
+              <a:rPr lang="en-US" sz="1300" b="1" dirty="0">
+                <a:solidFill>
+                  <a:srgbClr val="F5F7FA"/>
+                </a:solidFill>
+                <a:latin typeface="Arial" pitchFamily="34" charset="0"/>
+                <a:ea typeface="Arial" pitchFamily="34" charset="-122"/>
+                <a:cs typeface="Arial" pitchFamily="34" charset="-120"/>
+              </a:rPr>
+              <a:t>Quiet watch
+</a:t>
+            </a:r>
+            <a:pPr indent="0" marL="0">
+              <a:lnSpc>
+                <a:spcPct val="108000"/>
+              </a:lnSpc>
+              <a:buNone/>
+            </a:pPr>
+            <a:r>
+              <a:rPr lang="en-US" sz="950" dirty="0">
+                <a:solidFill>
+                  <a:srgbClr val="C9D4E6"/>
+                </a:solidFill>
+                <a:latin typeface="Arial" pitchFamily="34" charset="0"/>
+                <a:ea typeface="Arial" pitchFamily="34" charset="-122"/>
+                <a:cs typeface="Arial" pitchFamily="34" charset="-120"/>
+              </a:rPr>
+              <a:t>Normal snapshot schedules; the orchestrator tracks forecasts and radar for every node's neighborhood.</a:t>
+            </a:r>
+            <a:endParaRPr lang="en-US" sz="1300" dirty="0"/>
+          </a:p>
+        </p:txBody>
+      </p:sp>
+      <p:sp>
+        <p:nvSpPr>
+          <p:cNvPr id="18" name="Text 16"/>
+          <p:cNvSpPr/>
+          <p:nvPr/>
+        </p:nvSpPr>
+        <p:spPr>
+          <a:xfrm>
+            <a:off x="4343400" y="2057400"/>
+            <a:ext cx="7223760" cy="256032"/>
+          </a:xfrm>
+          <a:prstGeom prst="rect">
+            <a:avLst/>
+          </a:prstGeom>
+          <a:noFill/>
+          <a:ln/>
+        </p:spPr>
+        <p:txBody>
+          <a:bodyPr wrap="square" lIns="0" tIns="0" rIns="0" bIns="0" rtlCol="0" anchor="ctr"/>
+          <a:lstStyle/>
+          <a:p>
+            <a:pPr indent="0" marL="0">
+              <a:buNone/>
+            </a:pPr>
+            <a:r>
+              <a:rPr lang="en-US" sz="1200" dirty="0">
+                <a:solidFill>
+                  <a:srgbClr val="8A97B0"/>
+                </a:solidFill>
+                <a:latin typeface="Arial" pitchFamily="34" charset="0"/>
+                <a:ea typeface="Arial" pitchFamily="34" charset="-122"/>
+                <a:cs typeface="Arial" pitchFamily="34" charset="-120"/>
+              </a:rPr>
+              <a:t>↓   </a:t>
+            </a:r>
+            <a:pPr indent="0" marL="0">
+              <a:buNone/>
+            </a:pPr>
+            <a:r>
+              <a:rPr lang="en-US" sz="1000" i="1" dirty="0">
+                <a:solidFill>
+                  <a:srgbClr val="FAB219"/>
+                </a:solidFill>
+                <a:latin typeface="Arial" pitchFamily="34" charset="0"/>
+                <a:ea typeface="Arial" pitchFamily="34" charset="-122"/>
+                <a:cs typeface="Arial" pitchFamily="34" charset="-120"/>
+              </a:rPr>
+              <a:t>weather conditions suggest lightning near a group of nodes</a:t>
+            </a:r>
+            <a:endParaRPr lang="en-US" sz="1200" dirty="0"/>
+          </a:p>
+        </p:txBody>
+      </p:sp>
+      <p:sp>
+        <p:nvSpPr>
+          <p:cNvPr id="19" name="Shape 17"/>
+          <p:cNvSpPr/>
+          <p:nvPr/>
+        </p:nvSpPr>
+        <p:spPr>
+          <a:xfrm>
+            <a:off x="4023360" y="2313432"/>
+            <a:ext cx="7662672" cy="731520"/>
+          </a:xfrm>
+          <a:prstGeom prst="roundRect">
+            <a:avLst>
+              <a:gd name="adj" fmla="val 11250"/>
+            </a:avLst>
+          </a:prstGeom>
+          <a:solidFill>
+            <a:srgbClr val="1D2740"/>
+          </a:solidFill>
+          <a:ln w="19050">
+            <a:solidFill>
+              <a:srgbClr val="1BAF7A"/>
+            </a:solidFill>
+            <a:prstDash val="solid"/>
+          </a:ln>
+        </p:spPr>
+      </p:sp>
+      <p:sp>
+        <p:nvSpPr>
+          <p:cNvPr id="20" name="Shape 18"/>
+          <p:cNvSpPr/>
+          <p:nvPr/>
+        </p:nvSpPr>
+        <p:spPr>
+          <a:xfrm>
+            <a:off x="4187952" y="2514600"/>
+            <a:ext cx="329184" cy="329184"/>
+          </a:xfrm>
+          <a:prstGeom prst="ellipse">
+            <a:avLst/>
+          </a:prstGeom>
+          <a:solidFill>
+            <a:srgbClr val="101625"/>
+          </a:solidFill>
+          <a:ln w="19050">
+            <a:solidFill>
+              <a:srgbClr val="1BAF7A"/>
+            </a:solidFill>
+            <a:prstDash val="solid"/>
+          </a:ln>
+        </p:spPr>
+      </p:sp>
+      <p:sp>
+        <p:nvSpPr>
+          <p:cNvPr id="21" name="Text 19"/>
+          <p:cNvSpPr/>
+          <p:nvPr/>
+        </p:nvSpPr>
+        <p:spPr>
+          <a:xfrm>
+            <a:off x="4187952" y="2514600"/>
+            <a:ext cx="329184" cy="329184"/>
+          </a:xfrm>
+          <a:prstGeom prst="rect">
+            <a:avLst/>
+          </a:prstGeom>
+          <a:noFill/>
+          <a:ln/>
+        </p:spPr>
+        <p:txBody>
+          <a:bodyPr wrap="square" lIns="0" tIns="0" rIns="0" bIns="0" rtlCol="0" anchor="ctr"/>
+          <a:lstStyle/>
+          <a:p>
+            <a:pPr algn="ctr" indent="0" marL="0">
+              <a:buNone/>
+            </a:pPr>
+            <a:r>
+              <a:rPr lang="en-US" sz="1300" b="1" dirty="0">
+                <a:solidFill>
+                  <a:srgbClr val="1BAF7A"/>
+                </a:solidFill>
+                <a:latin typeface="Arial" pitchFamily="34" charset="0"/>
+                <a:ea typeface="Arial" pitchFamily="34" charset="-122"/>
+                <a:cs typeface="Arial" pitchFamily="34" charset="-120"/>
+              </a:rPr>
+              <a:t>2</a:t>
+            </a:r>
+            <a:endParaRPr lang="en-US" sz="1300" dirty="0"/>
+          </a:p>
+        </p:txBody>
+      </p:sp>
+      <p:sp>
+        <p:nvSpPr>
+          <p:cNvPr id="22" name="Text 20"/>
+          <p:cNvSpPr/>
+          <p:nvPr/>
+        </p:nvSpPr>
+        <p:spPr>
+          <a:xfrm>
+            <a:off x="4681728" y="2377440"/>
+            <a:ext cx="6858000" cy="621792"/>
+          </a:xfrm>
+          <a:prstGeom prst="rect">
+            <a:avLst/>
+          </a:prstGeom>
+          <a:noFill/>
+          <a:ln/>
+        </p:spPr>
+        <p:txBody>
+          <a:bodyPr wrap="square" lIns="0" tIns="0" rIns="0" bIns="0" rtlCol="0" anchor="t"/>
+          <a:lstStyle/>
+          <a:p>
+            <a:pPr indent="0" marL="0">
+              <a:lnSpc>
+                <a:spcPct val="108000"/>
+              </a:lnSpc>
+              <a:buNone/>
+            </a:pPr>
+            <a:r>
+              <a:rPr lang="en-US" sz="1300" b="1" dirty="0">
+                <a:solidFill>
+                  <a:srgbClr val="F5F7FA"/>
+                </a:solidFill>
+                <a:latin typeface="Arial" pitchFamily="34" charset="0"/>
+                <a:ea typeface="Arial" pitchFamily="34" charset="-122"/>
+                <a:cs typeface="Arial" pitchFamily="34" charset="-120"/>
+              </a:rPr>
+              <a:t>Always-on capture
+</a:t>
+            </a:r>
+            <a:pPr indent="0" marL="0">
+              <a:lnSpc>
+                <a:spcPct val="108000"/>
+              </a:lnSpc>
+              <a:buNone/>
+            </a:pPr>
+            <a:r>
+              <a:rPr lang="en-US" sz="950" dirty="0">
+                <a:solidFill>
+                  <a:srgbClr val="C9D4E6"/>
+                </a:solidFill>
+                <a:latin typeface="Arial" pitchFamily="34" charset="0"/>
+                <a:ea typeface="Arial" pitchFamily="34" charset="-122"/>
+                <a:cs typeface="Arial" pitchFamily="34" charset="-120"/>
+              </a:rPr>
+              <a:t>Cameras, microphones, and the SDR (software-defined radio) lightning sensor record continuously on the affected nodes.</a:t>
+            </a:r>
+            <a:endParaRPr lang="en-US" sz="1300" dirty="0"/>
+          </a:p>
+        </p:txBody>
+      </p:sp>
+      <p:sp>
+        <p:nvSpPr>
+          <p:cNvPr id="23" name="Text 21"/>
+          <p:cNvSpPr/>
+          <p:nvPr/>
+        </p:nvSpPr>
+        <p:spPr>
+          <a:xfrm>
+            <a:off x="4343400" y="3044952"/>
+            <a:ext cx="7223760" cy="256032"/>
+          </a:xfrm>
+          <a:prstGeom prst="rect">
+            <a:avLst/>
+          </a:prstGeom>
+          <a:noFill/>
+          <a:ln/>
+        </p:spPr>
+        <p:txBody>
+          <a:bodyPr wrap="square" lIns="0" tIns="0" rIns="0" bIns="0" rtlCol="0" anchor="ctr"/>
+          <a:lstStyle/>
+          <a:p>
+            <a:pPr indent="0" marL="0">
+              <a:buNone/>
+            </a:pPr>
+            <a:r>
+              <a:rPr lang="en-US" sz="1200" dirty="0">
+                <a:solidFill>
+                  <a:srgbClr val="8A97B0"/>
+                </a:solidFill>
+                <a:latin typeface="Arial" pitchFamily="34" charset="0"/>
+                <a:ea typeface="Arial" pitchFamily="34" charset="-122"/>
+                <a:cs typeface="Arial" pitchFamily="34" charset="-120"/>
+              </a:rPr>
+              <a:t>↓   </a:t>
+            </a:r>
+            <a:pPr indent="0" marL="0">
+              <a:buNone/>
+            </a:pPr>
+            <a:r>
+              <a:rPr lang="en-US" sz="1000" i="1" dirty="0">
+                <a:solidFill>
+                  <a:srgbClr val="FAB219"/>
+                </a:solidFill>
+                <a:latin typeface="Arial" pitchFamily="34" charset="0"/>
+                <a:ea typeface="Arial" pitchFamily="34" charset="-122"/>
+                <a:cs typeface="Arial" pitchFamily="34" charset="-120"/>
+              </a:rPr>
+              <a:t>SDR registers a positive strike AND enough nodes sit within listening range</a:t>
+            </a:r>
+            <a:endParaRPr lang="en-US" sz="1200" dirty="0"/>
+          </a:p>
+        </p:txBody>
+      </p:sp>
+      <p:sp>
+        <p:nvSpPr>
+          <p:cNvPr id="24" name="Shape 22"/>
+          <p:cNvSpPr/>
+          <p:nvPr/>
+        </p:nvSpPr>
+        <p:spPr>
+          <a:xfrm>
+            <a:off x="4023360" y="3300984"/>
+            <a:ext cx="7662672" cy="731520"/>
+          </a:xfrm>
+          <a:prstGeom prst="roundRect">
+            <a:avLst>
+              <a:gd name="adj" fmla="val 11250"/>
+            </a:avLst>
+          </a:prstGeom>
+          <a:solidFill>
+            <a:srgbClr val="1D2740"/>
+          </a:solidFill>
+          <a:ln w="19050">
+            <a:solidFill>
+              <a:srgbClr val="FAB219"/>
+            </a:solidFill>
+            <a:prstDash val="solid"/>
+          </a:ln>
+        </p:spPr>
+      </p:sp>
+      <p:sp>
+        <p:nvSpPr>
+          <p:cNvPr id="25" name="Shape 23"/>
+          <p:cNvSpPr/>
+          <p:nvPr/>
+        </p:nvSpPr>
+        <p:spPr>
+          <a:xfrm>
+            <a:off x="4187952" y="3502152"/>
+            <a:ext cx="329184" cy="329184"/>
+          </a:xfrm>
+          <a:prstGeom prst="ellipse">
+            <a:avLst/>
+          </a:prstGeom>
+          <a:solidFill>
+            <a:srgbClr val="101625"/>
+          </a:solidFill>
+          <a:ln w="19050">
+            <a:solidFill>
+              <a:srgbClr val="FAB219"/>
+            </a:solidFill>
+            <a:prstDash val="solid"/>
+          </a:ln>
+        </p:spPr>
+      </p:sp>
+      <p:sp>
+        <p:nvSpPr>
+          <p:cNvPr id="26" name="Text 24"/>
+          <p:cNvSpPr/>
+          <p:nvPr/>
+        </p:nvSpPr>
+        <p:spPr>
+          <a:xfrm>
+            <a:off x="4187952" y="3502152"/>
+            <a:ext cx="329184" cy="329184"/>
+          </a:xfrm>
+          <a:prstGeom prst="rect">
+            <a:avLst/>
+          </a:prstGeom>
+          <a:noFill/>
+          <a:ln/>
+        </p:spPr>
+        <p:txBody>
+          <a:bodyPr wrap="square" lIns="0" tIns="0" rIns="0" bIns="0" rtlCol="0" anchor="ctr"/>
+          <a:lstStyle/>
+          <a:p>
+            <a:pPr algn="ctr" indent="0" marL="0">
+              <a:buNone/>
+            </a:pPr>
+            <a:r>
+              <a:rPr lang="en-US" sz="1300" b="1" dirty="0">
+                <a:solidFill>
+                  <a:srgbClr val="FAB219"/>
+                </a:solidFill>
+                <a:latin typeface="Arial" pitchFamily="34" charset="0"/>
+                <a:ea typeface="Arial" pitchFamily="34" charset="-122"/>
+                <a:cs typeface="Arial" pitchFamily="34" charset="-120"/>
+              </a:rPr>
+              <a:t>3</a:t>
+            </a:r>
+            <a:endParaRPr lang="en-US" sz="1300" dirty="0"/>
+          </a:p>
+        </p:txBody>
+      </p:sp>
+      <p:sp>
+        <p:nvSpPr>
+          <p:cNvPr id="27" name="Text 25"/>
+          <p:cNvSpPr/>
+          <p:nvPr/>
+        </p:nvSpPr>
+        <p:spPr>
+          <a:xfrm>
+            <a:off x="4681728" y="3364992"/>
+            <a:ext cx="6858000" cy="621792"/>
+          </a:xfrm>
+          <a:prstGeom prst="rect">
+            <a:avLst/>
+          </a:prstGeom>
+          <a:noFill/>
+          <a:ln/>
+        </p:spPr>
+        <p:txBody>
+          <a:bodyPr wrap="square" lIns="0" tIns="0" rIns="0" bIns="0" rtlCol="0" anchor="t"/>
+          <a:lstStyle/>
+          <a:p>
+            <a:pPr indent="0" marL="0">
+              <a:lnSpc>
+                <a:spcPct val="108000"/>
+              </a:lnSpc>
+              <a:buNone/>
+            </a:pPr>
+            <a:r>
+              <a:rPr lang="en-US" sz="1300" b="1" dirty="0">
+                <a:solidFill>
+                  <a:srgbClr val="F5F7FA"/>
+                </a:solidFill>
+                <a:latin typeface="Arial" pitchFamily="34" charset="0"/>
+                <a:ea typeface="Arial" pitchFamily="34" charset="-122"/>
+                <a:cs typeface="Arial" pitchFamily="34" charset="-120"/>
+              </a:rPr>
+              <a:t>Strike triangulated
+</a:t>
+            </a:r>
+            <a:pPr indent="0" marL="0">
+              <a:lnSpc>
+                <a:spcPct val="108000"/>
+              </a:lnSpc>
+              <a:buNone/>
+            </a:pPr>
+            <a:r>
+              <a:rPr lang="en-US" sz="950" dirty="0">
+                <a:solidFill>
+                  <a:srgbClr val="C9D4E6"/>
+                </a:solidFill>
+                <a:latin typeface="Arial" pitchFamily="34" charset="0"/>
+                <a:ea typeface="Arial" pitchFamily="34" charset="-122"/>
+                <a:cs typeface="Arial" pitchFamily="34" charset="-120"/>
+              </a:rPr>
+              <a:t>The strike's radio pulse gives every node the same start-of-clock; thunder delays give distances that cross at the strike.</a:t>
+            </a:r>
+            <a:endParaRPr lang="en-US" sz="1300" dirty="0"/>
+          </a:p>
+        </p:txBody>
+      </p:sp>
+      <p:sp>
+        <p:nvSpPr>
+          <p:cNvPr id="28" name="Text 26"/>
+          <p:cNvSpPr/>
+          <p:nvPr/>
+        </p:nvSpPr>
+        <p:spPr>
+          <a:xfrm>
+            <a:off x="4343400" y="4032504"/>
+            <a:ext cx="7223760" cy="256032"/>
+          </a:xfrm>
+          <a:prstGeom prst="rect">
+            <a:avLst/>
+          </a:prstGeom>
+          <a:noFill/>
+          <a:ln/>
+        </p:spPr>
+        <p:txBody>
+          <a:bodyPr wrap="square" lIns="0" tIns="0" rIns="0" bIns="0" rtlCol="0" anchor="ctr"/>
+          <a:lstStyle/>
+          <a:p>
+            <a:pPr indent="0" marL="0">
+              <a:buNone/>
+            </a:pPr>
+            <a:r>
+              <a:rPr lang="en-US" sz="1200" dirty="0">
+                <a:solidFill>
+                  <a:srgbClr val="8A97B0"/>
+                </a:solidFill>
+                <a:latin typeface="Arial" pitchFamily="34" charset="0"/>
+                <a:ea typeface="Arial" pitchFamily="34" charset="-122"/>
+                <a:cs typeface="Arial" pitchFamily="34" charset="-120"/>
+              </a:rPr>
+              <a:t>↓   </a:t>
+            </a:r>
+            <a:pPr indent="0" marL="0">
+              <a:buNone/>
+            </a:pPr>
+            <a:r>
+              <a:rPr lang="en-US" sz="1000" i="1" dirty="0">
+                <a:solidFill>
+                  <a:srgbClr val="FAB219"/>
+                </a:solidFill>
+                <a:latin typeface="Arial" pitchFamily="34" charset="0"/>
+                <a:ea typeface="Arial" pitchFamily="34" charset="-122"/>
+                <a:cs typeface="Arial" pitchFamily="34" charset="-120"/>
+              </a:rPr>
+              <a:t>location fixed — the orchestrator picks the best-placed camera</a:t>
+            </a:r>
+            <a:endParaRPr lang="en-US" sz="1200" dirty="0"/>
+          </a:p>
+        </p:txBody>
+      </p:sp>
+      <p:sp>
+        <p:nvSpPr>
+          <p:cNvPr id="29" name="Shape 27"/>
+          <p:cNvSpPr/>
+          <p:nvPr/>
+        </p:nvSpPr>
+        <p:spPr>
+          <a:xfrm>
+            <a:off x="4023360" y="4288536"/>
+            <a:ext cx="7662672" cy="731520"/>
+          </a:xfrm>
+          <a:prstGeom prst="roundRect">
+            <a:avLst>
+              <a:gd name="adj" fmla="val 11250"/>
+            </a:avLst>
+          </a:prstGeom>
+          <a:solidFill>
+            <a:srgbClr val="1D2740"/>
+          </a:solidFill>
+          <a:ln w="19050">
+            <a:solidFill>
+              <a:srgbClr val="EB6834"/>
+            </a:solidFill>
+            <a:prstDash val="solid"/>
+          </a:ln>
+        </p:spPr>
+      </p:sp>
+      <p:sp>
+        <p:nvSpPr>
+          <p:cNvPr id="30" name="Shape 28"/>
+          <p:cNvSpPr/>
+          <p:nvPr/>
+        </p:nvSpPr>
+        <p:spPr>
+          <a:xfrm>
+            <a:off x="4187952" y="4489704"/>
+            <a:ext cx="329184" cy="329184"/>
+          </a:xfrm>
+          <a:prstGeom prst="ellipse">
+            <a:avLst/>
+          </a:prstGeom>
+          <a:solidFill>
+            <a:srgbClr val="101625"/>
+          </a:solidFill>
+          <a:ln w="19050">
+            <a:solidFill>
+              <a:srgbClr val="EB6834"/>
+            </a:solidFill>
+            <a:prstDash val="solid"/>
+          </a:ln>
+        </p:spPr>
+      </p:sp>
+      <p:sp>
+        <p:nvSpPr>
+          <p:cNvPr id="31" name="Text 29"/>
+          <p:cNvSpPr/>
+          <p:nvPr/>
+        </p:nvSpPr>
+        <p:spPr>
+          <a:xfrm>
+            <a:off x="4187952" y="4489704"/>
+            <a:ext cx="329184" cy="329184"/>
+          </a:xfrm>
+          <a:prstGeom prst="rect">
+            <a:avLst/>
+          </a:prstGeom>
+          <a:noFill/>
+          <a:ln/>
+        </p:spPr>
+        <p:txBody>
+          <a:bodyPr wrap="square" lIns="0" tIns="0" rIns="0" bIns="0" rtlCol="0" anchor="ctr"/>
+          <a:lstStyle/>
+          <a:p>
+            <a:pPr algn="ctr" indent="0" marL="0">
+              <a:buNone/>
+            </a:pPr>
+            <a:r>
+              <a:rPr lang="en-US" sz="1300" b="1" dirty="0">
+                <a:solidFill>
+                  <a:srgbClr val="EB6834"/>
+                </a:solidFill>
+                <a:latin typeface="Arial" pitchFamily="34" charset="0"/>
+                <a:ea typeface="Arial" pitchFamily="34" charset="-122"/>
+                <a:cs typeface="Arial" pitchFamily="34" charset="-120"/>
+              </a:rPr>
+              <a:t>4</a:t>
+            </a:r>
+            <a:endParaRPr lang="en-US" sz="1300" dirty="0"/>
+          </a:p>
+        </p:txBody>
+      </p:sp>
+      <p:sp>
+        <p:nvSpPr>
+          <p:cNvPr id="32" name="Text 30"/>
+          <p:cNvSpPr/>
+          <p:nvPr/>
+        </p:nvSpPr>
+        <p:spPr>
+          <a:xfrm>
+            <a:off x="4681728" y="4352544"/>
+            <a:ext cx="6858000" cy="621792"/>
+          </a:xfrm>
+          <a:prstGeom prst="rect">
+            <a:avLst/>
+          </a:prstGeom>
+          <a:noFill/>
+          <a:ln/>
+        </p:spPr>
+        <p:txBody>
+          <a:bodyPr wrap="square" lIns="0" tIns="0" rIns="0" bIns="0" rtlCol="0" anchor="t"/>
+          <a:lstStyle/>
+          <a:p>
+            <a:pPr indent="0" marL="0">
+              <a:lnSpc>
+                <a:spcPct val="108000"/>
+              </a:lnSpc>
+              <a:buNone/>
+            </a:pPr>
+            <a:r>
+              <a:rPr lang="en-US" sz="1300" b="1" dirty="0">
+                <a:solidFill>
+                  <a:srgbClr val="F5F7FA"/>
+                </a:solidFill>
+                <a:latin typeface="Arial" pitchFamily="34" charset="0"/>
+                <a:ea typeface="Arial" pitchFamily="34" charset="-122"/>
+                <a:cs typeface="Arial" pitchFamily="34" charset="-120"/>
+              </a:rPr>
+              <a:t>Smoke watch
+</a:t>
+            </a:r>
+            <a:pPr indent="0" marL="0">
+              <a:lnSpc>
+                <a:spcPct val="108000"/>
+              </a:lnSpc>
+              <a:buNone/>
+            </a:pPr>
+            <a:r>
+              <a:rPr lang="en-US" sz="950" dirty="0">
+                <a:solidFill>
+                  <a:srgbClr val="C9D4E6"/>
+                </a:solidFill>
+                <a:latin typeface="Arial" pitchFamily="34" charset="0"/>
+                <a:ea typeface="Arial" pitchFamily="34" charset="-122"/>
+                <a:cs typeface="Arial" pitchFamily="34" charset="-120"/>
+              </a:rPr>
+              <a:t>A PTZ (pan-tilt-zoom) camera with a horizon view aims at the strike sector; the smoke agent revisits through the holdover window.</a:t>
+            </a:r>
+            <a:endParaRPr lang="en-US" sz="1300" dirty="0"/>
+          </a:p>
+        </p:txBody>
+      </p:sp>
+      <p:sp>
+        <p:nvSpPr>
+          <p:cNvPr id="33" name="Text 31"/>
+          <p:cNvSpPr/>
+          <p:nvPr/>
+        </p:nvSpPr>
+        <p:spPr>
+          <a:xfrm>
+            <a:off x="4343400" y="5020056"/>
+            <a:ext cx="7223760" cy="256032"/>
+          </a:xfrm>
+          <a:prstGeom prst="rect">
+            <a:avLst/>
+          </a:prstGeom>
+          <a:noFill/>
+          <a:ln/>
+        </p:spPr>
+        <p:txBody>
+          <a:bodyPr wrap="square" lIns="0" tIns="0" rIns="0" bIns="0" rtlCol="0" anchor="ctr"/>
+          <a:lstStyle/>
+          <a:p>
+            <a:pPr indent="0" marL="0">
+              <a:buNone/>
+            </a:pPr>
+            <a:r>
+              <a:rPr lang="en-US" sz="1200" dirty="0">
+                <a:solidFill>
+                  <a:srgbClr val="8A97B0"/>
+                </a:solidFill>
+                <a:latin typeface="Arial" pitchFamily="34" charset="0"/>
+                <a:ea typeface="Arial" pitchFamily="34" charset="-122"/>
+                <a:cs typeface="Arial" pitchFamily="34" charset="-120"/>
+              </a:rPr>
+              <a:t>↓   </a:t>
+            </a:r>
+            <a:pPr indent="0" marL="0">
+              <a:buNone/>
+            </a:pPr>
+            <a:r>
+              <a:rPr lang="en-US" sz="1000" i="1" dirty="0">
+                <a:solidFill>
+                  <a:srgbClr val="FAB219"/>
+                </a:solidFill>
+                <a:latin typeface="Arial" pitchFamily="34" charset="0"/>
+                <a:ea typeface="Arial" pitchFamily="34" charset="-122"/>
+                <a:cs typeface="Arial" pitchFamily="34" charset="-120"/>
+              </a:rPr>
+              <a:t>smoke confirmed at the sector   ·   no smoke by window's end → return to 1</a:t>
+            </a:r>
+            <a:endParaRPr lang="en-US" sz="1200" dirty="0"/>
+          </a:p>
+        </p:txBody>
+      </p:sp>
+      <p:sp>
+        <p:nvSpPr>
+          <p:cNvPr id="34" name="Shape 32"/>
+          <p:cNvSpPr/>
+          <p:nvPr/>
+        </p:nvSpPr>
+        <p:spPr>
+          <a:xfrm>
+            <a:off x="4023360" y="5276088"/>
+            <a:ext cx="7662672" cy="731520"/>
+          </a:xfrm>
+          <a:prstGeom prst="roundRect">
+            <a:avLst>
+              <a:gd name="adj" fmla="val 11250"/>
+            </a:avLst>
+          </a:prstGeom>
+          <a:solidFill>
+            <a:srgbClr val="1D2740"/>
+          </a:solidFill>
+          <a:ln w="19050">
+            <a:solidFill>
+              <a:srgbClr val="D03B3B"/>
+            </a:solidFill>
+            <a:prstDash val="solid"/>
+          </a:ln>
+        </p:spPr>
+      </p:sp>
+      <p:sp>
+        <p:nvSpPr>
+          <p:cNvPr id="35" name="Shape 33"/>
+          <p:cNvSpPr/>
+          <p:nvPr/>
+        </p:nvSpPr>
+        <p:spPr>
+          <a:xfrm>
+            <a:off x="4187952" y="5477256"/>
+            <a:ext cx="329184" cy="329184"/>
+          </a:xfrm>
+          <a:prstGeom prst="ellipse">
+            <a:avLst/>
+          </a:prstGeom>
+          <a:solidFill>
+            <a:srgbClr val="101625"/>
+          </a:solidFill>
+          <a:ln w="19050">
+            <a:solidFill>
+              <a:srgbClr val="D03B3B"/>
+            </a:solidFill>
+            <a:prstDash val="solid"/>
+          </a:ln>
+        </p:spPr>
+      </p:sp>
+      <p:sp>
+        <p:nvSpPr>
+          <p:cNvPr id="36" name="Text 34"/>
+          <p:cNvSpPr/>
+          <p:nvPr/>
+        </p:nvSpPr>
+        <p:spPr>
+          <a:xfrm>
+            <a:off x="4187952" y="5477256"/>
+            <a:ext cx="329184" cy="329184"/>
+          </a:xfrm>
+          <a:prstGeom prst="rect">
+            <a:avLst/>
+          </a:prstGeom>
+          <a:noFill/>
+          <a:ln/>
+        </p:spPr>
+        <p:txBody>
+          <a:bodyPr wrap="square" lIns="0" tIns="0" rIns="0" bIns="0" rtlCol="0" anchor="ctr"/>
+          <a:lstStyle/>
+          <a:p>
+            <a:pPr algn="ctr" indent="0" marL="0">
+              <a:buNone/>
+            </a:pPr>
+            <a:r>
+              <a:rPr lang="en-US" sz="1300" b="1" dirty="0">
+                <a:solidFill>
+                  <a:srgbClr val="D03B3B"/>
+                </a:solidFill>
+                <a:latin typeface="Arial" pitchFamily="34" charset="0"/>
+                <a:ea typeface="Arial" pitchFamily="34" charset="-122"/>
+                <a:cs typeface="Arial" pitchFamily="34" charset="-120"/>
+              </a:rPr>
+              <a:t>5</a:t>
+            </a:r>
+            <a:endParaRPr lang="en-US" sz="1300" dirty="0"/>
+          </a:p>
+        </p:txBody>
+      </p:sp>
+      <p:sp>
+        <p:nvSpPr>
+          <p:cNvPr id="37" name="Text 35"/>
+          <p:cNvSpPr/>
+          <p:nvPr/>
+        </p:nvSpPr>
+        <p:spPr>
+          <a:xfrm>
+            <a:off x="4681728" y="5340096"/>
+            <a:ext cx="6858000" cy="621792"/>
+          </a:xfrm>
+          <a:prstGeom prst="rect">
+            <a:avLst/>
+          </a:prstGeom>
+          <a:noFill/>
+          <a:ln/>
+        </p:spPr>
+        <p:txBody>
+          <a:bodyPr wrap="square" lIns="0" tIns="0" rIns="0" bIns="0" rtlCol="0" anchor="t"/>
+          <a:lstStyle/>
+          <a:p>
+            <a:pPr indent="0" marL="0">
+              <a:lnSpc>
+                <a:spcPct val="108000"/>
+              </a:lnSpc>
+              <a:buNone/>
+            </a:pPr>
+            <a:r>
+              <a:rPr lang="en-US" sz="1300" b="1" dirty="0">
+                <a:solidFill>
+                  <a:srgbClr val="F5F7FA"/>
+                </a:solidFill>
+                <a:latin typeface="Arial" pitchFamily="34" charset="0"/>
+                <a:ea typeface="Arial" pitchFamily="34" charset="-122"/>
+                <a:cs typeface="Arial" pitchFamily="34" charset="-120"/>
+              </a:rPr>
+              <a:t>Notify emergency personnel
+</a:t>
+            </a:r>
+            <a:pPr indent="0" marL="0">
+              <a:lnSpc>
+                <a:spcPct val="108000"/>
+              </a:lnSpc>
+              <a:buNone/>
+            </a:pPr>
+            <a:r>
+              <a:rPr lang="en-US" sz="950" dirty="0">
+                <a:solidFill>
+                  <a:srgbClr val="C9D4E6"/>
+                </a:solidFill>
+                <a:latin typeface="Arial" pitchFamily="34" charset="0"/>
+                <a:ea typeface="Arial" pitchFamily="34" charset="-122"/>
+                <a:cs typeface="Arial" pitchFamily="34" charset="-120"/>
+              </a:rPr>
+              <a:t>Before-and-after pictures plus the conditions leading up to the strike — soil moisture, rainfall, wind.</a:t>
+            </a:r>
+            <a:endParaRPr lang="en-US" sz="1300" dirty="0"/>
+          </a:p>
+        </p:txBody>
+      </p:sp>
+      <p:sp>
+        <p:nvSpPr>
+          <p:cNvPr id="38" name="Text 36"/>
+          <p:cNvSpPr/>
+          <p:nvPr/>
+        </p:nvSpPr>
+        <p:spPr>
+          <a:xfrm>
+            <a:off x="4023360" y="6144768"/>
+            <a:ext cx="7662672" cy="411480"/>
+          </a:xfrm>
+          <a:prstGeom prst="rect">
+            <a:avLst/>
+          </a:prstGeom>
+          <a:noFill/>
+          <a:ln/>
+        </p:spPr>
+        <p:txBody>
+          <a:bodyPr wrap="square" lIns="0" tIns="0" rIns="0" bIns="0" rtlCol="0" anchor="ctr"/>
+          <a:lstStyle/>
+          <a:p>
+            <a:pPr indent="0" marL="0">
+              <a:lnSpc>
+                <a:spcPct val="112000"/>
+              </a:lnSpc>
+              <a:buNone/>
+            </a:pPr>
+            <a:r>
+              <a:rPr lang="en-US" sz="850" i="1" dirty="0">
+                <a:solidFill>
+                  <a:srgbClr val="8A97B0"/>
+                </a:solidFill>
+                <a:latin typeface="Arial" pitchFamily="34" charset="0"/>
+                <a:ea typeface="Arial" pitchFamily="34" charset="-122"/>
+                <a:cs typeface="Arial" pitchFamily="34" charset="-120"/>
+              </a:rPr>
+              <a:t>SDR sensing is planned hardware — the camera flash is the start-of-clock today. Notifications are human-reviewed before anything reaches responders. Soil moisture currently comes from NASA data; an on-node probe is the planned upgrade.</a:t>
+            </a:r>
+            <a:endParaRPr lang="en-US" sz="850" dirty="0"/>
+          </a:p>
+        </p:txBody>
+      </p:sp>
+    </p:spTree>
+  </p:cSld>
+  <p:clrMapOvr>
+    <a:masterClrMapping/>
+  </p:clrMapOvr>
+</p:sld>
+</file>
+
+<file path=ppt/slides/slide12.xml><?xml version="1.0" encoding="utf-8"?>
+<p:sld xmlns:a="http://schemas.openxmlformats.org/drawingml/2006/main" xmlns:r="http://schemas.openxmlformats.org/officeDocument/2006/relationships" xmlns:p="http://schemas.openxmlformats.org/presentationml/2006/main">
+  <p:cSld name="Slide 12">
+    <p:spTree>
+      <p:nvGrpSpPr>
+        <p:cNvPr id="1" name=""/>
+        <p:cNvGrpSpPr/>
+        <p:nvPr/>
+      </p:nvGrpSpPr>
+      <p:grpSpPr>
+        <a:xfrm>
+          <a:off x="0" y="0"/>
+          <a:ext cx="0" cy="0"/>
+          <a:chOff x="0" y="0"/>
+          <a:chExt cx="0" cy="0"/>
+        </a:xfrm>
+      </p:grpSpPr>
+      <p:sp>
+        <p:nvSpPr>
+          <p:cNvPr id="2" name="Text 0"/>
+          <p:cNvSpPr/>
+          <p:nvPr/>
+        </p:nvSpPr>
+        <p:spPr>
+          <a:xfrm>
+            <a:off x="502920" y="310896"/>
+            <a:ext cx="11183112" cy="274320"/>
+          </a:xfrm>
+          <a:prstGeom prst="rect">
+            <a:avLst/>
+          </a:prstGeom>
+          <a:noFill/>
+          <a:ln/>
+        </p:spPr>
+        <p:txBody>
+          <a:bodyPr wrap="square" lIns="0" tIns="0" rIns="0" bIns="0" rtlCol="0" anchor="ctr"/>
+          <a:lstStyle/>
+          <a:p>
+            <a:pPr indent="0" marL="0">
+              <a:buNone/>
+            </a:pPr>
+            <a:r>
+              <a:rPr lang="en-US" sz="1300" b="1" spc="300" kern="0" dirty="0">
+                <a:solidFill>
+                  <a:srgbClr val="FAB219"/>
+                </a:solidFill>
+                <a:latin typeface="Arial" pitchFamily="34" charset="0"/>
+                <a:ea typeface="Arial" pitchFamily="34" charset="-122"/>
+                <a:cs typeface="Arial" pitchFamily="34" charset="-120"/>
+              </a:rPr>
               <a:t>BACKUP — FOR Q&amp;A</a:t>
             </a:r>
             <a:endParaRPr lang="en-US" sz="1300" dirty="0"/>

</xml_diff>

<commit_message>
Add Sage-docs-style flow-of-state slide as native editable shapes
Second flow diagram (white background, Beehive cloud container, five
state boxes with transition-condition arrows) rebuilt from PowerPoint
shapes and text boxes so it is editable like the dark version; both
flow-of-state slides now sit adjacent in the deck. Adds the small
line-art icon set used by the tabs.

Co-Authored-By: Claude Fable 5 <noreply@anthropic.com>
Claude-Session: https://claude.ai/code/session_01UD3fcKavuimuC1QvaVbRS3
</commit_message>
<xml_diff>
--- a/flashpoint/deck/FlashPoint-Camp-Results.pptx
+++ b/flashpoint/deck/FlashPoint-Camp-Results.pptx
@@ -17,9 +17,10 @@
     <p:sldId id="265" r:id="rId11"/>
     <p:sldId id="266" r:id="rId12"/>
     <p:sldId id="267" r:id="rId13"/>
+    <p:sldId id="268" r:id="rId14"/>
   </p:sldIdLst>
   <p:notesMasterIdLst>
-    <p:notesMasterId r:id="rId14"/>
+    <p:notesMasterId r:id="rId15"/>
   </p:notesMasterIdLst>
   <p:sldSz cx="12192000" cy="6858000"/>
   <p:notesSz cx="6858000" cy="12192000"/>
@@ -777,7 +778,7 @@
           <a:p>
             <a:r>
               <a:rPr lang="en-US" dirty="0"/>
-              <a:t>[Backup — show only if siting or tasking questions come up in Q&amp;A. Second, independent example: this node's fixed camera flagged the plume with its production detector while the steerable camera studied canopy the same day. Tasking, not camera capability, is the gap the storm-mode controller closes.]</a:t>
+              <a:t>[Optional / Q&amp;A] The same five-state flow as the previous slide, drawn in the Sage documentation style: the Beehive cloud container on top, the node states left to right beneath it. Content is identical — use whichever version reads better for the audience. The footnote again separates what runs today from planned hardware.</a:t>
             </a:r>
             <a:endParaRPr lang="en-US" dirty="0"/>
           </a:p>
@@ -801,6 +802,94 @@
             <a:fld id="{F7021451-1387-4CA6-816F-3879F97B5CBC}" type="slidenum">
               <a:rPr lang="en-US"/>
               <a:t>12</a:t>
+            </a:fld>
+            <a:endParaRPr lang="en-US"/>
+          </a:p>
+        </p:txBody>
+      </p:sp>
+    </p:spTree>
+    <p:extLst>
+      <p:ext uri="{BB962C8B-B14F-4D97-AF65-F5344CB8AC3E}">
+        <p14:creationId xmlns:p14="http://schemas.microsoft.com/office/powerpoint/2010/main" val="1024086991"/>
+      </p:ext>
+    </p:extLst>
+  </p:cSld>
+  <p:clrMapOvr>
+    <a:masterClrMapping/>
+  </p:clrMapOvr>
+</p:notes>
+</file>
+
+<file path=ppt/notesSlides/notesSlide13.xml><?xml version="1.0" encoding="utf-8"?>
+<p:notes xmlns:a="http://schemas.openxmlformats.org/drawingml/2006/main" xmlns:r="http://schemas.openxmlformats.org/officeDocument/2006/relationships" xmlns:p="http://schemas.openxmlformats.org/presentationml/2006/main">
+  <p:cSld>
+    <p:spTree>
+      <p:nvGrpSpPr>
+        <p:cNvPr id="1" name=""/>
+        <p:cNvGrpSpPr/>
+        <p:nvPr/>
+      </p:nvGrpSpPr>
+      <p:grpSpPr>
+        <a:xfrm>
+          <a:off x="0" y="0"/>
+          <a:ext cx="0" cy="0"/>
+          <a:chOff x="0" y="0"/>
+          <a:chExt cx="0" cy="0"/>
+        </a:xfrm>
+      </p:grpSpPr>
+      <p:sp>
+        <p:nvSpPr>
+          <p:cNvPr id="2" name="Slide Image Placeholder 1"/>
+          <p:cNvSpPr>
+            <a:spLocks noGrp="1" noRot="1" noChangeAspect="1"/>
+          </p:cNvSpPr>
+          <p:nvPr>
+            <p:ph type="sldImg"/>
+          </p:nvPr>
+        </p:nvSpPr>
+        <p:spPr/>
+      </p:sp>
+      <p:sp>
+        <p:nvSpPr>
+          <p:cNvPr id="3" name="Notes Placeholder 2"/>
+          <p:cNvSpPr>
+            <a:spLocks noGrp="1"/>
+          </p:cNvSpPr>
+          <p:nvPr>
+            <p:ph type="body" idx="1"/>
+          </p:nvPr>
+        </p:nvSpPr>
+        <p:spPr/>
+        <p:txBody>
+          <a:bodyPr/>
+          <a:lstStyle/>
+          <a:p>
+            <a:r>
+              <a:rPr lang="en-US" dirty="0"/>
+              <a:t>[Backup — show only if siting or tasking questions come up in Q&amp;A. Second, independent example: this node's fixed camera flagged the plume with its production detector while the steerable camera studied canopy the same day. Tasking, not camera capability, is the gap the storm-mode controller closes.]</a:t>
+            </a:r>
+            <a:endParaRPr lang="en-US" dirty="0"/>
+          </a:p>
+        </p:txBody>
+      </p:sp>
+      <p:sp>
+        <p:nvSpPr>
+          <p:cNvPr id="4" name="Slide Number Placeholder 3"/>
+          <p:cNvSpPr>
+            <a:spLocks noGrp="1"/>
+          </p:cNvSpPr>
+          <p:nvPr>
+            <p:ph type="sldNum" sz="quarter" idx="10"/>
+          </p:nvPr>
+        </p:nvSpPr>
+        <p:spPr/>
+        <p:txBody>
+          <a:bodyPr/>
+          <a:lstStyle/>
+          <a:p>
+            <a:fld id="{F7021451-1387-4CA6-816F-3879F97B5CBC}" type="slidenum">
+              <a:rPr lang="en-US"/>
+              <a:t>13</a:t>
             </a:fld>
             <a:endParaRPr lang="en-US"/>
           </a:p>
@@ -4684,6 +4773,1733 @@
 <file path=ppt/slides/slide12.xml><?xml version="1.0" encoding="utf-8"?>
 <p:sld xmlns:a="http://schemas.openxmlformats.org/drawingml/2006/main" xmlns:r="http://schemas.openxmlformats.org/officeDocument/2006/relationships" xmlns:p="http://schemas.openxmlformats.org/presentationml/2006/main">
   <p:cSld name="Slide 12">
+    <p:bg>
+      <p:bgPr>
+        <a:solidFill>
+          <a:srgbClr val="FFFFFF"/>
+        </a:solidFill>
+      </p:bgPr>
+    </p:bg>
+    <p:spTree>
+      <p:nvGrpSpPr>
+        <p:cNvPr id="1" name=""/>
+        <p:cNvGrpSpPr/>
+        <p:nvPr/>
+      </p:nvGrpSpPr>
+      <p:grpSpPr>
+        <a:xfrm>
+          <a:off x="0" y="0"/>
+          <a:ext cx="0" cy="0"/>
+          <a:chOff x="0" y="0"/>
+          <a:chExt cx="0" cy="0"/>
+        </a:xfrm>
+      </p:grpSpPr>
+      <p:sp>
+        <p:nvSpPr>
+          <p:cNvPr id="2" name="Text 0"/>
+          <p:cNvSpPr/>
+          <p:nvPr/>
+        </p:nvSpPr>
+        <p:spPr>
+          <a:xfrm>
+            <a:off x="502920" y="274320"/>
+            <a:ext cx="11183112" cy="237744"/>
+          </a:xfrm>
+          <a:prstGeom prst="rect">
+            <a:avLst/>
+          </a:prstGeom>
+          <a:noFill/>
+          <a:ln/>
+        </p:spPr>
+        <p:txBody>
+          <a:bodyPr wrap="square" lIns="0" tIns="0" rIns="0" bIns="0" rtlCol="0" anchor="ctr"/>
+          <a:lstStyle/>
+          <a:p>
+            <a:pPr indent="0" marL="0">
+              <a:buNone/>
+            </a:pPr>
+            <a:r>
+              <a:rPr lang="en-US" sz="1100" b="1" spc="300" kern="0" dirty="0">
+                <a:solidFill>
+                  <a:srgbClr val="5F6B7A"/>
+                </a:solidFill>
+                <a:latin typeface="Arial" pitchFamily="34" charset="0"/>
+                <a:ea typeface="Arial" pitchFamily="34" charset="-122"/>
+                <a:cs typeface="Arial" pitchFamily="34" charset="-120"/>
+              </a:rPr>
+              <a:t>TARGET OPERATING CONCEPT — SIMPLIFIED</a:t>
+            </a:r>
+            <a:endParaRPr lang="en-US" sz="1100" dirty="0"/>
+          </a:p>
+        </p:txBody>
+      </p:sp>
+      <p:sp>
+        <p:nvSpPr>
+          <p:cNvPr id="3" name="Text 1"/>
+          <p:cNvSpPr/>
+          <p:nvPr/>
+        </p:nvSpPr>
+        <p:spPr>
+          <a:xfrm>
+            <a:off x="502920" y="512064"/>
+            <a:ext cx="11183112" cy="411480"/>
+          </a:xfrm>
+          <a:prstGeom prst="rect">
+            <a:avLst/>
+          </a:prstGeom>
+          <a:noFill/>
+          <a:ln/>
+        </p:spPr>
+        <p:txBody>
+          <a:bodyPr wrap="square" lIns="0" tIns="0" rIns="0" bIns="0" rtlCol="0" anchor="ctr"/>
+          <a:lstStyle/>
+          <a:p>
+            <a:pPr indent="0" marL="0">
+              <a:buNone/>
+            </a:pPr>
+            <a:r>
+              <a:rPr lang="en-US" sz="2400" b="1" dirty="0">
+                <a:solidFill>
+                  <a:srgbClr val="232F3E"/>
+                </a:solidFill>
+                <a:latin typeface="Arial" pitchFamily="34" charset="0"/>
+                <a:ea typeface="Arial" pitchFamily="34" charset="-122"/>
+                <a:cs typeface="Arial" pitchFamily="34" charset="-120"/>
+              </a:rPr>
+              <a:t>Sage FlashPoint — flow of state</a:t>
+            </a:r>
+            <a:endParaRPr lang="en-US" sz="2400" dirty="0"/>
+          </a:p>
+        </p:txBody>
+      </p:sp>
+      <p:sp>
+        <p:nvSpPr>
+          <p:cNvPr id="4" name="Text 2"/>
+          <p:cNvSpPr/>
+          <p:nvPr/>
+        </p:nvSpPr>
+        <p:spPr>
+          <a:xfrm>
+            <a:off x="502920" y="914400"/>
+            <a:ext cx="11183112" cy="256032"/>
+          </a:xfrm>
+          <a:prstGeom prst="rect">
+            <a:avLst/>
+          </a:prstGeom>
+          <a:noFill/>
+          <a:ln/>
+        </p:spPr>
+        <p:txBody>
+          <a:bodyPr wrap="square" lIns="0" tIns="0" rIns="0" bIns="0" rtlCol="0" anchor="ctr"/>
+          <a:lstStyle/>
+          <a:p>
+            <a:pPr indent="0" marL="0">
+              <a:buNone/>
+            </a:pPr>
+            <a:r>
+              <a:rPr lang="en-US" sz="1150" dirty="0">
+                <a:solidFill>
+                  <a:srgbClr val="5F6B7A"/>
+                </a:solidFill>
+                <a:latin typeface="Arial" pitchFamily="34" charset="0"/>
+                <a:ea typeface="Arial" pitchFamily="34" charset="-122"/>
+                <a:cs typeface="Arial" pitchFamily="34" charset="-120"/>
+              </a:rPr>
+              <a:t>The Beehive-level orchestrator supervises every step; each arrow fires only when its condition is met.</a:t>
+            </a:r>
+            <a:endParaRPr lang="en-US" sz="1150" dirty="0"/>
+          </a:p>
+        </p:txBody>
+      </p:sp>
+      <p:sp>
+        <p:nvSpPr>
+          <p:cNvPr id="5" name="Shape 3"/>
+          <p:cNvSpPr/>
+          <p:nvPr/>
+        </p:nvSpPr>
+        <p:spPr>
+          <a:xfrm>
+            <a:off x="502920" y="1207008"/>
+            <a:ext cx="11183112" cy="1600200"/>
+          </a:xfrm>
+          <a:prstGeom prst="roundRect">
+            <a:avLst>
+              <a:gd name="adj" fmla="val 5714"/>
+            </a:avLst>
+          </a:prstGeom>
+          <a:solidFill>
+            <a:srgbClr val="FFFFFF"/>
+          </a:solidFill>
+          <a:ln w="31750">
+            <a:solidFill>
+              <a:srgbClr val="232F3E"/>
+            </a:solidFill>
+            <a:prstDash val="solid"/>
+          </a:ln>
+        </p:spPr>
+      </p:sp>
+      <p:sp>
+        <p:nvSpPr>
+          <p:cNvPr id="6" name="Shape 4"/>
+          <p:cNvSpPr/>
+          <p:nvPr/>
+        </p:nvSpPr>
+        <p:spPr>
+          <a:xfrm>
+            <a:off x="502920" y="1207008"/>
+            <a:ext cx="658368" cy="658368"/>
+          </a:xfrm>
+          <a:prstGeom prst="roundRect">
+            <a:avLst>
+              <a:gd name="adj" fmla="val 11111"/>
+            </a:avLst>
+          </a:prstGeom>
+          <a:solidFill>
+            <a:srgbClr val="232F3E"/>
+          </a:solidFill>
+          <a:ln w="12700">
+            <a:solidFill>
+              <a:srgbClr val="232F3E"/>
+            </a:solidFill>
+            <a:prstDash val="solid"/>
+          </a:ln>
+        </p:spPr>
+      </p:sp>
+      <p:pic>
+        <p:nvPicPr>
+          <p:cNvPr id="7" name="Image 0" descr="Cloud icon">    </p:cNvPr>
+          <p:cNvPicPr>
+            <a:picLocks noChangeAspect="1"/>
+          </p:cNvPicPr>
+          <p:nvPr/>
+        </p:nvPicPr>
+        <p:blipFill>
+          <a:blip r:embed="rId1"/>
+          <a:stretch>
+            <a:fillRect/>
+          </a:stretch>
+        </p:blipFill>
+        <p:spPr>
+          <a:xfrm>
+            <a:off x="630936" y="1335024"/>
+            <a:ext cx="402336" cy="402336"/>
+          </a:xfrm>
+          <a:prstGeom prst="rect">
+            <a:avLst/>
+          </a:prstGeom>
+        </p:spPr>
+      </p:pic>
+      <p:sp>
+        <p:nvSpPr>
+          <p:cNvPr id="8" name="Text 5"/>
+          <p:cNvSpPr/>
+          <p:nvPr/>
+        </p:nvSpPr>
+        <p:spPr>
+          <a:xfrm>
+            <a:off x="1280160" y="1371600"/>
+            <a:ext cx="2240280" cy="1280160"/>
+          </a:xfrm>
+          <a:prstGeom prst="rect">
+            <a:avLst/>
+          </a:prstGeom>
+          <a:noFill/>
+          <a:ln/>
+        </p:spPr>
+        <p:txBody>
+          <a:bodyPr wrap="square" lIns="0" tIns="0" rIns="0" bIns="0" rtlCol="0" anchor="ctr"/>
+          <a:lstStyle/>
+          <a:p>
+            <a:pPr indent="0" marL="0">
+              <a:lnSpc>
+                <a:spcPct val="115000"/>
+              </a:lnSpc>
+              <a:buNone/>
+            </a:pPr>
+            <a:r>
+              <a:rPr lang="en-US" sz="1600" b="1" dirty="0">
+                <a:solidFill>
+                  <a:srgbClr val="232F3E"/>
+                </a:solidFill>
+                <a:latin typeface="Arial" pitchFamily="34" charset="0"/>
+                <a:ea typeface="Arial" pitchFamily="34" charset="-122"/>
+                <a:cs typeface="Arial" pitchFamily="34" charset="-120"/>
+              </a:rPr>
+              <a:t>Beehive Cloud
+</a:t>
+            </a:r>
+            <a:pPr indent="0" marL="0">
+              <a:lnSpc>
+                <a:spcPct val="115000"/>
+              </a:lnSpc>
+              <a:buNone/>
+            </a:pPr>
+            <a:r>
+              <a:rPr lang="en-US" sz="1000" dirty="0">
+                <a:solidFill>
+                  <a:srgbClr val="5F6B7A"/>
+                </a:solidFill>
+                <a:latin typeface="Arial" pitchFamily="34" charset="0"/>
+                <a:ea typeface="Arial" pitchFamily="34" charset="-122"/>
+                <a:cs typeface="Arial" pitchFamily="34" charset="-120"/>
+              </a:rPr>
+              <a:t>Orchestrator Agent — LLM (large language model)</a:t>
+            </a:r>
+            <a:endParaRPr lang="en-US" sz="1600" dirty="0"/>
+          </a:p>
+        </p:txBody>
+      </p:sp>
+      <p:pic>
+        <p:nvPicPr>
+          <p:cNvPr id="9" name="Image 1" descr="Every node">    </p:cNvPr>
+          <p:cNvPicPr>
+            <a:picLocks noChangeAspect="1"/>
+          </p:cNvPicPr>
+          <p:nvPr/>
+        </p:nvPicPr>
+        <p:blipFill>
+          <a:blip r:embed="rId2"/>
+          <a:stretch>
+            <a:fillRect/>
+          </a:stretch>
+        </p:blipFill>
+        <p:spPr>
+          <a:xfrm>
+            <a:off x="4379976" y="1371600"/>
+            <a:ext cx="384048" cy="384048"/>
+          </a:xfrm>
+          <a:prstGeom prst="rect">
+            <a:avLst/>
+          </a:prstGeom>
+        </p:spPr>
+      </p:pic>
+      <p:sp>
+        <p:nvSpPr>
+          <p:cNvPr id="10" name="Text 6"/>
+          <p:cNvSpPr/>
+          <p:nvPr/>
+        </p:nvSpPr>
+        <p:spPr>
+          <a:xfrm>
+            <a:off x="3246120" y="1792224"/>
+            <a:ext cx="2651760" cy="237744"/>
+          </a:xfrm>
+          <a:prstGeom prst="rect">
+            <a:avLst/>
+          </a:prstGeom>
+          <a:noFill/>
+          <a:ln/>
+        </p:spPr>
+        <p:txBody>
+          <a:bodyPr wrap="square" lIns="0" tIns="0" rIns="0" bIns="0" rtlCol="0" anchor="ctr"/>
+          <a:lstStyle/>
+          <a:p>
+            <a:pPr algn="ctr" indent="0" marL="0">
+              <a:buNone/>
+            </a:pPr>
+            <a:r>
+              <a:rPr lang="en-US" sz="1150" b="1" dirty="0">
+                <a:solidFill>
+                  <a:srgbClr val="232F3E"/>
+                </a:solidFill>
+                <a:latin typeface="Arial" pitchFamily="34" charset="0"/>
+                <a:ea typeface="Arial" pitchFamily="34" charset="-122"/>
+                <a:cs typeface="Arial" pitchFamily="34" charset="-120"/>
+              </a:rPr>
+              <a:t>Every node</a:t>
+            </a:r>
+            <a:endParaRPr lang="en-US" sz="1150" dirty="0"/>
+          </a:p>
+        </p:txBody>
+      </p:sp>
+      <p:sp>
+        <p:nvSpPr>
+          <p:cNvPr id="11" name="Text 7"/>
+          <p:cNvSpPr/>
+          <p:nvPr/>
+        </p:nvSpPr>
+        <p:spPr>
+          <a:xfrm>
+            <a:off x="3246120" y="2029968"/>
+            <a:ext cx="2651760" cy="640080"/>
+          </a:xfrm>
+          <a:prstGeom prst="rect">
+            <a:avLst/>
+          </a:prstGeom>
+          <a:noFill/>
+          <a:ln/>
+        </p:spPr>
+        <p:txBody>
+          <a:bodyPr wrap="square" lIns="0" tIns="0" rIns="0" bIns="0" rtlCol="0" anchor="t"/>
+          <a:lstStyle/>
+          <a:p>
+            <a:pPr algn="ctr" indent="0" marL="0">
+              <a:lnSpc>
+                <a:spcPct val="112000"/>
+              </a:lnSpc>
+              <a:buNone/>
+            </a:pPr>
+            <a:r>
+              <a:rPr lang="en-US" sz="950" dirty="0">
+                <a:solidFill>
+                  <a:srgbClr val="37475A"/>
+                </a:solidFill>
+                <a:latin typeface="Arial" pitchFamily="34" charset="0"/>
+                <a:ea typeface="Arial" pitchFamily="34" charset="-122"/>
+                <a:cs typeface="Arial" pitchFamily="34" charset="-120"/>
+              </a:rPr>
+              <a:t>telemetry · detections · frames</a:t>
+            </a:r>
+            <a:endParaRPr lang="en-US" sz="950" dirty="0"/>
+          </a:p>
+        </p:txBody>
+      </p:sp>
+      <p:pic>
+        <p:nvPicPr>
+          <p:cNvPr id="12" name="Image 2" descr="External data">    </p:cNvPr>
+          <p:cNvPicPr>
+            <a:picLocks noChangeAspect="1"/>
+          </p:cNvPicPr>
+          <p:nvPr/>
+        </p:nvPicPr>
+        <p:blipFill>
+          <a:blip r:embed="rId3"/>
+          <a:stretch>
+            <a:fillRect/>
+          </a:stretch>
+        </p:blipFill>
+        <p:spPr>
+          <a:xfrm>
+            <a:off x="7168896" y="1371600"/>
+            <a:ext cx="384048" cy="384048"/>
+          </a:xfrm>
+          <a:prstGeom prst="rect">
+            <a:avLst/>
+          </a:prstGeom>
+        </p:spPr>
+      </p:pic>
+      <p:sp>
+        <p:nvSpPr>
+          <p:cNvPr id="13" name="Text 8"/>
+          <p:cNvSpPr/>
+          <p:nvPr/>
+        </p:nvSpPr>
+        <p:spPr>
+          <a:xfrm>
+            <a:off x="6035040" y="1792224"/>
+            <a:ext cx="2651760" cy="237744"/>
+          </a:xfrm>
+          <a:prstGeom prst="rect">
+            <a:avLst/>
+          </a:prstGeom>
+          <a:noFill/>
+          <a:ln/>
+        </p:spPr>
+        <p:txBody>
+          <a:bodyPr wrap="square" lIns="0" tIns="0" rIns="0" bIns="0" rtlCol="0" anchor="ctr"/>
+          <a:lstStyle/>
+          <a:p>
+            <a:pPr algn="ctr" indent="0" marL="0">
+              <a:buNone/>
+            </a:pPr>
+            <a:r>
+              <a:rPr lang="en-US" sz="1150" b="1" dirty="0">
+                <a:solidFill>
+                  <a:srgbClr val="232F3E"/>
+                </a:solidFill>
+                <a:latin typeface="Arial" pitchFamily="34" charset="0"/>
+                <a:ea typeface="Arial" pitchFamily="34" charset="-122"/>
+                <a:cs typeface="Arial" pitchFamily="34" charset="-120"/>
+              </a:rPr>
+              <a:t>External data</a:t>
+            </a:r>
+            <a:endParaRPr lang="en-US" sz="1150" dirty="0"/>
+          </a:p>
+        </p:txBody>
+      </p:sp>
+      <p:sp>
+        <p:nvSpPr>
+          <p:cNvPr id="14" name="Text 9"/>
+          <p:cNvSpPr/>
+          <p:nvPr/>
+        </p:nvSpPr>
+        <p:spPr>
+          <a:xfrm>
+            <a:off x="6035040" y="2029968"/>
+            <a:ext cx="2651760" cy="640080"/>
+          </a:xfrm>
+          <a:prstGeom prst="rect">
+            <a:avLst/>
+          </a:prstGeom>
+          <a:noFill/>
+          <a:ln/>
+        </p:spPr>
+        <p:txBody>
+          <a:bodyPr wrap="square" lIns="0" tIns="0" rIns="0" bIns="0" rtlCol="0" anchor="t"/>
+          <a:lstStyle/>
+          <a:p>
+            <a:pPr algn="ctr" indent="0" marL="0">
+              <a:lnSpc>
+                <a:spcPct val="112000"/>
+              </a:lnSpc>
+              <a:buNone/>
+            </a:pPr>
+            <a:r>
+              <a:rPr lang="en-US" sz="950" dirty="0">
+                <a:solidFill>
+                  <a:srgbClr val="37475A"/>
+                </a:solidFill>
+                <a:latin typeface="Arial" pitchFamily="34" charset="0"/>
+                <a:ea typeface="Arial" pitchFamily="34" charset="-122"/>
+                <a:cs typeface="Arial" pitchFamily="34" charset="-120"/>
+              </a:rPr>
+              <a:t>NASA · Xweather · National Weather Service · GOES</a:t>
+            </a:r>
+            <a:endParaRPr lang="en-US" sz="950" dirty="0"/>
+          </a:p>
+        </p:txBody>
+      </p:sp>
+      <p:pic>
+        <p:nvPicPr>
+          <p:cNvPr id="15" name="Image 3" descr="Directs, never dispatches">    </p:cNvPr>
+          <p:cNvPicPr>
+            <a:picLocks noChangeAspect="1"/>
+          </p:cNvPicPr>
+          <p:nvPr/>
+        </p:nvPicPr>
+        <p:blipFill>
+          <a:blip r:embed="rId4"/>
+          <a:stretch>
+            <a:fillRect/>
+          </a:stretch>
+        </p:blipFill>
+        <p:spPr>
+          <a:xfrm>
+            <a:off x="9957816" y="1371600"/>
+            <a:ext cx="384048" cy="384048"/>
+          </a:xfrm>
+          <a:prstGeom prst="rect">
+            <a:avLst/>
+          </a:prstGeom>
+        </p:spPr>
+      </p:pic>
+      <p:sp>
+        <p:nvSpPr>
+          <p:cNvPr id="16" name="Text 10"/>
+          <p:cNvSpPr/>
+          <p:nvPr/>
+        </p:nvSpPr>
+        <p:spPr>
+          <a:xfrm>
+            <a:off x="8823960" y="1792224"/>
+            <a:ext cx="2651760" cy="237744"/>
+          </a:xfrm>
+          <a:prstGeom prst="rect">
+            <a:avLst/>
+          </a:prstGeom>
+          <a:noFill/>
+          <a:ln/>
+        </p:spPr>
+        <p:txBody>
+          <a:bodyPr wrap="square" lIns="0" tIns="0" rIns="0" bIns="0" rtlCol="0" anchor="ctr"/>
+          <a:lstStyle/>
+          <a:p>
+            <a:pPr algn="ctr" indent="0" marL="0">
+              <a:buNone/>
+            </a:pPr>
+            <a:r>
+              <a:rPr lang="en-US" sz="1150" b="1" dirty="0">
+                <a:solidFill>
+                  <a:srgbClr val="232F3E"/>
+                </a:solidFill>
+                <a:latin typeface="Arial" pitchFamily="34" charset="0"/>
+                <a:ea typeface="Arial" pitchFamily="34" charset="-122"/>
+                <a:cs typeface="Arial" pitchFamily="34" charset="-120"/>
+              </a:rPr>
+              <a:t>Directs, never dispatches</a:t>
+            </a:r>
+            <a:endParaRPr lang="en-US" sz="1150" dirty="0"/>
+          </a:p>
+        </p:txBody>
+      </p:sp>
+      <p:sp>
+        <p:nvSpPr>
+          <p:cNvPr id="17" name="Text 11"/>
+          <p:cNvSpPr/>
+          <p:nvPr/>
+        </p:nvSpPr>
+        <p:spPr>
+          <a:xfrm>
+            <a:off x="8823960" y="2029968"/>
+            <a:ext cx="2651760" cy="640080"/>
+          </a:xfrm>
+          <a:prstGeom prst="rect">
+            <a:avLst/>
+          </a:prstGeom>
+          <a:noFill/>
+          <a:ln/>
+        </p:spPr>
+        <p:txBody>
+          <a:bodyPr wrap="square" lIns="0" tIns="0" rIns="0" bIns="0" rtlCol="0" anchor="t"/>
+          <a:lstStyle/>
+          <a:p>
+            <a:pPr algn="ctr" indent="0" marL="0">
+              <a:lnSpc>
+                <a:spcPct val="112000"/>
+              </a:lnSpc>
+              <a:buNone/>
+            </a:pPr>
+            <a:r>
+              <a:rPr lang="en-US" sz="950" dirty="0">
+                <a:solidFill>
+                  <a:srgbClr val="37475A"/>
+                </a:solidFill>
+                <a:latin typeface="Arial" pitchFamily="34" charset="0"/>
+                <a:ea typeface="Arial" pitchFamily="34" charset="-122"/>
+                <a:cs typeface="Arial" pitchFamily="34" charset="-120"/>
+              </a:rPr>
+              <a:t>every action logged</a:t>
+            </a:r>
+            <a:endParaRPr lang="en-US" sz="950" dirty="0"/>
+          </a:p>
+        </p:txBody>
+      </p:sp>
+      <p:sp>
+        <p:nvSpPr>
+          <p:cNvPr id="18" name="Shape 12"/>
+          <p:cNvSpPr/>
+          <p:nvPr/>
+        </p:nvSpPr>
+        <p:spPr>
+          <a:xfrm>
+            <a:off x="6094476" y="2843784"/>
+            <a:ext cx="0" cy="310896"/>
+          </a:xfrm>
+          <a:prstGeom prst="line">
+            <a:avLst/>
+          </a:prstGeom>
+          <a:noFill/>
+          <a:ln w="25400">
+            <a:solidFill>
+              <a:srgbClr val="5F6B7A"/>
+            </a:solidFill>
+            <a:prstDash val="solid"/>
+            <a:tailEnd type="triangle"/>
+          </a:ln>
+        </p:spPr>
+      </p:sp>
+      <p:sp>
+        <p:nvSpPr>
+          <p:cNvPr id="19" name="Shape 13"/>
+          <p:cNvSpPr/>
+          <p:nvPr/>
+        </p:nvSpPr>
+        <p:spPr>
+          <a:xfrm>
+            <a:off x="502920" y="3236976"/>
+            <a:ext cx="1600200" cy="2331720"/>
+          </a:xfrm>
+          <a:prstGeom prst="roundRect">
+            <a:avLst>
+              <a:gd name="adj" fmla="val 5143"/>
+            </a:avLst>
+          </a:prstGeom>
+          <a:solidFill>
+            <a:srgbClr val="FFFFFF"/>
+          </a:solidFill>
+          <a:ln w="31750">
+            <a:solidFill>
+              <a:srgbClr val="E8710A"/>
+            </a:solidFill>
+            <a:prstDash val="solid"/>
+          </a:ln>
+        </p:spPr>
+      </p:sp>
+      <p:sp>
+        <p:nvSpPr>
+          <p:cNvPr id="20" name="Shape 14"/>
+          <p:cNvSpPr/>
+          <p:nvPr/>
+        </p:nvSpPr>
+        <p:spPr>
+          <a:xfrm>
+            <a:off x="502920" y="3236976"/>
+            <a:ext cx="457200" cy="457200"/>
+          </a:xfrm>
+          <a:prstGeom prst="roundRect">
+            <a:avLst>
+              <a:gd name="adj" fmla="val 14000"/>
+            </a:avLst>
+          </a:prstGeom>
+          <a:solidFill>
+            <a:srgbClr val="E8710A"/>
+          </a:solidFill>
+          <a:ln w="12700">
+            <a:solidFill>
+              <a:srgbClr val="E8710A"/>
+            </a:solidFill>
+            <a:prstDash val="solid"/>
+          </a:ln>
+        </p:spPr>
+      </p:sp>
+      <p:pic>
+        <p:nvPicPr>
+          <p:cNvPr id="21" name="Image 4" descr="1 · Quiet watch">    </p:cNvPr>
+          <p:cNvPicPr>
+            <a:picLocks noChangeAspect="1"/>
+          </p:cNvPicPr>
+          <p:nvPr/>
+        </p:nvPicPr>
+        <p:blipFill>
+          <a:blip r:embed="rId5"/>
+          <a:stretch>
+            <a:fillRect/>
+          </a:stretch>
+        </p:blipFill>
+        <p:spPr>
+          <a:xfrm>
+            <a:off x="585216" y="3319272"/>
+            <a:ext cx="292608" cy="292608"/>
+          </a:xfrm>
+          <a:prstGeom prst="rect">
+            <a:avLst/>
+          </a:prstGeom>
+        </p:spPr>
+      </p:pic>
+      <p:sp>
+        <p:nvSpPr>
+          <p:cNvPr id="22" name="Text 15"/>
+          <p:cNvSpPr/>
+          <p:nvPr/>
+        </p:nvSpPr>
+        <p:spPr>
+          <a:xfrm>
+            <a:off x="557784" y="3785616"/>
+            <a:ext cx="1490472" cy="512064"/>
+          </a:xfrm>
+          <a:prstGeom prst="rect">
+            <a:avLst/>
+          </a:prstGeom>
+          <a:noFill/>
+          <a:ln/>
+        </p:spPr>
+        <p:txBody>
+          <a:bodyPr wrap="square" lIns="0" tIns="0" rIns="0" bIns="0" rtlCol="0" anchor="t"/>
+          <a:lstStyle/>
+          <a:p>
+            <a:pPr algn="ctr" indent="0" marL="0">
+              <a:buNone/>
+            </a:pPr>
+            <a:r>
+              <a:rPr lang="en-US" sz="1200" b="1" dirty="0">
+                <a:solidFill>
+                  <a:srgbClr val="232F3E"/>
+                </a:solidFill>
+                <a:latin typeface="Arial" pitchFamily="34" charset="0"/>
+                <a:ea typeface="Arial" pitchFamily="34" charset="-122"/>
+                <a:cs typeface="Arial" pitchFamily="34" charset="-120"/>
+              </a:rPr>
+              <a:t>1 · Quiet watch</a:t>
+            </a:r>
+            <a:endParaRPr lang="en-US" sz="1200" dirty="0"/>
+          </a:p>
+        </p:txBody>
+      </p:sp>
+      <p:sp>
+        <p:nvSpPr>
+          <p:cNvPr id="23" name="Text 16"/>
+          <p:cNvSpPr/>
+          <p:nvPr/>
+        </p:nvSpPr>
+        <p:spPr>
+          <a:xfrm>
+            <a:off x="594360" y="4279392"/>
+            <a:ext cx="1417320" cy="1179576"/>
+          </a:xfrm>
+          <a:prstGeom prst="rect">
+            <a:avLst/>
+          </a:prstGeom>
+          <a:noFill/>
+          <a:ln/>
+        </p:spPr>
+        <p:txBody>
+          <a:bodyPr wrap="square" lIns="0" tIns="0" rIns="0" bIns="0" rtlCol="0" anchor="t"/>
+          <a:lstStyle/>
+          <a:p>
+            <a:pPr algn="ctr" indent="0" marL="0">
+              <a:lnSpc>
+                <a:spcPct val="115000"/>
+              </a:lnSpc>
+              <a:buNone/>
+            </a:pPr>
+            <a:r>
+              <a:rPr lang="en-US" sz="900" dirty="0">
+                <a:solidFill>
+                  <a:srgbClr val="5F6B7A"/>
+                </a:solidFill>
+                <a:latin typeface="Arial" pitchFamily="34" charset="0"/>
+                <a:ea typeface="Arial" pitchFamily="34" charset="-122"/>
+                <a:cs typeface="Arial" pitchFamily="34" charset="-120"/>
+              </a:rPr>
+              <a:t>Normal snapshot schedules; the orchestrator tracks the weather</a:t>
+            </a:r>
+            <a:endParaRPr lang="en-US" sz="900" dirty="0"/>
+          </a:p>
+        </p:txBody>
+      </p:sp>
+      <p:sp>
+        <p:nvSpPr>
+          <p:cNvPr id="24" name="Shape 17"/>
+          <p:cNvSpPr/>
+          <p:nvPr/>
+        </p:nvSpPr>
+        <p:spPr>
+          <a:xfrm>
+            <a:off x="2898648" y="3236976"/>
+            <a:ext cx="1600200" cy="2331720"/>
+          </a:xfrm>
+          <a:prstGeom prst="roundRect">
+            <a:avLst>
+              <a:gd name="adj" fmla="val 5143"/>
+            </a:avLst>
+          </a:prstGeom>
+          <a:solidFill>
+            <a:srgbClr val="FFFFFF"/>
+          </a:solidFill>
+          <a:ln w="31750">
+            <a:solidFill>
+              <a:srgbClr val="E8710A"/>
+            </a:solidFill>
+            <a:prstDash val="solid"/>
+          </a:ln>
+        </p:spPr>
+      </p:sp>
+      <p:sp>
+        <p:nvSpPr>
+          <p:cNvPr id="25" name="Shape 18"/>
+          <p:cNvSpPr/>
+          <p:nvPr/>
+        </p:nvSpPr>
+        <p:spPr>
+          <a:xfrm>
+            <a:off x="2898648" y="3236976"/>
+            <a:ext cx="457200" cy="457200"/>
+          </a:xfrm>
+          <a:prstGeom prst="roundRect">
+            <a:avLst>
+              <a:gd name="adj" fmla="val 14000"/>
+            </a:avLst>
+          </a:prstGeom>
+          <a:solidFill>
+            <a:srgbClr val="E8710A"/>
+          </a:solidFill>
+          <a:ln w="12700">
+            <a:solidFill>
+              <a:srgbClr val="E8710A"/>
+            </a:solidFill>
+            <a:prstDash val="solid"/>
+          </a:ln>
+        </p:spPr>
+      </p:sp>
+      <p:pic>
+        <p:nvPicPr>
+          <p:cNvPr id="26" name="Image 5" descr="2 · Always-on capture">    </p:cNvPr>
+          <p:cNvPicPr>
+            <a:picLocks noChangeAspect="1"/>
+          </p:cNvPicPr>
+          <p:nvPr/>
+        </p:nvPicPr>
+        <p:blipFill>
+          <a:blip r:embed="rId6"/>
+          <a:stretch>
+            <a:fillRect/>
+          </a:stretch>
+        </p:blipFill>
+        <p:spPr>
+          <a:xfrm>
+            <a:off x="2980944" y="3319272"/>
+            <a:ext cx="292608" cy="292608"/>
+          </a:xfrm>
+          <a:prstGeom prst="rect">
+            <a:avLst/>
+          </a:prstGeom>
+        </p:spPr>
+      </p:pic>
+      <p:sp>
+        <p:nvSpPr>
+          <p:cNvPr id="27" name="Text 19"/>
+          <p:cNvSpPr/>
+          <p:nvPr/>
+        </p:nvSpPr>
+        <p:spPr>
+          <a:xfrm>
+            <a:off x="2953512" y="3785616"/>
+            <a:ext cx="1490472" cy="512064"/>
+          </a:xfrm>
+          <a:prstGeom prst="rect">
+            <a:avLst/>
+          </a:prstGeom>
+          <a:noFill/>
+          <a:ln/>
+        </p:spPr>
+        <p:txBody>
+          <a:bodyPr wrap="square" lIns="0" tIns="0" rIns="0" bIns="0" rtlCol="0" anchor="t"/>
+          <a:lstStyle/>
+          <a:p>
+            <a:pPr algn="ctr" indent="0" marL="0">
+              <a:buNone/>
+            </a:pPr>
+            <a:r>
+              <a:rPr lang="en-US" sz="1200" b="1" dirty="0">
+                <a:solidFill>
+                  <a:srgbClr val="232F3E"/>
+                </a:solidFill>
+                <a:latin typeface="Arial" pitchFamily="34" charset="0"/>
+                <a:ea typeface="Arial" pitchFamily="34" charset="-122"/>
+                <a:cs typeface="Arial" pitchFamily="34" charset="-120"/>
+              </a:rPr>
+              <a:t>2 · Always-on capture</a:t>
+            </a:r>
+            <a:endParaRPr lang="en-US" sz="1200" dirty="0"/>
+          </a:p>
+        </p:txBody>
+      </p:sp>
+      <p:sp>
+        <p:nvSpPr>
+          <p:cNvPr id="28" name="Text 20"/>
+          <p:cNvSpPr/>
+          <p:nvPr/>
+        </p:nvSpPr>
+        <p:spPr>
+          <a:xfrm>
+            <a:off x="2990088" y="4279392"/>
+            <a:ext cx="1417320" cy="1179576"/>
+          </a:xfrm>
+          <a:prstGeom prst="rect">
+            <a:avLst/>
+          </a:prstGeom>
+          <a:noFill/>
+          <a:ln/>
+        </p:spPr>
+        <p:txBody>
+          <a:bodyPr wrap="square" lIns="0" tIns="0" rIns="0" bIns="0" rtlCol="0" anchor="t"/>
+          <a:lstStyle/>
+          <a:p>
+            <a:pPr algn="ctr" indent="0" marL="0">
+              <a:lnSpc>
+                <a:spcPct val="115000"/>
+              </a:lnSpc>
+              <a:buNone/>
+            </a:pPr>
+            <a:r>
+              <a:rPr lang="en-US" sz="900" dirty="0">
+                <a:solidFill>
+                  <a:srgbClr val="5F6B7A"/>
+                </a:solidFill>
+                <a:latin typeface="Arial" pitchFamily="34" charset="0"/>
+                <a:ea typeface="Arial" pitchFamily="34" charset="-122"/>
+                <a:cs typeface="Arial" pitchFamily="34" charset="-120"/>
+              </a:rPr>
+              <a:t>Cameras, microphones, and the SDR (software-defined radio) sensor record continuously</a:t>
+            </a:r>
+            <a:endParaRPr lang="en-US" sz="900" dirty="0"/>
+          </a:p>
+        </p:txBody>
+      </p:sp>
+      <p:sp>
+        <p:nvSpPr>
+          <p:cNvPr id="29" name="Shape 21"/>
+          <p:cNvSpPr/>
+          <p:nvPr/>
+        </p:nvSpPr>
+        <p:spPr>
+          <a:xfrm>
+            <a:off x="5294376" y="3236976"/>
+            <a:ext cx="1600200" cy="2331720"/>
+          </a:xfrm>
+          <a:prstGeom prst="roundRect">
+            <a:avLst>
+              <a:gd name="adj" fmla="val 5143"/>
+            </a:avLst>
+          </a:prstGeom>
+          <a:solidFill>
+            <a:srgbClr val="FFFFFF"/>
+          </a:solidFill>
+          <a:ln w="31750">
+            <a:solidFill>
+              <a:srgbClr val="E8710A"/>
+            </a:solidFill>
+            <a:prstDash val="solid"/>
+          </a:ln>
+        </p:spPr>
+      </p:sp>
+      <p:sp>
+        <p:nvSpPr>
+          <p:cNvPr id="30" name="Shape 22"/>
+          <p:cNvSpPr/>
+          <p:nvPr/>
+        </p:nvSpPr>
+        <p:spPr>
+          <a:xfrm>
+            <a:off x="5294376" y="3236976"/>
+            <a:ext cx="457200" cy="457200"/>
+          </a:xfrm>
+          <a:prstGeom prst="roundRect">
+            <a:avLst>
+              <a:gd name="adj" fmla="val 14000"/>
+            </a:avLst>
+          </a:prstGeom>
+          <a:solidFill>
+            <a:srgbClr val="E8710A"/>
+          </a:solidFill>
+          <a:ln w="12700">
+            <a:solidFill>
+              <a:srgbClr val="E8710A"/>
+            </a:solidFill>
+            <a:prstDash val="solid"/>
+          </a:ln>
+        </p:spPr>
+      </p:sp>
+      <p:pic>
+        <p:nvPicPr>
+          <p:cNvPr id="31" name="Image 6" descr="3 · Strike located">    </p:cNvPr>
+          <p:cNvPicPr>
+            <a:picLocks noChangeAspect="1"/>
+          </p:cNvPicPr>
+          <p:nvPr/>
+        </p:nvPicPr>
+        <p:blipFill>
+          <a:blip r:embed="rId7"/>
+          <a:stretch>
+            <a:fillRect/>
+          </a:stretch>
+        </p:blipFill>
+        <p:spPr>
+          <a:xfrm>
+            <a:off x="5376672" y="3319272"/>
+            <a:ext cx="292608" cy="292608"/>
+          </a:xfrm>
+          <a:prstGeom prst="rect">
+            <a:avLst/>
+          </a:prstGeom>
+        </p:spPr>
+      </p:pic>
+      <p:sp>
+        <p:nvSpPr>
+          <p:cNvPr id="32" name="Text 23"/>
+          <p:cNvSpPr/>
+          <p:nvPr/>
+        </p:nvSpPr>
+        <p:spPr>
+          <a:xfrm>
+            <a:off x="5349240" y="3785616"/>
+            <a:ext cx="1490472" cy="512064"/>
+          </a:xfrm>
+          <a:prstGeom prst="rect">
+            <a:avLst/>
+          </a:prstGeom>
+          <a:noFill/>
+          <a:ln/>
+        </p:spPr>
+        <p:txBody>
+          <a:bodyPr wrap="square" lIns="0" tIns="0" rIns="0" bIns="0" rtlCol="0" anchor="t"/>
+          <a:lstStyle/>
+          <a:p>
+            <a:pPr algn="ctr" indent="0" marL="0">
+              <a:buNone/>
+            </a:pPr>
+            <a:r>
+              <a:rPr lang="en-US" sz="1200" b="1" dirty="0">
+                <a:solidFill>
+                  <a:srgbClr val="232F3E"/>
+                </a:solidFill>
+                <a:latin typeface="Arial" pitchFamily="34" charset="0"/>
+                <a:ea typeface="Arial" pitchFamily="34" charset="-122"/>
+                <a:cs typeface="Arial" pitchFamily="34" charset="-120"/>
+              </a:rPr>
+              <a:t>3 · Strike located</a:t>
+            </a:r>
+            <a:endParaRPr lang="en-US" sz="1200" dirty="0"/>
+          </a:p>
+        </p:txBody>
+      </p:sp>
+      <p:sp>
+        <p:nvSpPr>
+          <p:cNvPr id="33" name="Text 24"/>
+          <p:cNvSpPr/>
+          <p:nvPr/>
+        </p:nvSpPr>
+        <p:spPr>
+          <a:xfrm>
+            <a:off x="5385816" y="4279392"/>
+            <a:ext cx="1417320" cy="1179576"/>
+          </a:xfrm>
+          <a:prstGeom prst="rect">
+            <a:avLst/>
+          </a:prstGeom>
+          <a:noFill/>
+          <a:ln/>
+        </p:spPr>
+        <p:txBody>
+          <a:bodyPr wrap="square" lIns="0" tIns="0" rIns="0" bIns="0" rtlCol="0" anchor="t"/>
+          <a:lstStyle/>
+          <a:p>
+            <a:pPr algn="ctr" indent="0" marL="0">
+              <a:lnSpc>
+                <a:spcPct val="115000"/>
+              </a:lnSpc>
+              <a:buNone/>
+            </a:pPr>
+            <a:r>
+              <a:rPr lang="en-US" sz="900" dirty="0">
+                <a:solidFill>
+                  <a:srgbClr val="5F6B7A"/>
+                </a:solidFill>
+                <a:latin typeface="Arial" pitchFamily="34" charset="0"/>
+                <a:ea typeface="Arial" pitchFamily="34" charset="-122"/>
+                <a:cs typeface="Arial" pitchFamily="34" charset="-120"/>
+              </a:rPr>
+              <a:t>The radio pulse is the shared clock; thunder delays cross at the strike</a:t>
+            </a:r>
+            <a:endParaRPr lang="en-US" sz="900" dirty="0"/>
+          </a:p>
+        </p:txBody>
+      </p:sp>
+      <p:sp>
+        <p:nvSpPr>
+          <p:cNvPr id="34" name="Shape 25"/>
+          <p:cNvSpPr/>
+          <p:nvPr/>
+        </p:nvSpPr>
+        <p:spPr>
+          <a:xfrm>
+            <a:off x="7690104" y="3236976"/>
+            <a:ext cx="1600200" cy="2331720"/>
+          </a:xfrm>
+          <a:prstGeom prst="roundRect">
+            <a:avLst>
+              <a:gd name="adj" fmla="val 5143"/>
+            </a:avLst>
+          </a:prstGeom>
+          <a:solidFill>
+            <a:srgbClr val="FFFFFF"/>
+          </a:solidFill>
+          <a:ln w="31750">
+            <a:solidFill>
+              <a:srgbClr val="E8710A"/>
+            </a:solidFill>
+            <a:prstDash val="solid"/>
+          </a:ln>
+        </p:spPr>
+      </p:sp>
+      <p:sp>
+        <p:nvSpPr>
+          <p:cNvPr id="35" name="Shape 26"/>
+          <p:cNvSpPr/>
+          <p:nvPr/>
+        </p:nvSpPr>
+        <p:spPr>
+          <a:xfrm>
+            <a:off x="7690104" y="3236976"/>
+            <a:ext cx="457200" cy="457200"/>
+          </a:xfrm>
+          <a:prstGeom prst="roundRect">
+            <a:avLst>
+              <a:gd name="adj" fmla="val 14000"/>
+            </a:avLst>
+          </a:prstGeom>
+          <a:solidFill>
+            <a:srgbClr val="E8710A"/>
+          </a:solidFill>
+          <a:ln w="12700">
+            <a:solidFill>
+              <a:srgbClr val="E8710A"/>
+            </a:solidFill>
+            <a:prstDash val="solid"/>
+          </a:ln>
+        </p:spPr>
+      </p:sp>
+      <p:pic>
+        <p:nvPicPr>
+          <p:cNvPr id="36" name="Image 7" descr="4 · Smoke watch">    </p:cNvPr>
+          <p:cNvPicPr>
+            <a:picLocks noChangeAspect="1"/>
+          </p:cNvPicPr>
+          <p:nvPr/>
+        </p:nvPicPr>
+        <p:blipFill>
+          <a:blip r:embed="rId8"/>
+          <a:stretch>
+            <a:fillRect/>
+          </a:stretch>
+        </p:blipFill>
+        <p:spPr>
+          <a:xfrm>
+            <a:off x="7772400" y="3319272"/>
+            <a:ext cx="292608" cy="292608"/>
+          </a:xfrm>
+          <a:prstGeom prst="rect">
+            <a:avLst/>
+          </a:prstGeom>
+        </p:spPr>
+      </p:pic>
+      <p:sp>
+        <p:nvSpPr>
+          <p:cNvPr id="37" name="Text 27"/>
+          <p:cNvSpPr/>
+          <p:nvPr/>
+        </p:nvSpPr>
+        <p:spPr>
+          <a:xfrm>
+            <a:off x="7744968" y="3785616"/>
+            <a:ext cx="1490472" cy="512064"/>
+          </a:xfrm>
+          <a:prstGeom prst="rect">
+            <a:avLst/>
+          </a:prstGeom>
+          <a:noFill/>
+          <a:ln/>
+        </p:spPr>
+        <p:txBody>
+          <a:bodyPr wrap="square" lIns="0" tIns="0" rIns="0" bIns="0" rtlCol="0" anchor="t"/>
+          <a:lstStyle/>
+          <a:p>
+            <a:pPr algn="ctr" indent="0" marL="0">
+              <a:buNone/>
+            </a:pPr>
+            <a:r>
+              <a:rPr lang="en-US" sz="1200" b="1" dirty="0">
+                <a:solidFill>
+                  <a:srgbClr val="232F3E"/>
+                </a:solidFill>
+                <a:latin typeface="Arial" pitchFamily="34" charset="0"/>
+                <a:ea typeface="Arial" pitchFamily="34" charset="-122"/>
+                <a:cs typeface="Arial" pitchFamily="34" charset="-120"/>
+              </a:rPr>
+              <a:t>4 · Smoke watch</a:t>
+            </a:r>
+            <a:endParaRPr lang="en-US" sz="1200" dirty="0"/>
+          </a:p>
+        </p:txBody>
+      </p:sp>
+      <p:sp>
+        <p:nvSpPr>
+          <p:cNvPr id="38" name="Text 28"/>
+          <p:cNvSpPr/>
+          <p:nvPr/>
+        </p:nvSpPr>
+        <p:spPr>
+          <a:xfrm>
+            <a:off x="7781544" y="4279392"/>
+            <a:ext cx="1417320" cy="1179576"/>
+          </a:xfrm>
+          <a:prstGeom prst="rect">
+            <a:avLst/>
+          </a:prstGeom>
+          <a:noFill/>
+          <a:ln/>
+        </p:spPr>
+        <p:txBody>
+          <a:bodyPr wrap="square" lIns="0" tIns="0" rIns="0" bIns="0" rtlCol="0" anchor="t"/>
+          <a:lstStyle/>
+          <a:p>
+            <a:pPr algn="ctr" indent="0" marL="0">
+              <a:lnSpc>
+                <a:spcPct val="115000"/>
+              </a:lnSpc>
+              <a:buNone/>
+            </a:pPr>
+            <a:r>
+              <a:rPr lang="en-US" sz="900" dirty="0">
+                <a:solidFill>
+                  <a:srgbClr val="5F6B7A"/>
+                </a:solidFill>
+                <a:latin typeface="Arial" pitchFamily="34" charset="0"/>
+                <a:ea typeface="Arial" pitchFamily="34" charset="-122"/>
+                <a:cs typeface="Arial" pitchFamily="34" charset="-120"/>
+              </a:rPr>
+              <a:t>A horizon-view PTZ (pan-tilt-zoom) camera aims at the sector; the smoke agent revisits for days</a:t>
+            </a:r>
+            <a:endParaRPr lang="en-US" sz="900" dirty="0"/>
+          </a:p>
+        </p:txBody>
+      </p:sp>
+      <p:sp>
+        <p:nvSpPr>
+          <p:cNvPr id="39" name="Shape 29"/>
+          <p:cNvSpPr/>
+          <p:nvPr/>
+        </p:nvSpPr>
+        <p:spPr>
+          <a:xfrm>
+            <a:off x="10085832" y="3236976"/>
+            <a:ext cx="1600200" cy="2331720"/>
+          </a:xfrm>
+          <a:prstGeom prst="roundRect">
+            <a:avLst>
+              <a:gd name="adj" fmla="val 5143"/>
+            </a:avLst>
+          </a:prstGeom>
+          <a:solidFill>
+            <a:srgbClr val="FFFFFF"/>
+          </a:solidFill>
+          <a:ln w="31750">
+            <a:solidFill>
+              <a:srgbClr val="1976D2"/>
+            </a:solidFill>
+            <a:prstDash val="solid"/>
+          </a:ln>
+        </p:spPr>
+      </p:sp>
+      <p:sp>
+        <p:nvSpPr>
+          <p:cNvPr id="40" name="Shape 30"/>
+          <p:cNvSpPr/>
+          <p:nvPr/>
+        </p:nvSpPr>
+        <p:spPr>
+          <a:xfrm>
+            <a:off x="10085832" y="3236976"/>
+            <a:ext cx="457200" cy="457200"/>
+          </a:xfrm>
+          <a:prstGeom prst="roundRect">
+            <a:avLst>
+              <a:gd name="adj" fmla="val 14000"/>
+            </a:avLst>
+          </a:prstGeom>
+          <a:solidFill>
+            <a:srgbClr val="1976D2"/>
+          </a:solidFill>
+          <a:ln w="12700">
+            <a:solidFill>
+              <a:srgbClr val="1976D2"/>
+            </a:solidFill>
+            <a:prstDash val="solid"/>
+          </a:ln>
+        </p:spPr>
+      </p:sp>
+      <p:pic>
+        <p:nvPicPr>
+          <p:cNvPr id="41" name="Image 8" descr="5 · Notify responders">    </p:cNvPr>
+          <p:cNvPicPr>
+            <a:picLocks noChangeAspect="1"/>
+          </p:cNvPicPr>
+          <p:nvPr/>
+        </p:nvPicPr>
+        <p:blipFill>
+          <a:blip r:embed="rId9"/>
+          <a:stretch>
+            <a:fillRect/>
+          </a:stretch>
+        </p:blipFill>
+        <p:spPr>
+          <a:xfrm>
+            <a:off x="10168128" y="3319272"/>
+            <a:ext cx="292608" cy="292608"/>
+          </a:xfrm>
+          <a:prstGeom prst="rect">
+            <a:avLst/>
+          </a:prstGeom>
+        </p:spPr>
+      </p:pic>
+      <p:sp>
+        <p:nvSpPr>
+          <p:cNvPr id="42" name="Text 31"/>
+          <p:cNvSpPr/>
+          <p:nvPr/>
+        </p:nvSpPr>
+        <p:spPr>
+          <a:xfrm>
+            <a:off x="10140696" y="3785616"/>
+            <a:ext cx="1490472" cy="512064"/>
+          </a:xfrm>
+          <a:prstGeom prst="rect">
+            <a:avLst/>
+          </a:prstGeom>
+          <a:noFill/>
+          <a:ln/>
+        </p:spPr>
+        <p:txBody>
+          <a:bodyPr wrap="square" lIns="0" tIns="0" rIns="0" bIns="0" rtlCol="0" anchor="t"/>
+          <a:lstStyle/>
+          <a:p>
+            <a:pPr algn="ctr" indent="0" marL="0">
+              <a:buNone/>
+            </a:pPr>
+            <a:r>
+              <a:rPr lang="en-US" sz="1200" b="1" dirty="0">
+                <a:solidFill>
+                  <a:srgbClr val="232F3E"/>
+                </a:solidFill>
+                <a:latin typeface="Arial" pitchFamily="34" charset="0"/>
+                <a:ea typeface="Arial" pitchFamily="34" charset="-122"/>
+                <a:cs typeface="Arial" pitchFamily="34" charset="-120"/>
+              </a:rPr>
+              <a:t>5 · Notify responders</a:t>
+            </a:r>
+            <a:endParaRPr lang="en-US" sz="1200" dirty="0"/>
+          </a:p>
+        </p:txBody>
+      </p:sp>
+      <p:sp>
+        <p:nvSpPr>
+          <p:cNvPr id="43" name="Text 32"/>
+          <p:cNvSpPr/>
+          <p:nvPr/>
+        </p:nvSpPr>
+        <p:spPr>
+          <a:xfrm>
+            <a:off x="10177272" y="4279392"/>
+            <a:ext cx="1417320" cy="1179576"/>
+          </a:xfrm>
+          <a:prstGeom prst="rect">
+            <a:avLst/>
+          </a:prstGeom>
+          <a:noFill/>
+          <a:ln/>
+        </p:spPr>
+        <p:txBody>
+          <a:bodyPr wrap="square" lIns="0" tIns="0" rIns="0" bIns="0" rtlCol="0" anchor="t"/>
+          <a:lstStyle/>
+          <a:p>
+            <a:pPr algn="ctr" indent="0" marL="0">
+              <a:lnSpc>
+                <a:spcPct val="115000"/>
+              </a:lnSpc>
+              <a:buNone/>
+            </a:pPr>
+            <a:r>
+              <a:rPr lang="en-US" sz="900" dirty="0">
+                <a:solidFill>
+                  <a:srgbClr val="5F6B7A"/>
+                </a:solidFill>
+                <a:latin typeface="Arial" pitchFamily="34" charset="0"/>
+                <a:ea typeface="Arial" pitchFamily="34" charset="-122"/>
+                <a:cs typeface="Arial" pitchFamily="34" charset="-120"/>
+              </a:rPr>
+              <a:t>Before-and-after pictures plus soil moisture, rainfall, and wind before the strike</a:t>
+            </a:r>
+            <a:endParaRPr lang="en-US" sz="900" dirty="0"/>
+          </a:p>
+        </p:txBody>
+      </p:sp>
+      <p:sp>
+        <p:nvSpPr>
+          <p:cNvPr id="44" name="Shape 33"/>
+          <p:cNvSpPr/>
+          <p:nvPr/>
+        </p:nvSpPr>
+        <p:spPr>
+          <a:xfrm>
+            <a:off x="2176272" y="3465576"/>
+            <a:ext cx="649224" cy="0"/>
+          </a:xfrm>
+          <a:prstGeom prst="line">
+            <a:avLst/>
+          </a:prstGeom>
+          <a:noFill/>
+          <a:ln w="22225">
+            <a:solidFill>
+              <a:srgbClr val="5F6B7A"/>
+            </a:solidFill>
+            <a:prstDash val="solid"/>
+            <a:tailEnd type="triangle"/>
+          </a:ln>
+        </p:spPr>
+      </p:sp>
+      <p:sp>
+        <p:nvSpPr>
+          <p:cNvPr id="45" name="Text 34"/>
+          <p:cNvSpPr/>
+          <p:nvPr/>
+        </p:nvSpPr>
+        <p:spPr>
+          <a:xfrm>
+            <a:off x="2112264" y="3621024"/>
+            <a:ext cx="777240" cy="1463040"/>
+          </a:xfrm>
+          <a:prstGeom prst="rect">
+            <a:avLst/>
+          </a:prstGeom>
+          <a:noFill/>
+          <a:ln/>
+        </p:spPr>
+        <p:txBody>
+          <a:bodyPr wrap="square" lIns="0" tIns="0" rIns="0" bIns="0" rtlCol="0" anchor="t"/>
+          <a:lstStyle/>
+          <a:p>
+            <a:pPr algn="ctr" indent="0" marL="0">
+              <a:lnSpc>
+                <a:spcPct val="115000"/>
+              </a:lnSpc>
+              <a:buNone/>
+            </a:pPr>
+            <a:r>
+              <a:rPr lang="en-US" sz="800" i="1" dirty="0">
+                <a:solidFill>
+                  <a:srgbClr val="5F6B7A"/>
+                </a:solidFill>
+                <a:latin typeface="Arial" pitchFamily="34" charset="0"/>
+                <a:ea typeface="Arial" pitchFamily="34" charset="-122"/>
+                <a:cs typeface="Arial" pitchFamily="34" charset="-120"/>
+              </a:rPr>
+              <a:t>lightning weather forecast near nodes</a:t>
+            </a:r>
+            <a:endParaRPr lang="en-US" sz="800" dirty="0"/>
+          </a:p>
+        </p:txBody>
+      </p:sp>
+      <p:sp>
+        <p:nvSpPr>
+          <p:cNvPr id="46" name="Shape 35"/>
+          <p:cNvSpPr/>
+          <p:nvPr/>
+        </p:nvSpPr>
+        <p:spPr>
+          <a:xfrm>
+            <a:off x="4572000" y="3465576"/>
+            <a:ext cx="649224" cy="0"/>
+          </a:xfrm>
+          <a:prstGeom prst="line">
+            <a:avLst/>
+          </a:prstGeom>
+          <a:noFill/>
+          <a:ln w="22225">
+            <a:solidFill>
+              <a:srgbClr val="5F6B7A"/>
+            </a:solidFill>
+            <a:prstDash val="solid"/>
+            <a:tailEnd type="triangle"/>
+          </a:ln>
+        </p:spPr>
+      </p:sp>
+      <p:sp>
+        <p:nvSpPr>
+          <p:cNvPr id="47" name="Text 36"/>
+          <p:cNvSpPr/>
+          <p:nvPr/>
+        </p:nvSpPr>
+        <p:spPr>
+          <a:xfrm>
+            <a:off x="4507992" y="3621024"/>
+            <a:ext cx="777240" cy="1463040"/>
+          </a:xfrm>
+          <a:prstGeom prst="rect">
+            <a:avLst/>
+          </a:prstGeom>
+          <a:noFill/>
+          <a:ln/>
+        </p:spPr>
+        <p:txBody>
+          <a:bodyPr wrap="square" lIns="0" tIns="0" rIns="0" bIns="0" rtlCol="0" anchor="t"/>
+          <a:lstStyle/>
+          <a:p>
+            <a:pPr algn="ctr" indent="0" marL="0">
+              <a:lnSpc>
+                <a:spcPct val="115000"/>
+              </a:lnSpc>
+              <a:buNone/>
+            </a:pPr>
+            <a:r>
+              <a:rPr lang="en-US" sz="800" i="1" dirty="0">
+                <a:solidFill>
+                  <a:srgbClr val="5F6B7A"/>
+                </a:solidFill>
+                <a:latin typeface="Arial" pitchFamily="34" charset="0"/>
+                <a:ea typeface="Arial" pitchFamily="34" charset="-122"/>
+                <a:cs typeface="Arial" pitchFamily="34" charset="-120"/>
+              </a:rPr>
+              <a:t>SDR strike + enough nodes in range</a:t>
+            </a:r>
+            <a:endParaRPr lang="en-US" sz="800" dirty="0"/>
+          </a:p>
+        </p:txBody>
+      </p:sp>
+      <p:sp>
+        <p:nvSpPr>
+          <p:cNvPr id="48" name="Shape 37"/>
+          <p:cNvSpPr/>
+          <p:nvPr/>
+        </p:nvSpPr>
+        <p:spPr>
+          <a:xfrm>
+            <a:off x="6967728" y="3465576"/>
+            <a:ext cx="649224" cy="0"/>
+          </a:xfrm>
+          <a:prstGeom prst="line">
+            <a:avLst/>
+          </a:prstGeom>
+          <a:noFill/>
+          <a:ln w="22225">
+            <a:solidFill>
+              <a:srgbClr val="5F6B7A"/>
+            </a:solidFill>
+            <a:prstDash val="solid"/>
+            <a:tailEnd type="triangle"/>
+          </a:ln>
+        </p:spPr>
+      </p:sp>
+      <p:sp>
+        <p:nvSpPr>
+          <p:cNvPr id="49" name="Text 38"/>
+          <p:cNvSpPr/>
+          <p:nvPr/>
+        </p:nvSpPr>
+        <p:spPr>
+          <a:xfrm>
+            <a:off x="6903720" y="3621024"/>
+            <a:ext cx="777240" cy="1463040"/>
+          </a:xfrm>
+          <a:prstGeom prst="rect">
+            <a:avLst/>
+          </a:prstGeom>
+          <a:noFill/>
+          <a:ln/>
+        </p:spPr>
+        <p:txBody>
+          <a:bodyPr wrap="square" lIns="0" tIns="0" rIns="0" bIns="0" rtlCol="0" anchor="t"/>
+          <a:lstStyle/>
+          <a:p>
+            <a:pPr algn="ctr" indent="0" marL="0">
+              <a:lnSpc>
+                <a:spcPct val="115000"/>
+              </a:lnSpc>
+              <a:buNone/>
+            </a:pPr>
+            <a:r>
+              <a:rPr lang="en-US" sz="800" i="1" dirty="0">
+                <a:solidFill>
+                  <a:srgbClr val="5F6B7A"/>
+                </a:solidFill>
+                <a:latin typeface="Arial" pitchFamily="34" charset="0"/>
+                <a:ea typeface="Arial" pitchFamily="34" charset="-122"/>
+                <a:cs typeface="Arial" pitchFamily="34" charset="-120"/>
+              </a:rPr>
+              <a:t>location fixed → best camera chosen</a:t>
+            </a:r>
+            <a:endParaRPr lang="en-US" sz="800" dirty="0"/>
+          </a:p>
+        </p:txBody>
+      </p:sp>
+      <p:sp>
+        <p:nvSpPr>
+          <p:cNvPr id="50" name="Shape 39"/>
+          <p:cNvSpPr/>
+          <p:nvPr/>
+        </p:nvSpPr>
+        <p:spPr>
+          <a:xfrm>
+            <a:off x="9363456" y="3465576"/>
+            <a:ext cx="649224" cy="0"/>
+          </a:xfrm>
+          <a:prstGeom prst="line">
+            <a:avLst/>
+          </a:prstGeom>
+          <a:noFill/>
+          <a:ln w="22225">
+            <a:solidFill>
+              <a:srgbClr val="5F6B7A"/>
+            </a:solidFill>
+            <a:prstDash val="solid"/>
+            <a:tailEnd type="triangle"/>
+          </a:ln>
+        </p:spPr>
+      </p:sp>
+      <p:sp>
+        <p:nvSpPr>
+          <p:cNvPr id="51" name="Text 40"/>
+          <p:cNvSpPr/>
+          <p:nvPr/>
+        </p:nvSpPr>
+        <p:spPr>
+          <a:xfrm>
+            <a:off x="9299448" y="3621024"/>
+            <a:ext cx="777240" cy="1463040"/>
+          </a:xfrm>
+          <a:prstGeom prst="rect">
+            <a:avLst/>
+          </a:prstGeom>
+          <a:noFill/>
+          <a:ln/>
+        </p:spPr>
+        <p:txBody>
+          <a:bodyPr wrap="square" lIns="0" tIns="0" rIns="0" bIns="0" rtlCol="0" anchor="t"/>
+          <a:lstStyle/>
+          <a:p>
+            <a:pPr algn="ctr" indent="0" marL="0">
+              <a:lnSpc>
+                <a:spcPct val="115000"/>
+              </a:lnSpc>
+              <a:buNone/>
+            </a:pPr>
+            <a:r>
+              <a:rPr lang="en-US" sz="800" i="1" dirty="0">
+                <a:solidFill>
+                  <a:srgbClr val="5F6B7A"/>
+                </a:solidFill>
+                <a:latin typeface="Arial" pitchFamily="34" charset="0"/>
+                <a:ea typeface="Arial" pitchFamily="34" charset="-122"/>
+                <a:cs typeface="Arial" pitchFamily="34" charset="-120"/>
+              </a:rPr>
+              <a:t>smoke confirmed (else back to 1)</a:t>
+            </a:r>
+            <a:endParaRPr lang="en-US" sz="800" dirty="0"/>
+          </a:p>
+        </p:txBody>
+      </p:sp>
+      <p:sp>
+        <p:nvSpPr>
+          <p:cNvPr id="52" name="Text 41"/>
+          <p:cNvSpPr/>
+          <p:nvPr/>
+        </p:nvSpPr>
+        <p:spPr>
+          <a:xfrm>
+            <a:off x="502920" y="5806440"/>
+            <a:ext cx="11183112" cy="502920"/>
+          </a:xfrm>
+          <a:prstGeom prst="rect">
+            <a:avLst/>
+          </a:prstGeom>
+          <a:noFill/>
+          <a:ln/>
+        </p:spPr>
+        <p:txBody>
+          <a:bodyPr wrap="square" lIns="0" tIns="0" rIns="0" bIns="0" rtlCol="0" anchor="ctr"/>
+          <a:lstStyle/>
+          <a:p>
+            <a:pPr indent="0" marL="0">
+              <a:lnSpc>
+                <a:spcPct val="120000"/>
+              </a:lnSpc>
+              <a:buNone/>
+            </a:pPr>
+            <a:r>
+              <a:rPr lang="en-US" sz="900" i="1" dirty="0">
+                <a:solidFill>
+                  <a:srgbClr val="5F6B7A"/>
+                </a:solidFill>
+                <a:latin typeface="Arial" pitchFamily="34" charset="0"/>
+                <a:ea typeface="Arial" pitchFamily="34" charset="-122"/>
+                <a:cs typeface="Arial" pitchFamily="34" charset="-120"/>
+              </a:rPr>
+              <a:t>SDR lightning sensing is planned hardware — the camera flash serves as the start-of-clock today. Notifications are human-reviewed before anything reaches responders. Soil moisture comes from NASA satellite and model data; an on-node probe is the planned upgrade.</a:t>
+            </a:r>
+            <a:endParaRPr lang="en-US" sz="900" dirty="0"/>
+          </a:p>
+        </p:txBody>
+      </p:sp>
+    </p:spTree>
+  </p:cSld>
+  <p:clrMapOvr>
+    <a:masterClrMapping/>
+  </p:clrMapOvr>
+</p:sld>
+</file>
+
+<file path=ppt/slides/slide13.xml><?xml version="1.0" encoding="utf-8"?>
+<p:sld xmlns:a="http://schemas.openxmlformats.org/drawingml/2006/main" xmlns:r="http://schemas.openxmlformats.org/officeDocument/2006/relationships" xmlns:p="http://schemas.openxmlformats.org/presentationml/2006/main">
+  <p:cSld name="Slide 13">
     <p:spTree>
       <p:nvGrpSpPr>
         <p:cNvPr id="1" name=""/>

</xml_diff>